<commit_message>
Make the AI Gameplan short and scannable, refresh the slides
Co-Authored-By: Claude Opus 5.5 <noreply@anthropic.com>
Claude-Session: https://claude.ai/code/session_01PJvvaL6iM7EXiNVtK6cm1w
</commit_message>
<xml_diff>
--- a/downloads/AI-ideas-Myles-Parslow.pptx
+++ b/downloads/AI-ideas-Myles-Parslow.pptx
@@ -111,7 +111,7 @@
   <p:extLst>
     <p:ext uri="{521415D9-36F7-43E2-AB2F-B90AF26B5E84}">
       <p14:sectionLst xmlns:p14="http://schemas.microsoft.com/office/powerpoint/2010/main">
-        <p14:section name="AI for the firm" id="{f705e735-d5c5-3b20-367b-90ddbf63dbf2}">
+        <p14:section name="AI for the firm" id="{6b1d20b7-4271-c322-219c-3523f9396ca3}">
           <p14:sldIdLst>
             <p14:sldId id="256"/>
             <p14:sldId id="257"/>
@@ -1223,7 +1223,7 @@
                   <a:srgbClr val="2D4459"/>
                 </a:solidFill>
               </a:rPr>
-              <a:t>What I have already built</a:t>
+              <a:t>I have built fifteen working legal tools</a:t>
             </a:r>
             <a:endParaRPr lang="en-US" sz="2600" dirty="0"/>
           </a:p>
@@ -1261,7 +1261,7 @@
                   <a:schemeClr val="tx2"/>
                 </a:solidFill>
               </a:rPr>
-              <a:t>Fifteen working tools, built on my own time to learn what AI can do for this work. A lawyer makes every decision.</a:t>
+              <a:t>Built on my own time, for nearly every part of the firm. A lawyer makes every decision.</a:t>
             </a:r>
             <a:endParaRPr lang="en-US" sz="1300" dirty="0"/>
           </a:p>
@@ -1337,7 +1337,7 @@
         <p:spPr>
           <a:xfrm>
             <a:off x="548640" y="1682496"/>
-            <a:ext cx="1389888" cy="640080"/>
+            <a:ext cx="1389888" cy="603504"/>
           </a:xfrm>
           <a:prstGeom prst="rect">
             <a:avLst/>
@@ -1353,28 +1353,28 @@
               <a:buNone/>
             </a:pPr>
             <a:r>
-              <a:rPr lang="en-US" sz="1100" b="1" dirty="0">
+              <a:rPr lang="en-US" sz="1200" b="1" dirty="0">
                 <a:solidFill>
                   <a:schemeClr val="tx1"/>
                 </a:solidFill>
               </a:rPr>
               <a:t>Conflion</a:t>
             </a:r>
-            <a:endParaRPr lang="en-US" sz="1100" dirty="0"/>
-          </a:p>
-          <a:p>
-            <a:pPr indent="0" marL="0">
-              <a:buNone/>
-            </a:pPr>
-            <a:r>
-              <a:rPr lang="en-US" sz="850" dirty="0">
+            <a:endParaRPr lang="en-US" sz="1200" dirty="0"/>
+          </a:p>
+          <a:p>
+            <a:pPr indent="0" marL="0">
+              <a:buNone/>
+            </a:pPr>
+            <a:r>
+              <a:rPr lang="en-US" sz="1000" dirty="0">
                 <a:solidFill>
                   <a:schemeClr val="tx2"/>
                 </a:solidFill>
               </a:rPr>
-              <a:t>Conflicts check and intake that finds what a letter-for-letter search misses.</a:t>
-            </a:r>
-            <a:endParaRPr lang="en-US" sz="1100" dirty="0"/>
+              <a:t>Conflicts check and intake</a:t>
+            </a:r>
+            <a:endParaRPr lang="en-US" sz="1200" dirty="0"/>
           </a:p>
         </p:txBody>
       </p:sp>
@@ -1386,8 +1386,8 @@
         </p:nvSpPr>
         <p:spPr>
           <a:xfrm>
-            <a:off x="548640" y="2340864"/>
-            <a:ext cx="1389888" cy="640080"/>
+            <a:off x="548640" y="2322576"/>
+            <a:ext cx="1389888" cy="603504"/>
           </a:xfrm>
           <a:prstGeom prst="rect">
             <a:avLst/>
@@ -1403,28 +1403,28 @@
               <a:buNone/>
             </a:pPr>
             <a:r>
-              <a:rPr lang="en-US" sz="1100" b="1" dirty="0">
+              <a:rPr lang="en-US" sz="1200" b="1" dirty="0">
                 <a:solidFill>
                   <a:schemeClr val="tx1"/>
                 </a:solidFill>
               </a:rPr>
               <a:t>Party Finder</a:t>
             </a:r>
-            <a:endParaRPr lang="en-US" sz="1100" dirty="0"/>
-          </a:p>
-          <a:p>
-            <a:pPr indent="0" marL="0">
-              <a:buNone/>
-            </a:pPr>
-            <a:r>
-              <a:rPr lang="en-US" sz="850" dirty="0">
+            <a:endParaRPr lang="en-US" sz="1200" dirty="0"/>
+          </a:p>
+          <a:p>
+            <a:pPr indent="0" marL="0">
+              <a:buNone/>
+            </a:pPr>
+            <a:r>
+              <a:rPr lang="en-US" sz="1000" dirty="0">
                 <a:solidFill>
                   <a:schemeClr val="tx2"/>
                 </a:solidFill>
               </a:rPr>
-              <a:t>Reads the complaint or deal papers and builds the list of names to search.</a:t>
-            </a:r>
-            <a:endParaRPr lang="en-US" sz="1100" dirty="0"/>
+              <a:t>Names to search, from the documents</a:t>
+            </a:r>
+            <a:endParaRPr lang="en-US" sz="1200" dirty="0"/>
           </a:p>
         </p:txBody>
       </p:sp>
@@ -1436,8 +1436,8 @@
         </p:nvSpPr>
         <p:spPr>
           <a:xfrm>
-            <a:off x="548640" y="2999232"/>
-            <a:ext cx="1389888" cy="640080"/>
+            <a:off x="548640" y="2962656"/>
+            <a:ext cx="1389888" cy="603504"/>
           </a:xfrm>
           <a:prstGeom prst="rect">
             <a:avLst/>
@@ -1453,28 +1453,28 @@
               <a:buNone/>
             </a:pPr>
             <a:r>
-              <a:rPr lang="en-US" sz="1100" b="1" dirty="0">
+              <a:rPr lang="en-US" sz="1200" b="1" dirty="0">
                 <a:solidFill>
                   <a:schemeClr val="tx1"/>
                 </a:solidFill>
               </a:rPr>
               <a:t>LexAtlas</a:t>
             </a:r>
-            <a:endParaRPr lang="en-US" sz="1100" dirty="0"/>
-          </a:p>
-          <a:p>
-            <a:pPr indent="0" marL="0">
-              <a:buNone/>
-            </a:pPr>
-            <a:r>
-              <a:rPr lang="en-US" sz="850" dirty="0">
+            <a:endParaRPr lang="en-US" sz="1200" dirty="0"/>
+          </a:p>
+          <a:p>
+            <a:pPr indent="0" marL="0">
+              <a:buNone/>
+            </a:pPr>
+            <a:r>
+              <a:rPr lang="en-US" sz="1000" dirty="0">
                 <a:solidFill>
                   <a:schemeClr val="tx2"/>
                 </a:solidFill>
               </a:rPr>
-              <a:t>Relationship graph of companies, people and matters, walls in the data.</a:t>
-            </a:r>
-            <a:endParaRPr lang="en-US" sz="1100" dirty="0"/>
+              <a:t>Relationship graph with ethical walls</a:t>
+            </a:r>
+            <a:endParaRPr lang="en-US" sz="1200" dirty="0"/>
           </a:p>
         </p:txBody>
       </p:sp>
@@ -1486,8 +1486,8 @@
         </p:nvSpPr>
         <p:spPr>
           <a:xfrm>
-            <a:off x="548640" y="3657600"/>
-            <a:ext cx="1389888" cy="640080"/>
+            <a:off x="548640" y="3602736"/>
+            <a:ext cx="1389888" cy="603504"/>
           </a:xfrm>
           <a:prstGeom prst="rect">
             <a:avLst/>
@@ -1503,28 +1503,28 @@
               <a:buNone/>
             </a:pPr>
             <a:r>
-              <a:rPr lang="en-US" sz="1100" b="1" dirty="0">
+              <a:rPr lang="en-US" sz="1200" b="1" dirty="0">
                 <a:solidFill>
                   <a:schemeClr val="tx1"/>
                 </a:solidFill>
               </a:rPr>
               <a:t>VigilMark</a:t>
             </a:r>
-            <a:endParaRPr lang="en-US" sz="1100" dirty="0"/>
-          </a:p>
-          <a:p>
-            <a:pPr indent="0" marL="0">
-              <a:buNone/>
-            </a:pPr>
-            <a:r>
-              <a:rPr lang="en-US" sz="850" dirty="0">
+            <a:endParaRPr lang="en-US" sz="1200" dirty="0"/>
+          </a:p>
+          <a:p>
+            <a:pPr indent="0" marL="0">
+              <a:buNone/>
+            </a:pPr>
+            <a:r>
+              <a:rPr lang="en-US" sz="1000" dirty="0">
                 <a:solidFill>
                   <a:schemeClr val="tx2"/>
                 </a:solidFill>
               </a:rPr>
-              <a:t>Trademark watch that ranks new filings against clients' marks.</a:t>
-            </a:r>
-            <a:endParaRPr lang="en-US" sz="1100" dirty="0"/>
+              <a:t>Trademark watch and triage</a:t>
+            </a:r>
+            <a:endParaRPr lang="en-US" sz="1200" dirty="0"/>
           </a:p>
         </p:txBody>
       </p:sp>
@@ -1598,7 +1598,7 @@
         <p:spPr>
           <a:xfrm>
             <a:off x="2231136" y="1682496"/>
-            <a:ext cx="1389888" cy="640080"/>
+            <a:ext cx="1389888" cy="603504"/>
           </a:xfrm>
           <a:prstGeom prst="rect">
             <a:avLst/>
@@ -1614,28 +1614,28 @@
               <a:buNone/>
             </a:pPr>
             <a:r>
-              <a:rPr lang="en-US" sz="1100" b="1" dirty="0">
+              <a:rPr lang="en-US" sz="1200" b="1" dirty="0">
                 <a:solidFill>
                   <a:schemeClr val="tx1"/>
                 </a:solidFill>
               </a:rPr>
               <a:t>Win your case ASAP</a:t>
             </a:r>
-            <a:endParaRPr lang="en-US" sz="1100" dirty="0"/>
-          </a:p>
-          <a:p>
-            <a:pPr indent="0" marL="0">
-              <a:buNone/>
-            </a:pPr>
-            <a:r>
-              <a:rPr lang="en-US" sz="850" dirty="0">
+            <a:endParaRPr lang="en-US" sz="1200" dirty="0"/>
+          </a:p>
+          <a:p>
+            <a:pPr indent="0" marL="0">
+              <a:buNone/>
+            </a:pPr>
+            <a:r>
+              <a:rPr lang="en-US" sz="1000" dirty="0">
                 <a:solidFill>
                   <a:schemeClr val="tx2"/>
                 </a:solidFill>
               </a:rPr>
-              <a:t>First read of a complaint: every theory that could end the case early.</a:t>
-            </a:r>
-            <a:endParaRPr lang="en-US" sz="1100" dirty="0"/>
+              <a:t>First read of a complaint</a:t>
+            </a:r>
+            <a:endParaRPr lang="en-US" sz="1200" dirty="0"/>
           </a:p>
         </p:txBody>
       </p:sp>
@@ -1647,8 +1647,8 @@
         </p:nvSpPr>
         <p:spPr>
           <a:xfrm>
-            <a:off x="2231136" y="2340864"/>
-            <a:ext cx="1389888" cy="640080"/>
+            <a:off x="2231136" y="2322576"/>
+            <a:ext cx="1389888" cy="603504"/>
           </a:xfrm>
           <a:prstGeom prst="rect">
             <a:avLst/>
@@ -1664,28 +1664,28 @@
               <a:buNone/>
             </a:pPr>
             <a:r>
-              <a:rPr lang="en-US" sz="1100" b="1" dirty="0">
+              <a:rPr lang="en-US" sz="1200" b="1" dirty="0">
                 <a:solidFill>
                   <a:schemeClr val="tx1"/>
                 </a:solidFill>
               </a:rPr>
               <a:t>Testimony Check</a:t>
             </a:r>
-            <a:endParaRPr lang="en-US" sz="1100" dirty="0"/>
-          </a:p>
-          <a:p>
-            <a:pPr indent="0" marL="0">
-              <a:buNone/>
-            </a:pPr>
-            <a:r>
-              <a:rPr lang="en-US" sz="850" dirty="0">
+            <a:endParaRPr lang="en-US" sz="1200" dirty="0"/>
+          </a:p>
+          <a:p>
+            <a:pPr indent="0" marL="0">
+              <a:buNone/>
+            </a:pPr>
+            <a:r>
+              <a:rPr lang="en-US" sz="1000" dirty="0">
                 <a:solidFill>
                   <a:schemeClr val="tx2"/>
                 </a:solidFill>
               </a:rPr>
-              <a:t>Finds where a witness's story conflicts with the record.</a:t>
-            </a:r>
-            <a:endParaRPr lang="en-US" sz="1100" dirty="0"/>
+              <a:t>Witness vs. the record</a:t>
+            </a:r>
+            <a:endParaRPr lang="en-US" sz="1200" dirty="0"/>
           </a:p>
         </p:txBody>
       </p:sp>
@@ -1697,8 +1697,8 @@
         </p:nvSpPr>
         <p:spPr>
           <a:xfrm>
-            <a:off x="2231136" y="2999232"/>
-            <a:ext cx="1389888" cy="640080"/>
+            <a:off x="2231136" y="2962656"/>
+            <a:ext cx="1389888" cy="603504"/>
           </a:xfrm>
           <a:prstGeom prst="rect">
             <a:avLst/>
@@ -1714,28 +1714,28 @@
               <a:buNone/>
             </a:pPr>
             <a:r>
-              <a:rPr lang="en-US" sz="1100" b="1" dirty="0">
+              <a:rPr lang="en-US" sz="1200" b="1" dirty="0">
                 <a:solidFill>
                   <a:schemeClr val="tx1"/>
                 </a:solidFill>
               </a:rPr>
               <a:t>Citation Gate</a:t>
             </a:r>
-            <a:endParaRPr lang="en-US" sz="1100" dirty="0"/>
-          </a:p>
-          <a:p>
-            <a:pPr indent="0" marL="0">
-              <a:buNone/>
-            </a:pPr>
-            <a:r>
-              <a:rPr lang="en-US" sz="850" dirty="0">
+            <a:endParaRPr lang="en-US" sz="1200" dirty="0"/>
+          </a:p>
+          <a:p>
+            <a:pPr indent="0" marL="0">
+              <a:buNone/>
+            </a:pPr>
+            <a:r>
+              <a:rPr lang="en-US" sz="1000" dirty="0">
                 <a:solidFill>
                   <a:schemeClr val="tx2"/>
                 </a:solidFill>
               </a:rPr>
-              <a:t>Checks every cited case and quotation against real opinions.</a:t>
-            </a:r>
-            <a:endParaRPr lang="en-US" sz="1100" dirty="0"/>
+              <a:t>Every citation checked</a:t>
+            </a:r>
+            <a:endParaRPr lang="en-US" sz="1200" dirty="0"/>
           </a:p>
         </p:txBody>
       </p:sp>
@@ -1747,8 +1747,8 @@
         </p:nvSpPr>
         <p:spPr>
           <a:xfrm>
-            <a:off x="2231136" y="3657600"/>
-            <a:ext cx="1389888" cy="640080"/>
+            <a:off x="2231136" y="3602736"/>
+            <a:ext cx="1389888" cy="603504"/>
           </a:xfrm>
           <a:prstGeom prst="rect">
             <a:avLst/>
@@ -1764,28 +1764,28 @@
               <a:buNone/>
             </a:pPr>
             <a:r>
-              <a:rPr lang="en-US" sz="1100" b="1" dirty="0">
+              <a:rPr lang="en-US" sz="1200" b="1" dirty="0">
                 <a:solidFill>
                   <a:schemeClr val="tx1"/>
                 </a:solidFill>
               </a:rPr>
               <a:t>Case Wins Debrief</a:t>
             </a:r>
-            <a:endParaRPr lang="en-US" sz="1100" dirty="0"/>
-          </a:p>
-          <a:p>
-            <a:pPr indent="0" marL="0">
-              <a:buNone/>
-            </a:pPr>
-            <a:r>
-              <a:rPr lang="en-US" sz="850" dirty="0">
+            <a:endParaRPr lang="en-US" sz="1200" dirty="0"/>
+          </a:p>
+          <a:p>
+            <a:pPr indent="0" marL="0">
+              <a:buNone/>
+            </a:pPr>
+            <a:r>
+              <a:rPr lang="en-US" sz="1000" dirty="0">
                 <a:solidFill>
                   <a:schemeClr val="tx2"/>
                 </a:solidFill>
               </a:rPr>
-              <a:t>Turns the firm's wins into patterns the next team can reuse.</a:t>
-            </a:r>
-            <a:endParaRPr lang="en-US" sz="1100" dirty="0"/>
+              <a:t>Lessons from wins, reusable</a:t>
+            </a:r>
+            <a:endParaRPr lang="en-US" sz="1200" dirty="0"/>
           </a:p>
         </p:txBody>
       </p:sp>
@@ -1859,7 +1859,7 @@
         <p:spPr>
           <a:xfrm>
             <a:off x="3913632" y="1682496"/>
-            <a:ext cx="1389888" cy="640080"/>
+            <a:ext cx="1389888" cy="603504"/>
           </a:xfrm>
           <a:prstGeom prst="rect">
             <a:avLst/>
@@ -1875,28 +1875,28 @@
               <a:buNone/>
             </a:pPr>
             <a:r>
-              <a:rPr lang="en-US" sz="1100" b="1" dirty="0">
+              <a:rPr lang="en-US" sz="1200" b="1" dirty="0">
                 <a:solidFill>
                   <a:schemeClr val="tx1"/>
                 </a:solidFill>
               </a:rPr>
               <a:t>Matter Desk</a:t>
             </a:r>
-            <a:endParaRPr lang="en-US" sz="1100" dirty="0"/>
-          </a:p>
-          <a:p>
-            <a:pPr indent="0" marL="0">
-              <a:buNone/>
-            </a:pPr>
-            <a:r>
-              <a:rPr lang="en-US" sz="850" dirty="0">
+            <a:endParaRPr lang="en-US" sz="1200" dirty="0"/>
+          </a:p>
+          <a:p>
+            <a:pPr indent="0" marL="0">
+              <a:buNone/>
+            </a:pPr>
+            <a:r>
+              <a:rPr lang="en-US" sz="1000" dirty="0">
                 <a:solidFill>
                   <a:schemeClr val="tx2"/>
                 </a:solidFill>
               </a:rPr>
-              <a:t>First read of a new matter in five practice areas, deadlines dated.</a:t>
-            </a:r>
-            <a:endParaRPr lang="en-US" sz="1100" dirty="0"/>
+              <a:t>First read of a new matter</a:t>
+            </a:r>
+            <a:endParaRPr lang="en-US" sz="1200" dirty="0"/>
           </a:p>
         </p:txBody>
       </p:sp>
@@ -1908,8 +1908,8 @@
         </p:nvSpPr>
         <p:spPr>
           <a:xfrm>
-            <a:off x="3913632" y="2340864"/>
-            <a:ext cx="1389888" cy="640080"/>
+            <a:off x="3913632" y="2322576"/>
+            <a:ext cx="1389888" cy="603504"/>
           </a:xfrm>
           <a:prstGeom prst="rect">
             <a:avLst/>
@@ -1925,28 +1925,28 @@
               <a:buNone/>
             </a:pPr>
             <a:r>
-              <a:rPr lang="en-US" sz="1100" b="1" dirty="0">
+              <a:rPr lang="en-US" sz="1200" b="1" dirty="0">
                 <a:solidFill>
                   <a:schemeClr val="tx1"/>
                 </a:solidFill>
               </a:rPr>
               <a:t>Synthesis</a:t>
             </a:r>
-            <a:endParaRPr lang="en-US" sz="1100" dirty="0"/>
-          </a:p>
-          <a:p>
-            <a:pPr indent="0" marL="0">
-              <a:buNone/>
-            </a:pPr>
-            <a:r>
-              <a:rPr lang="en-US" sz="850" dirty="0">
+            <a:endParaRPr lang="en-US" sz="1200" dirty="0"/>
+          </a:p>
+          <a:p>
+            <a:pPr indent="0" marL="0">
+              <a:buNone/>
+            </a:pPr>
+            <a:r>
+              <a:rPr lang="en-US" sz="1000" dirty="0">
                 <a:solidFill>
                   <a:schemeClr val="tx2"/>
                 </a:solidFill>
               </a:rPr>
-              <a:t>Buy-side deal workbench: schedules, markup and closing checklist.</a:t>
-            </a:r>
-            <a:endParaRPr lang="en-US" sz="1100" dirty="0"/>
+              <a:t>Buy-side deal workbench</a:t>
+            </a:r>
+            <a:endParaRPr lang="en-US" sz="1200" dirty="0"/>
           </a:p>
         </p:txBody>
       </p:sp>
@@ -1958,8 +1958,8 @@
         </p:nvSpPr>
         <p:spPr>
           <a:xfrm>
-            <a:off x="3913632" y="2999232"/>
-            <a:ext cx="1389888" cy="640080"/>
+            <a:off x="3913632" y="2962656"/>
+            <a:ext cx="1389888" cy="603504"/>
           </a:xfrm>
           <a:prstGeom prst="rect">
             <a:avLst/>
@@ -1975,28 +1975,28 @@
               <a:buNone/>
             </a:pPr>
             <a:r>
-              <a:rPr lang="en-US" sz="1100" b="1" dirty="0">
+              <a:rPr lang="en-US" sz="1200" b="1" dirty="0">
                 <a:solidFill>
                   <a:schemeClr val="tx1"/>
                 </a:solidFill>
               </a:rPr>
               <a:t>Skippy</a:t>
             </a:r>
-            <a:endParaRPr lang="en-US" sz="1100" dirty="0"/>
-          </a:p>
-          <a:p>
-            <a:pPr indent="0" marL="0">
-              <a:buNone/>
-            </a:pPr>
-            <a:r>
-              <a:rPr lang="en-US" sz="850" dirty="0">
+            <a:endParaRPr lang="en-US" sz="1200" dirty="0"/>
+          </a:p>
+          <a:p>
+            <a:pPr indent="0" marL="0">
+              <a:buNone/>
+            </a:pPr>
+            <a:r>
+              <a:rPr lang="en-US" sz="1000" dirty="0">
                 <a:solidFill>
                   <a:schemeClr val="tx2"/>
                 </a:solidFill>
               </a:rPr>
-              <a:t>Answers questions about a matter's files, cited to the page.</a:t>
-            </a:r>
-            <a:endParaRPr lang="en-US" sz="1100" dirty="0"/>
+              <a:t>Ask the matter, cited to the page</a:t>
+            </a:r>
+            <a:endParaRPr lang="en-US" sz="1200" dirty="0"/>
           </a:p>
         </p:txBody>
       </p:sp>
@@ -2070,7 +2070,7 @@
         <p:spPr>
           <a:xfrm>
             <a:off x="5596128" y="1682496"/>
-            <a:ext cx="1389888" cy="640080"/>
+            <a:ext cx="1389888" cy="603504"/>
           </a:xfrm>
           <a:prstGeom prst="rect">
             <a:avLst/>
@@ -2086,28 +2086,28 @@
               <a:buNone/>
             </a:pPr>
             <a:r>
-              <a:rPr lang="en-US" sz="1100" b="1" dirty="0">
+              <a:rPr lang="en-US" sz="1200" b="1" dirty="0">
                 <a:solidFill>
                   <a:schemeClr val="tx1"/>
                 </a:solidFill>
               </a:rPr>
               <a:t>Guideline Guard</a:t>
             </a:r>
-            <a:endParaRPr lang="en-US" sz="1100" dirty="0"/>
-          </a:p>
-          <a:p>
-            <a:pPr indent="0" marL="0">
-              <a:buNone/>
-            </a:pPr>
-            <a:r>
-              <a:rPr lang="en-US" sz="850" dirty="0">
+            <a:endParaRPr lang="en-US" sz="1200" dirty="0"/>
+          </a:p>
+          <a:p>
+            <a:pPr indent="0" marL="0">
+              <a:buNone/>
+            </a:pPr>
+            <a:r>
+              <a:rPr lang="en-US" sz="1000" dirty="0">
                 <a:solidFill>
                   <a:schemeClr val="tx2"/>
                 </a:solidFill>
               </a:rPr>
-              <a:t>Applies each client's outside counsel guidelines to the prebill.</a:t>
-            </a:r>
-            <a:endParaRPr lang="en-US" sz="1100" dirty="0"/>
+              <a:t>Client guidelines on the prebill</a:t>
+            </a:r>
+            <a:endParaRPr lang="en-US" sz="1200" dirty="0"/>
           </a:p>
         </p:txBody>
       </p:sp>
@@ -2119,8 +2119,8 @@
         </p:nvSpPr>
         <p:spPr>
           <a:xfrm>
-            <a:off x="5596128" y="2340864"/>
-            <a:ext cx="1389888" cy="640080"/>
+            <a:off x="5596128" y="2322576"/>
+            <a:ext cx="1389888" cy="603504"/>
           </a:xfrm>
           <a:prstGeom prst="rect">
             <a:avLst/>
@@ -2136,28 +2136,28 @@
               <a:buNone/>
             </a:pPr>
             <a:r>
-              <a:rPr lang="en-US" sz="1100" b="1" dirty="0">
+              <a:rPr lang="en-US" sz="1200" b="1" dirty="0">
                 <a:solidFill>
                   <a:schemeClr val="tx1"/>
                 </a:solidFill>
               </a:rPr>
               <a:t>Hour Catch</a:t>
             </a:r>
-            <a:endParaRPr lang="en-US" sz="1100" dirty="0"/>
-          </a:p>
-          <a:p>
-            <a:pPr indent="0" marL="0">
-              <a:buNone/>
-            </a:pPr>
-            <a:r>
-              <a:rPr lang="en-US" sz="850" dirty="0">
+            <a:endParaRPr lang="en-US" sz="1200" dirty="0"/>
+          </a:p>
+          <a:p>
+            <a:pPr indent="0" marL="0">
+              <a:buNone/>
+            </a:pPr>
+            <a:r>
+              <a:rPr lang="en-US" sz="1000" dirty="0">
                 <a:solidFill>
                   <a:schemeClr val="tx2"/>
                 </a:solidFill>
               </a:rPr>
-              <a:t>Reads a lawyer's day and drafts the time entries it would miss.</a:t>
-            </a:r>
-            <a:endParaRPr lang="en-US" sz="1100" dirty="0"/>
+              <a:t>Missed time, drafted</a:t>
+            </a:r>
+            <a:endParaRPr lang="en-US" sz="1200" dirty="0"/>
           </a:p>
         </p:txBody>
       </p:sp>
@@ -2231,7 +2231,7 @@
         <p:spPr>
           <a:xfrm>
             <a:off x="7278624" y="1682496"/>
-            <a:ext cx="1389888" cy="640080"/>
+            <a:ext cx="1389888" cy="603504"/>
           </a:xfrm>
           <a:prstGeom prst="rect">
             <a:avLst/>
@@ -2247,28 +2247,28 @@
               <a:buNone/>
             </a:pPr>
             <a:r>
-              <a:rPr lang="en-US" sz="1100" b="1" dirty="0">
+              <a:rPr lang="en-US" sz="1200" b="1" dirty="0">
                 <a:solidFill>
                   <a:schemeClr val="tx1"/>
                 </a:solidFill>
               </a:rPr>
               <a:t>Praxis</a:t>
             </a:r>
-            <a:endParaRPr lang="en-US" sz="1100" dirty="0"/>
-          </a:p>
-          <a:p>
-            <a:pPr indent="0" marL="0">
-              <a:buNone/>
-            </a:pPr>
-            <a:r>
-              <a:rPr lang="en-US" sz="850" dirty="0">
+            <a:endParaRPr lang="en-US" sz="1200" dirty="0"/>
+          </a:p>
+          <a:p>
+            <a:pPr indent="0" marL="0">
+              <a:buNone/>
+            </a:pPr>
+            <a:r>
+              <a:rPr lang="en-US" sz="1000" dirty="0">
                 <a:solidFill>
                   <a:schemeClr val="tx2"/>
                 </a:solidFill>
               </a:rPr>
-              <a:t>Maps and scores AI ideas and carries the winners through pilots.</a:t>
-            </a:r>
-            <a:endParaRPr lang="en-US" sz="1100" dirty="0"/>
+              <a:t>Scores AI ideas, runs pilots</a:t>
+            </a:r>
+            <a:endParaRPr lang="en-US" sz="1200" dirty="0"/>
           </a:p>
         </p:txBody>
       </p:sp>
@@ -2280,8 +2280,8 @@
         </p:nvSpPr>
         <p:spPr>
           <a:xfrm>
-            <a:off x="7278624" y="2340864"/>
-            <a:ext cx="1389888" cy="640080"/>
+            <a:off x="7278624" y="2322576"/>
+            <a:ext cx="1389888" cy="603504"/>
           </a:xfrm>
           <a:prstGeom prst="rect">
             <a:avLst/>
@@ -2297,28 +2297,28 @@
               <a:buNone/>
             </a:pPr>
             <a:r>
-              <a:rPr lang="en-US" sz="1100" b="1" dirty="0">
+              <a:rPr lang="en-US" sz="1200" b="1" dirty="0">
                 <a:solidFill>
                   <a:schemeClr val="tx1"/>
                 </a:solidFill>
               </a:rPr>
               <a:t>Marketing Studio</a:t>
             </a:r>
-            <a:endParaRPr lang="en-US" sz="1100" dirty="0"/>
-          </a:p>
-          <a:p>
-            <a:pPr indent="0" marL="0">
-              <a:buNone/>
-            </a:pPr>
-            <a:r>
-              <a:rPr lang="en-US" sz="850" dirty="0">
+            <a:endParaRPr lang="en-US" sz="1200" dirty="0"/>
+          </a:p>
+          <a:p>
+            <a:pPr indent="0" marL="0">
+              <a:buNone/>
+            </a:pPr>
+            <a:r>
+              <a:rPr lang="en-US" sz="1000" dirty="0">
                 <a:solidFill>
                   <a:schemeClr val="tx2"/>
                 </a:solidFill>
               </a:rPr>
-              <a:t>Drafts bios, alerts and RFP responses, then checks them against the rules.</a:t>
-            </a:r>
-            <a:endParaRPr lang="en-US" sz="1100" dirty="0"/>
+              <a:t>Bios, alerts and RFPs, checked</a:t>
+            </a:r>
+            <a:endParaRPr lang="en-US" sz="1200" dirty="0"/>
           </a:p>
         </p:txBody>
       </p:sp>
@@ -2401,7 +2401,7 @@
                   <a:schemeClr val="tx2"/>
                 </a:solidFill>
               </a:rPr>
-              <a:t>Sensitive data stays on firm hardware</a:t>
+              <a:t>Data stays on firm hardware</a:t>
             </a:r>
             <a:endParaRPr lang="en-US" sz="950" dirty="0"/>
           </a:p>
@@ -2486,7 +2486,7 @@
                   <a:schemeClr val="tx2"/>
                 </a:solidFill>
               </a:rPr>
-              <a:t>Sign-on and role-based access</a:t>
+              <a:t>Sign-on and roles</a:t>
             </a:r>
             <a:endParaRPr lang="en-US" sz="950" dirty="0"/>
           </a:p>
@@ -2571,7 +2571,7 @@
                   <a:schemeClr val="tx2"/>
                 </a:solidFill>
               </a:rPr>
-              <a:t>Ethical walls enforced in the data</a:t>
+              <a:t>Ethical walls</a:t>
             </a:r>
             <a:endParaRPr lang="en-US" sz="950" dirty="0"/>
           </a:p>
@@ -2656,7 +2656,7 @@
                   <a:schemeClr val="tx2"/>
                 </a:solidFill>
               </a:rPr>
-              <a:t>Audit trail on every action</a:t>
+              <a:t>Audit trail</a:t>
             </a:r>
             <a:endParaRPr lang="en-US" sz="950" dirty="0"/>
           </a:p>
@@ -2741,7 +2741,7 @@
                   <a:schemeClr val="tx2"/>
                 </a:solidFill>
               </a:rPr>
-              <a:t>Tests and docs written for IT review</a:t>
+              <a:t>Tests and docs for IT</a:t>
             </a:r>
             <a:endParaRPr lang="en-US" sz="950" dirty="0"/>
           </a:p>
@@ -2849,7 +2849,7 @@
                   <a:srgbClr val="2D4459"/>
                 </a:solidFill>
               </a:rPr>
-              <a:t>Quick wins I think are worth exploring</a:t>
+              <a:t>Four quick wins on what we already license</a:t>
             </a:r>
             <a:endParaRPr lang="en-US" sz="2600" dirty="0"/>
           </a:p>
@@ -2887,7 +2887,7 @@
                   <a:schemeClr val="tx2"/>
                 </a:solidFill>
               </a:rPr>
-              <a:t>Ideas, not a plan. Each could run within a few months, mostly on tools the firm already licenses.</a:t>
+              <a:t>Ideas, not a plan. Each uses data the firm already holds, and a person reviews every output.</a:t>
             </a:r>
             <a:endParaRPr lang="en-US" sz="1300" dirty="0"/>
           </a:p>
@@ -2895,7 +2895,7 @@
       </p:sp>
       <p:sp>
         <p:nvSpPr>
-          <p:cNvPr id="4" name="Outside counsel guidelines brief card"/>
+          <p:cNvPr id="4" name="Client guidelines brief card"/>
           <p:cNvSpPr/>
           <p:nvPr/>
         </p:nvSpPr>
@@ -2969,7 +2969,7 @@
       </p:pic>
       <p:sp>
         <p:nvSpPr>
-          <p:cNvPr id="7" name="Outside counsel guidelines brief name"/>
+          <p:cNvPr id="7" name="Client guidelines brief name"/>
           <p:cNvSpPr txBox="1"/>
           <p:nvPr/>
         </p:nvSpPr>
@@ -2997,7 +2997,7 @@
                   <a:schemeClr val="tx1"/>
                 </a:solidFill>
               </a:rPr>
-              <a:t>Outside counsel guidelines brief</a:t>
+              <a:t>Client guidelines brief</a:t>
             </a:r>
             <a:endParaRPr lang="en-US" sz="1400" dirty="0"/>
           </a:p>
@@ -3005,14 +3005,14 @@
       </p:sp>
       <p:sp>
         <p:nvSpPr>
-          <p:cNvPr id="8" name="Outside counsel guidelines brief what"/>
-          <p:cNvSpPr txBox="1"/>
-          <p:nvPr/>
-        </p:nvSpPr>
-        <p:spPr>
-          <a:xfrm>
-            <a:off x="594360" y="1856232"/>
-            <a:ext cx="3749040" cy="548640"/>
+          <p:cNvPr id="8" name="Client guidelines brief what"/>
+          <p:cNvSpPr txBox="1"/>
+          <p:nvPr/>
+        </p:nvSpPr>
+        <p:spPr>
+          <a:xfrm>
+            <a:off x="594360" y="1892808"/>
+            <a:ext cx="3749040" cy="868680"/>
           </a:xfrm>
           <a:prstGeom prst="rect">
             <a:avLst/>
@@ -3028,67 +3028,20 @@
               <a:buNone/>
             </a:pPr>
             <a:r>
-              <a:rPr lang="en-US" sz="1100" dirty="0">
+              <a:rPr lang="en-US" sz="1300" dirty="0">
                 <a:solidFill>
                   <a:schemeClr val="tx1"/>
                 </a:solidFill>
               </a:rPr>
-              <a:t>Turns each client's guidelines into a one-page brief per matter and flags time entries that break them before the invoice goes out.</a:t>
-            </a:r>
-            <a:endParaRPr lang="en-US" sz="1100" dirty="0"/>
-          </a:p>
-        </p:txBody>
-      </p:sp>
-      <p:sp>
-        <p:nvSpPr>
-          <p:cNvPr id="9" name="Outside counsel guidelines brief why"/>
-          <p:cNvSpPr txBox="1"/>
-          <p:nvPr/>
-        </p:nvSpPr>
-        <p:spPr>
-          <a:xfrm>
-            <a:off x="594360" y="2386584"/>
-            <a:ext cx="3749040" cy="457200"/>
-          </a:xfrm>
-          <a:prstGeom prst="rect">
-            <a:avLst/>
-          </a:prstGeom>
-          <a:noFill/>
-          <a:ln/>
-        </p:spPr>
-        <p:txBody>
-          <a:bodyPr wrap="square" lIns="0" tIns="0" rIns="0" bIns="0" rtlCol="0" anchor="t"/>
-          <a:lstStyle/>
-          <a:p>
-            <a:pPr indent="0" marL="0">
-              <a:buNone/>
-            </a:pPr>
-            <a:r>
-              <a:rPr lang="en-US" sz="1000" b="1" dirty="0">
-                <a:solidFill>
-                  <a:schemeClr val="accent5"/>
-                </a:solidFill>
-              </a:rPr>
-              <a:t>Why I would start here: </a:t>
-            </a:r>
-            <a:pPr indent="0" marL="0">
-              <a:buNone/>
-            </a:pPr>
-            <a:r>
-              <a:rPr lang="en-US" sz="1000" dirty="0">
-                <a:solidFill>
-                  <a:schemeClr val="tx2"/>
-                </a:solidFill>
-              </a:rPr>
-              <a:t>Uses documents the firm already holds. A person reviews the output before anything leaves.</a:t>
-            </a:r>
-            <a:endParaRPr lang="en-US" sz="1000" dirty="0"/>
-          </a:p>
-        </p:txBody>
-      </p:sp>
-      <p:sp>
-        <p:nvSpPr>
-          <p:cNvPr id="10" name="Pre-bill reviewer card"/>
+              <a:t>Each client's billing rules on one page, and entries that break them flagged before the invoice goes out.</a:t>
+            </a:r>
+            <a:endParaRPr lang="en-US" sz="1300" dirty="0"/>
+          </a:p>
+        </p:txBody>
+      </p:sp>
+      <p:sp>
+        <p:nvSpPr>
+          <p:cNvPr id="9" name="Pre-bill reviewer card"/>
           <p:cNvSpPr/>
           <p:nvPr/>
         </p:nvSpPr>
@@ -3113,7 +3066,7 @@
       </p:sp>
       <p:sp>
         <p:nvSpPr>
-          <p:cNvPr id="11" name="icon square"/>
+          <p:cNvPr id="10" name="icon square"/>
           <p:cNvSpPr/>
           <p:nvPr/>
         </p:nvSpPr>
@@ -3138,7 +3091,7 @@
       </p:sp>
       <p:pic>
         <p:nvPicPr>
-          <p:cNvPr id="12" name="dollar icon" descr="preencoded.png">    </p:cNvPr>
+          <p:cNvPr id="11" name="dollar icon" descr="preencoded.png">    </p:cNvPr>
           <p:cNvPicPr>
             <a:picLocks noChangeAspect="1"/>
           </p:cNvPicPr>
@@ -3162,7 +3115,7 @@
       </p:pic>
       <p:sp>
         <p:nvSpPr>
-          <p:cNvPr id="13" name="Pre-bill reviewer name"/>
+          <p:cNvPr id="12" name="Pre-bill reviewer name"/>
           <p:cNvSpPr txBox="1"/>
           <p:nvPr/>
         </p:nvSpPr>
@@ -3198,14 +3151,14 @@
       </p:sp>
       <p:sp>
         <p:nvSpPr>
-          <p:cNvPr id="14" name="Pre-bill reviewer what"/>
-          <p:cNvSpPr txBox="1"/>
-          <p:nvPr/>
-        </p:nvSpPr>
-        <p:spPr>
-          <a:xfrm>
-            <a:off x="4800600" y="1856232"/>
-            <a:ext cx="3749040" cy="548640"/>
+          <p:cNvPr id="13" name="Pre-bill reviewer what"/>
+          <p:cNvSpPr txBox="1"/>
+          <p:nvPr/>
+        </p:nvSpPr>
+        <p:spPr>
+          <a:xfrm>
+            <a:off x="4800600" y="1892808"/>
+            <a:ext cx="3749040" cy="868680"/>
           </a:xfrm>
           <a:prstGeom prst="rect">
             <a:avLst/>
@@ -3221,67 +3174,20 @@
               <a:buNone/>
             </a:pPr>
             <a:r>
-              <a:rPr lang="en-US" sz="1100" dirty="0">
+              <a:rPr lang="en-US" sz="1300" dirty="0">
                 <a:solidFill>
                   <a:schemeClr val="tx1"/>
                 </a:solidFill>
               </a:rPr>
-              <a:t>Flags vague or block-billed entries a client is likely to reject and suggests a rewrite.</a:t>
-            </a:r>
-            <a:endParaRPr lang="en-US" sz="1100" dirty="0"/>
-          </a:p>
-        </p:txBody>
-      </p:sp>
-      <p:sp>
-        <p:nvSpPr>
-          <p:cNvPr id="15" name="Pre-bill reviewer why"/>
-          <p:cNvSpPr txBox="1"/>
-          <p:nvPr/>
-        </p:nvSpPr>
-        <p:spPr>
-          <a:xfrm>
-            <a:off x="4800600" y="2386584"/>
-            <a:ext cx="3749040" cy="457200"/>
-          </a:xfrm>
-          <a:prstGeom prst="rect">
-            <a:avLst/>
-          </a:prstGeom>
-          <a:noFill/>
-          <a:ln/>
-        </p:spPr>
-        <p:txBody>
-          <a:bodyPr wrap="square" lIns="0" tIns="0" rIns="0" bIns="0" rtlCol="0" anchor="t"/>
-          <a:lstStyle/>
-          <a:p>
-            <a:pPr indent="0" marL="0">
-              <a:buNone/>
-            </a:pPr>
-            <a:r>
-              <a:rPr lang="en-US" sz="1000" b="1" dirty="0">
-                <a:solidFill>
-                  <a:schemeClr val="accent5"/>
-                </a:solidFill>
-              </a:rPr>
-              <a:t>Why I would start here: </a:t>
-            </a:r>
-            <a:pPr indent="0" marL="0">
-              <a:buNone/>
-            </a:pPr>
-            <a:r>
-              <a:rPr lang="en-US" sz="1000" dirty="0">
-                <a:solidFill>
-                  <a:schemeClr val="tx2"/>
-                </a:solidFill>
-              </a:rPr>
-              <a:t>Internal only. The write-offs it prevents show up on the firm's own ledger.</a:t>
-            </a:r>
-            <a:endParaRPr lang="en-US" sz="1000" dirty="0"/>
-          </a:p>
-        </p:txBody>
-      </p:sp>
-      <p:sp>
-        <p:nvSpPr>
-          <p:cNvPr id="16" name="Matter handoff memo card"/>
+              <a:t>Flags vague or block-billed entries a client would reject, and suggests the rewrite.</a:t>
+            </a:r>
+            <a:endParaRPr lang="en-US" sz="1300" dirty="0"/>
+          </a:p>
+        </p:txBody>
+      </p:sp>
+      <p:sp>
+        <p:nvSpPr>
+          <p:cNvPr id="14" name="Matter handoff memo card"/>
           <p:cNvSpPr/>
           <p:nvPr/>
         </p:nvSpPr>
@@ -3306,7 +3212,7 @@
       </p:sp>
       <p:sp>
         <p:nvSpPr>
-          <p:cNvPr id="17" name="icon square"/>
+          <p:cNvPr id="15" name="icon square"/>
           <p:cNvSpPr/>
           <p:nvPr/>
         </p:nvSpPr>
@@ -3331,7 +3237,7 @@
       </p:sp>
       <p:pic>
         <p:nvPicPr>
-          <p:cNvPr id="18" name="repeat icon" descr="preencoded.png">    </p:cNvPr>
+          <p:cNvPr id="16" name="repeat icon" descr="preencoded.png">    </p:cNvPr>
           <p:cNvPicPr>
             <a:picLocks noChangeAspect="1"/>
           </p:cNvPicPr>
@@ -3355,7 +3261,7 @@
       </p:pic>
       <p:sp>
         <p:nvSpPr>
-          <p:cNvPr id="19" name="Matter handoff memo name"/>
+          <p:cNvPr id="17" name="Matter handoff memo name"/>
           <p:cNvSpPr txBox="1"/>
           <p:nvPr/>
         </p:nvSpPr>
@@ -3391,14 +3297,14 @@
       </p:sp>
       <p:sp>
         <p:nvSpPr>
-          <p:cNvPr id="20" name="Matter handoff memo what"/>
-          <p:cNvSpPr txBox="1"/>
-          <p:nvPr/>
-        </p:nvSpPr>
-        <p:spPr>
-          <a:xfrm>
-            <a:off x="594360" y="3639312"/>
-            <a:ext cx="3749040" cy="548640"/>
+          <p:cNvPr id="18" name="Matter handoff memo what"/>
+          <p:cNvSpPr txBox="1"/>
+          <p:nvPr/>
+        </p:nvSpPr>
+        <p:spPr>
+          <a:xfrm>
+            <a:off x="594360" y="3675888"/>
+            <a:ext cx="3749040" cy="868680"/>
           </a:xfrm>
           <a:prstGeom prst="rect">
             <a:avLst/>
@@ -3414,67 +3320,20 @@
               <a:buNone/>
             </a:pPr>
             <a:r>
-              <a:rPr lang="en-US" sz="1100" dirty="0">
+              <a:rPr lang="en-US" sz="1300" dirty="0">
                 <a:solidFill>
                   <a:schemeClr val="tx1"/>
                 </a:solidFill>
               </a:rPr>
-              <a:t>Produces a "state of the matter" summary from emails and documents when someone rotates off or retires.</a:t>
-            </a:r>
-            <a:endParaRPr lang="en-US" sz="1100" dirty="0"/>
-          </a:p>
-        </p:txBody>
-      </p:sp>
-      <p:sp>
-        <p:nvSpPr>
-          <p:cNvPr id="21" name="Matter handoff memo why"/>
-          <p:cNvSpPr txBox="1"/>
-          <p:nvPr/>
-        </p:nvSpPr>
-        <p:spPr>
-          <a:xfrm>
-            <a:off x="594360" y="4169664"/>
-            <a:ext cx="3749040" cy="457200"/>
-          </a:xfrm>
-          <a:prstGeom prst="rect">
-            <a:avLst/>
-          </a:prstGeom>
-          <a:noFill/>
-          <a:ln/>
-        </p:spPr>
-        <p:txBody>
-          <a:bodyPr wrap="square" lIns="0" tIns="0" rIns="0" bIns="0" rtlCol="0" anchor="t"/>
-          <a:lstStyle/>
-          <a:p>
-            <a:pPr indent="0" marL="0">
-              <a:buNone/>
-            </a:pPr>
-            <a:r>
-              <a:rPr lang="en-US" sz="1000" b="1" dirty="0">
-                <a:solidFill>
-                  <a:schemeClr val="accent5"/>
-                </a:solidFill>
-              </a:rPr>
-              <a:t>Why I would start here: </a:t>
-            </a:r>
-            <a:pPr indent="0" marL="0">
-              <a:buNone/>
-            </a:pPr>
-            <a:r>
-              <a:rPr lang="en-US" sz="1000" dirty="0">
-                <a:solidFill>
-                  <a:schemeClr val="tx2"/>
-                </a:solidFill>
-              </a:rPr>
-              <a:t>Reads the firm's own files. Replaces a task nobody enjoys.</a:t>
-            </a:r>
-            <a:endParaRPr lang="en-US" sz="1000" dirty="0"/>
-          </a:p>
-        </p:txBody>
-      </p:sp>
-      <p:sp>
-        <p:nvSpPr>
-          <p:cNvPr id="22" name="Drafting from our own precedents card"/>
+              <a:t>A "state of the matter" brief from the emails and documents when someone rotates off or retires.</a:t>
+            </a:r>
+            <a:endParaRPr lang="en-US" sz="1300" dirty="0"/>
+          </a:p>
+        </p:txBody>
+      </p:sp>
+      <p:sp>
+        <p:nvSpPr>
+          <p:cNvPr id="19" name="Drafting from our own precedents card"/>
           <p:cNvSpPr/>
           <p:nvPr/>
         </p:nvSpPr>
@@ -3499,7 +3358,7 @@
       </p:sp>
       <p:sp>
         <p:nvSpPr>
-          <p:cNvPr id="23" name="icon square"/>
+          <p:cNvPr id="20" name="icon square"/>
           <p:cNvSpPr/>
           <p:nvPr/>
         </p:nvSpPr>
@@ -3524,7 +3383,7 @@
       </p:sp>
       <p:pic>
         <p:nvPicPr>
-          <p:cNvPr id="24" name="edit icon" descr="preencoded.png">    </p:cNvPr>
+          <p:cNvPr id="21" name="edit icon" descr="preencoded.png">    </p:cNvPr>
           <p:cNvPicPr>
             <a:picLocks noChangeAspect="1"/>
           </p:cNvPicPr>
@@ -3548,7 +3407,7 @@
       </p:pic>
       <p:sp>
         <p:nvSpPr>
-          <p:cNvPr id="25" name="Drafting from our own precedents name"/>
+          <p:cNvPr id="22" name="Drafting from our own precedents name"/>
           <p:cNvSpPr txBox="1"/>
           <p:nvPr/>
         </p:nvSpPr>
@@ -3584,14 +3443,14 @@
       </p:sp>
       <p:sp>
         <p:nvSpPr>
-          <p:cNvPr id="26" name="Drafting from our own precedents what"/>
-          <p:cNvSpPr txBox="1"/>
-          <p:nvPr/>
-        </p:nvSpPr>
-        <p:spPr>
-          <a:xfrm>
-            <a:off x="4800600" y="3639312"/>
-            <a:ext cx="3749040" cy="548640"/>
+          <p:cNvPr id="23" name="Drafting from our own precedents what"/>
+          <p:cNvSpPr txBox="1"/>
+          <p:nvPr/>
+        </p:nvSpPr>
+        <p:spPr>
+          <a:xfrm>
+            <a:off x="4800600" y="3675888"/>
+            <a:ext cx="3749040" cy="868680"/>
           </a:xfrm>
           <a:prstGeom prst="rect">
             <a:avLst/>
@@ -3607,61 +3466,14 @@
               <a:buNone/>
             </a:pPr>
             <a:r>
-              <a:rPr lang="en-US" sz="1100" dirty="0">
+              <a:rPr lang="en-US" sz="1300" dirty="0">
                 <a:solidFill>
                   <a:schemeClr val="tx1"/>
                 </a:solidFill>
               </a:rPr>
-              <a:t>First drafts of routine documents from the firm's best past examples instead of generic templates.</a:t>
-            </a:r>
-            <a:endParaRPr lang="en-US" sz="1100" dirty="0"/>
-          </a:p>
-        </p:txBody>
-      </p:sp>
-      <p:sp>
-        <p:nvSpPr>
-          <p:cNvPr id="27" name="Drafting from our own precedents why"/>
-          <p:cNvSpPr txBox="1"/>
-          <p:nvPr/>
-        </p:nvSpPr>
-        <p:spPr>
-          <a:xfrm>
-            <a:off x="4800600" y="4169664"/>
-            <a:ext cx="3749040" cy="457200"/>
-          </a:xfrm>
-          <a:prstGeom prst="rect">
-            <a:avLst/>
-          </a:prstGeom>
-          <a:noFill/>
-          <a:ln/>
-        </p:spPr>
-        <p:txBody>
-          <a:bodyPr wrap="square" lIns="0" tIns="0" rIns="0" bIns="0" rtlCol="0" anchor="t"/>
-          <a:lstStyle/>
-          <a:p>
-            <a:pPr indent="0" marL="0">
-              <a:buNone/>
-            </a:pPr>
-            <a:r>
-              <a:rPr lang="en-US" sz="1000" b="1" dirty="0">
-                <a:solidFill>
-                  <a:schemeClr val="accent5"/>
-                </a:solidFill>
-              </a:rPr>
-              <a:t>Why I would start here: </a:t>
-            </a:r>
-            <a:pPr indent="0" marL="0">
-              <a:buNone/>
-            </a:pPr>
-            <a:r>
-              <a:rPr lang="en-US" sz="1000" dirty="0">
-                <a:solidFill>
-                  <a:schemeClr val="tx2"/>
-                </a:solidFill>
-              </a:rPr>
-              <a:t>Can start inside Copilot and the document system with approved prompts. Nothing new to host.</a:t>
-            </a:r>
-            <a:endParaRPr lang="en-US" sz="1000" dirty="0"/>
+              <a:t>First drafts from the firm's best past documents, inside Copilot and the document system.</a:t>
+            </a:r>
+            <a:endParaRPr lang="en-US" sz="1300" dirty="0"/>
           </a:p>
         </p:txBody>
       </p:sp>
@@ -3767,7 +3579,7 @@
                   <a:srgbClr val="2D4459"/>
                 </a:solidFill>
               </a:rPr>
-              <a:t>Bigger ideas, if there is appetite</a:t>
+              <a:t>Three bigger ideas, built on what the firm already knows</a:t>
             </a:r>
             <a:endParaRPr lang="en-US" sz="2600" dirty="0"/>
           </a:p>
@@ -3805,7 +3617,7 @@
                   <a:schemeClr val="tx2"/>
                 </a:solidFill>
               </a:rPr>
-              <a:t>A few directions I find promising. They would need IT and leadership to shape them.</a:t>
+              <a:t>Directions I find promising. They would need IT and leadership to shape them.</a:t>
             </a:r>
             <a:endParaRPr lang="en-US" sz="1300" dirty="0"/>
           </a:p>
@@ -3820,7 +3632,7 @@
         <p:spPr>
           <a:xfrm>
             <a:off x="457200" y="1325880"/>
-            <a:ext cx="2651760" cy="3246120"/>
+            <a:ext cx="2651760" cy="2743200"/>
           </a:xfrm>
           <a:prstGeom prst="rect">
             <a:avLst/>
@@ -3923,230 +3735,97 @@
       </p:sp>
       <p:sp>
         <p:nvSpPr>
-          <p:cNvPr id="8" name="Client risk radar What it is label"/>
-          <p:cNvSpPr txBox="1"/>
-          <p:nvPr/>
-        </p:nvSpPr>
-        <p:spPr>
-          <a:xfrm>
-            <a:off x="594360" y="1984248"/>
-            <a:ext cx="2377440" cy="201168"/>
-          </a:xfrm>
-          <a:prstGeom prst="rect">
-            <a:avLst/>
-          </a:prstGeom>
-          <a:noFill/>
-          <a:ln/>
-        </p:spPr>
-        <p:txBody>
-          <a:bodyPr wrap="square" lIns="0" tIns="0" rIns="0" bIns="0" rtlCol="0" anchor="ctr"/>
-          <a:lstStyle/>
-          <a:p>
-            <a:pPr indent="0" marL="0">
-              <a:buNone/>
-            </a:pPr>
-            <a:r>
-              <a:rPr lang="en-US" sz="950" b="1" dirty="0">
+          <p:cNvPr id="8" name="Client risk radar what"/>
+          <p:cNvSpPr txBox="1"/>
+          <p:nvPr/>
+        </p:nvSpPr>
+        <p:spPr>
+          <a:xfrm>
+            <a:off x="594360" y="2011680"/>
+            <a:ext cx="2377440" cy="1188720"/>
+          </a:xfrm>
+          <a:prstGeom prst="rect">
+            <a:avLst/>
+          </a:prstGeom>
+          <a:noFill/>
+          <a:ln/>
+        </p:spPr>
+        <p:txBody>
+          <a:bodyPr wrap="square" lIns="0" tIns="0" rIns="0" bIns="0" rtlCol="0" anchor="t"/>
+          <a:lstStyle/>
+          <a:p>
+            <a:pPr indent="0" marL="0">
+              <a:buNone/>
+            </a:pPr>
+            <a:r>
+              <a:rPr lang="en-US" sz="1250" dirty="0">
+                <a:solidFill>
+                  <a:schemeClr val="tx1"/>
+                </a:solidFill>
+              </a:rPr>
+              <a:t>Watches public signals about our clients, such as lawsuits, inspection citations and agency audits.</a:t>
+            </a:r>
+            <a:endParaRPr lang="en-US" sz="1250" dirty="0"/>
+          </a:p>
+        </p:txBody>
+      </p:sp>
+      <p:sp>
+        <p:nvSpPr>
+          <p:cNvPr id="9" name="Client risk radar why"/>
+          <p:cNvSpPr txBox="1"/>
+          <p:nvPr/>
+        </p:nvSpPr>
+        <p:spPr>
+          <a:xfrm>
+            <a:off x="594360" y="3154680"/>
+            <a:ext cx="2377440" cy="822960"/>
+          </a:xfrm>
+          <a:prstGeom prst="rect">
+            <a:avLst/>
+          </a:prstGeom>
+          <a:noFill/>
+          <a:ln/>
+        </p:spPr>
+        <p:txBody>
+          <a:bodyPr wrap="square" lIns="0" tIns="0" rIns="0" bIns="0" rtlCol="0" anchor="t"/>
+          <a:lstStyle/>
+          <a:p>
+            <a:pPr indent="0" marL="0">
+              <a:buNone/>
+            </a:pPr>
+            <a:r>
+              <a:rPr lang="en-US" sz="1200" b="1" dirty="0">
                 <a:solidFill>
                   <a:schemeClr val="accent5"/>
                 </a:solidFill>
               </a:rPr>
-              <a:t>What it is</a:t>
-            </a:r>
-            <a:endParaRPr lang="en-US" sz="950" dirty="0"/>
-          </a:p>
-        </p:txBody>
-      </p:sp>
-      <p:sp>
-        <p:nvSpPr>
-          <p:cNvPr id="9" name="Client risk radar What it is"/>
-          <p:cNvSpPr txBox="1"/>
-          <p:nvPr/>
-        </p:nvSpPr>
-        <p:spPr>
-          <a:xfrm>
-            <a:off x="594360" y="2185416"/>
-            <a:ext cx="2377440" cy="621792"/>
-          </a:xfrm>
-          <a:prstGeom prst="rect">
-            <a:avLst/>
-          </a:prstGeom>
-          <a:noFill/>
-          <a:ln/>
-        </p:spPr>
-        <p:txBody>
-          <a:bodyPr wrap="square" lIns="0" tIns="0" rIns="0" bIns="0" rtlCol="0" anchor="t"/>
-          <a:lstStyle/>
-          <a:p>
-            <a:pPr indent="0" marL="0">
-              <a:buNone/>
-            </a:pPr>
-            <a:r>
-              <a:rPr lang="en-US" sz="1050" dirty="0">
+              <a:t>Why it matters: </a:t>
+            </a:r>
+            <a:pPr indent="0" marL="0">
+              <a:buNone/>
+            </a:pPr>
+            <a:r>
+              <a:rPr lang="en-US" sz="1200" dirty="0">
                 <a:solidFill>
                   <a:schemeClr val="tx1"/>
                 </a:solidFill>
               </a:rPr>
-              <a:t>Watches public signals about our clients, such as lawsuits, inspection citations, agency audits and news, and turns them into early warnings.</a:t>
-            </a:r>
-            <a:endParaRPr lang="en-US" sz="1050" dirty="0"/>
-          </a:p>
-        </p:txBody>
-      </p:sp>
-      <p:sp>
-        <p:nvSpPr>
-          <p:cNvPr id="10" name="Client risk radar Why it matters label"/>
-          <p:cNvSpPr txBox="1"/>
-          <p:nvPr/>
-        </p:nvSpPr>
-        <p:spPr>
-          <a:xfrm>
-            <a:off x="594360" y="2843784"/>
-            <a:ext cx="2377440" cy="201168"/>
-          </a:xfrm>
-          <a:prstGeom prst="rect">
-            <a:avLst/>
-          </a:prstGeom>
-          <a:noFill/>
-          <a:ln/>
-        </p:spPr>
-        <p:txBody>
-          <a:bodyPr wrap="square" lIns="0" tIns="0" rIns="0" bIns="0" rtlCol="0" anchor="ctr"/>
-          <a:lstStyle/>
-          <a:p>
-            <a:pPr indent="0" marL="0">
-              <a:buNone/>
-            </a:pPr>
-            <a:r>
-              <a:rPr lang="en-US" sz="950" b="1" dirty="0">
-                <a:solidFill>
-                  <a:schemeClr val="accent5"/>
-                </a:solidFill>
-              </a:rPr>
-              <a:t>Why it matters</a:t>
-            </a:r>
-            <a:endParaRPr lang="en-US" sz="950" dirty="0"/>
-          </a:p>
-        </p:txBody>
-      </p:sp>
-      <p:sp>
-        <p:nvSpPr>
-          <p:cNvPr id="11" name="Client risk radar Why it matters"/>
-          <p:cNvSpPr txBox="1"/>
-          <p:nvPr/>
-        </p:nvSpPr>
-        <p:spPr>
-          <a:xfrm>
-            <a:off x="594360" y="3044952"/>
-            <a:ext cx="2377440" cy="621792"/>
-          </a:xfrm>
-          <a:prstGeom prst="rect">
-            <a:avLst/>
-          </a:prstGeom>
-          <a:noFill/>
-          <a:ln/>
-        </p:spPr>
-        <p:txBody>
-          <a:bodyPr wrap="square" lIns="0" tIns="0" rIns="0" bIns="0" rtlCol="0" anchor="t"/>
-          <a:lstStyle/>
-          <a:p>
-            <a:pPr indent="0" marL="0">
-              <a:buNone/>
-            </a:pPr>
-            <a:r>
-              <a:rPr lang="en-US" sz="1050" dirty="0">
-                <a:solidFill>
-                  <a:schemeClr val="tx1"/>
-                </a:solidFill>
-              </a:rPr>
-              <a:t>We call the client before the client knows it needs help. Reactive work becomes proactive outreach.</a:t>
-            </a:r>
-            <a:endParaRPr lang="en-US" sz="1050" dirty="0"/>
-          </a:p>
-        </p:txBody>
-      </p:sp>
-      <p:sp>
-        <p:nvSpPr>
-          <p:cNvPr id="12" name="Client risk radar What it needs label"/>
-          <p:cNvSpPr txBox="1"/>
-          <p:nvPr/>
-        </p:nvSpPr>
-        <p:spPr>
-          <a:xfrm>
-            <a:off x="594360" y="3703320"/>
-            <a:ext cx="2377440" cy="201168"/>
-          </a:xfrm>
-          <a:prstGeom prst="rect">
-            <a:avLst/>
-          </a:prstGeom>
-          <a:noFill/>
-          <a:ln/>
-        </p:spPr>
-        <p:txBody>
-          <a:bodyPr wrap="square" lIns="0" tIns="0" rIns="0" bIns="0" rtlCol="0" anchor="ctr"/>
-          <a:lstStyle/>
-          <a:p>
-            <a:pPr indent="0" marL="0">
-              <a:buNone/>
-            </a:pPr>
-            <a:r>
-              <a:rPr lang="en-US" sz="950" b="1" dirty="0">
-                <a:solidFill>
-                  <a:schemeClr val="accent5"/>
-                </a:solidFill>
-              </a:rPr>
-              <a:t>What it needs</a:t>
-            </a:r>
-            <a:endParaRPr lang="en-US" sz="950" dirty="0"/>
-          </a:p>
-        </p:txBody>
-      </p:sp>
-      <p:sp>
-        <p:nvSpPr>
-          <p:cNvPr id="13" name="Client risk radar What it needs"/>
-          <p:cNvSpPr txBox="1"/>
-          <p:nvPr/>
-        </p:nvSpPr>
-        <p:spPr>
-          <a:xfrm>
-            <a:off x="594360" y="3904488"/>
-            <a:ext cx="2377440" cy="621792"/>
-          </a:xfrm>
-          <a:prstGeom prst="rect">
-            <a:avLst/>
-          </a:prstGeom>
-          <a:noFill/>
-          <a:ln/>
-        </p:spPr>
-        <p:txBody>
-          <a:bodyPr wrap="square" lIns="0" tIns="0" rIns="0" bIns="0" rtlCol="0" anchor="t"/>
-          <a:lstStyle/>
-          <a:p>
-            <a:pPr indent="0" marL="0">
-              <a:buNone/>
-            </a:pPr>
-            <a:r>
-              <a:rPr lang="en-US" sz="1050" dirty="0">
-                <a:solidFill>
-                  <a:schemeClr val="tx1"/>
-                </a:solidFill>
-              </a:rPr>
-              <a:t>A client list, public sources, and a review step before any outreach.</a:t>
-            </a:r>
-            <a:endParaRPr lang="en-US" sz="1050" dirty="0"/>
-          </a:p>
-        </p:txBody>
-      </p:sp>
-      <p:sp>
-        <p:nvSpPr>
-          <p:cNvPr id="14" name="Institutional knowledge engine card"/>
+              <a:t>We call the client before they know they need help.</a:t>
+            </a:r>
+            <a:endParaRPr lang="en-US" sz="1200" dirty="0"/>
+          </a:p>
+        </p:txBody>
+      </p:sp>
+      <p:sp>
+        <p:nvSpPr>
+          <p:cNvPr id="10" name="Firm knowledge engine card"/>
           <p:cNvSpPr/>
           <p:nvPr/>
         </p:nvSpPr>
         <p:spPr>
           <a:xfrm>
             <a:off x="3291840" y="1325880"/>
-            <a:ext cx="2651760" cy="3246120"/>
+            <a:ext cx="2651760" cy="2743200"/>
           </a:xfrm>
           <a:prstGeom prst="rect">
             <a:avLst/>
@@ -4164,7 +3843,7 @@
       </p:sp>
       <p:sp>
         <p:nvSpPr>
-          <p:cNvPr id="15" name="icon square"/>
+          <p:cNvPr id="11" name="icon square"/>
           <p:cNvSpPr/>
           <p:nvPr/>
         </p:nvSpPr>
@@ -4189,7 +3868,7 @@
       </p:sp>
       <p:pic>
         <p:nvPicPr>
-          <p:cNvPr id="16" name="search icon" descr="preencoded.png">    </p:cNvPr>
+          <p:cNvPr id="12" name="search icon" descr="preencoded.png">    </p:cNvPr>
           <p:cNvPicPr>
             <a:picLocks noChangeAspect="1"/>
           </p:cNvPicPr>
@@ -4213,7 +3892,7 @@
       </p:pic>
       <p:sp>
         <p:nvSpPr>
-          <p:cNvPr id="17" name="Institutional knowledge engine name"/>
+          <p:cNvPr id="13" name="Firm knowledge engine name"/>
           <p:cNvSpPr txBox="1"/>
           <p:nvPr/>
         </p:nvSpPr>
@@ -4241,7 +3920,7 @@
                   <a:schemeClr val="tx1"/>
                 </a:solidFill>
               </a:rPr>
-              <a:t>Institutional knowledge engine</a:t>
+              <a:t>Firm knowledge engine</a:t>
             </a:r>
             <a:endParaRPr lang="en-US" sz="1400" dirty="0"/>
           </a:p>
@@ -4249,230 +3928,97 @@
       </p:sp>
       <p:sp>
         <p:nvSpPr>
-          <p:cNvPr id="18" name="Institutional knowledge engine What it is label"/>
-          <p:cNvSpPr txBox="1"/>
-          <p:nvPr/>
-        </p:nvSpPr>
-        <p:spPr>
-          <a:xfrm>
-            <a:off x="3429000" y="1984248"/>
-            <a:ext cx="2377440" cy="201168"/>
-          </a:xfrm>
-          <a:prstGeom prst="rect">
-            <a:avLst/>
-          </a:prstGeom>
-          <a:noFill/>
-          <a:ln/>
-        </p:spPr>
-        <p:txBody>
-          <a:bodyPr wrap="square" lIns="0" tIns="0" rIns="0" bIns="0" rtlCol="0" anchor="ctr"/>
-          <a:lstStyle/>
-          <a:p>
-            <a:pPr indent="0" marL="0">
-              <a:buNone/>
-            </a:pPr>
-            <a:r>
-              <a:rPr lang="en-US" sz="950" b="1" dirty="0">
+          <p:cNvPr id="14" name="Firm knowledge engine what"/>
+          <p:cNvSpPr txBox="1"/>
+          <p:nvPr/>
+        </p:nvSpPr>
+        <p:spPr>
+          <a:xfrm>
+            <a:off x="3429000" y="2011680"/>
+            <a:ext cx="2377440" cy="1188720"/>
+          </a:xfrm>
+          <a:prstGeom prst="rect">
+            <a:avLst/>
+          </a:prstGeom>
+          <a:noFill/>
+          <a:ln/>
+        </p:spPr>
+        <p:txBody>
+          <a:bodyPr wrap="square" lIns="0" tIns="0" rIns="0" bIns="0" rtlCol="0" anchor="t"/>
+          <a:lstStyle/>
+          <a:p>
+            <a:pPr indent="0" marL="0">
+              <a:buNone/>
+            </a:pPr>
+            <a:r>
+              <a:rPr lang="en-US" sz="1250" dirty="0">
+                <a:solidFill>
+                  <a:schemeClr val="tx1"/>
+                </a:solidFill>
+              </a:rPr>
+              <a:t>Ask "who here has handled this?" or "how did we argue this before?" and get an answer from our own files.</a:t>
+            </a:r>
+            <a:endParaRPr lang="en-US" sz="1250" dirty="0"/>
+          </a:p>
+        </p:txBody>
+      </p:sp>
+      <p:sp>
+        <p:nvSpPr>
+          <p:cNvPr id="15" name="Firm knowledge engine why"/>
+          <p:cNvSpPr txBox="1"/>
+          <p:nvPr/>
+        </p:nvSpPr>
+        <p:spPr>
+          <a:xfrm>
+            <a:off x="3429000" y="3154680"/>
+            <a:ext cx="2377440" cy="822960"/>
+          </a:xfrm>
+          <a:prstGeom prst="rect">
+            <a:avLst/>
+          </a:prstGeom>
+          <a:noFill/>
+          <a:ln/>
+        </p:spPr>
+        <p:txBody>
+          <a:bodyPr wrap="square" lIns="0" tIns="0" rIns="0" bIns="0" rtlCol="0" anchor="t"/>
+          <a:lstStyle/>
+          <a:p>
+            <a:pPr indent="0" marL="0">
+              <a:buNone/>
+            </a:pPr>
+            <a:r>
+              <a:rPr lang="en-US" sz="1200" b="1" dirty="0">
                 <a:solidFill>
                   <a:schemeClr val="accent5"/>
                 </a:solidFill>
               </a:rPr>
-              <a:t>What it is</a:t>
-            </a:r>
-            <a:endParaRPr lang="en-US" sz="950" dirty="0"/>
-          </a:p>
-        </p:txBody>
-      </p:sp>
-      <p:sp>
-        <p:nvSpPr>
-          <p:cNvPr id="19" name="Institutional knowledge engine What it is"/>
-          <p:cNvSpPr txBox="1"/>
-          <p:nvPr/>
-        </p:nvSpPr>
-        <p:spPr>
-          <a:xfrm>
-            <a:off x="3429000" y="2185416"/>
-            <a:ext cx="2377440" cy="621792"/>
-          </a:xfrm>
-          <a:prstGeom prst="rect">
-            <a:avLst/>
-          </a:prstGeom>
-          <a:noFill/>
-          <a:ln/>
-        </p:spPr>
-        <p:txBody>
-          <a:bodyPr wrap="square" lIns="0" tIns="0" rIns="0" bIns="0" rtlCol="0" anchor="t"/>
-          <a:lstStyle/>
-          <a:p>
-            <a:pPr indent="0" marL="0">
-              <a:buNone/>
-            </a:pPr>
-            <a:r>
-              <a:rPr lang="en-US" sz="1050" dirty="0">
+              <a:t>Why it matters: </a:t>
+            </a:r>
+            <a:pPr indent="0" marL="0">
+              <a:buNone/>
+            </a:pPr>
+            <a:r>
+              <a:rPr lang="en-US" sz="1200" dirty="0">
                 <a:solidFill>
                   <a:schemeClr val="tx1"/>
                 </a:solidFill>
               </a:rPr>
-              <a:t>Attorneys ask "who here has handled this kind of matter?" or "how did we argue this before?" and get an answer from the firm's own files.</a:t>
-            </a:r>
-            <a:endParaRPr lang="en-US" sz="1050" dirty="0"/>
-          </a:p>
-        </p:txBody>
-      </p:sp>
-      <p:sp>
-        <p:nvSpPr>
-          <p:cNvPr id="20" name="Institutional knowledge engine Why it matters label"/>
-          <p:cNvSpPr txBox="1"/>
-          <p:nvPr/>
-        </p:nvSpPr>
-        <p:spPr>
-          <a:xfrm>
-            <a:off x="3429000" y="2843784"/>
-            <a:ext cx="2377440" cy="201168"/>
-          </a:xfrm>
-          <a:prstGeom prst="rect">
-            <a:avLst/>
-          </a:prstGeom>
-          <a:noFill/>
-          <a:ln/>
-        </p:spPr>
-        <p:txBody>
-          <a:bodyPr wrap="square" lIns="0" tIns="0" rIns="0" bIns="0" rtlCol="0" anchor="ctr"/>
-          <a:lstStyle/>
-          <a:p>
-            <a:pPr indent="0" marL="0">
-              <a:buNone/>
-            </a:pPr>
-            <a:r>
-              <a:rPr lang="en-US" sz="950" b="1" dirty="0">
-                <a:solidFill>
-                  <a:schemeClr val="accent5"/>
-                </a:solidFill>
-              </a:rPr>
-              <a:t>Why it matters</a:t>
-            </a:r>
-            <a:endParaRPr lang="en-US" sz="950" dirty="0"/>
-          </a:p>
-        </p:txBody>
-      </p:sp>
-      <p:sp>
-        <p:nvSpPr>
-          <p:cNvPr id="21" name="Institutional knowledge engine Why it matters"/>
-          <p:cNvSpPr txBox="1"/>
-          <p:nvPr/>
-        </p:nvSpPr>
-        <p:spPr>
-          <a:xfrm>
-            <a:off x="3429000" y="3044952"/>
-            <a:ext cx="2377440" cy="621792"/>
-          </a:xfrm>
-          <a:prstGeom prst="rect">
-            <a:avLst/>
-          </a:prstGeom>
-          <a:noFill/>
-          <a:ln/>
-        </p:spPr>
-        <p:txBody>
-          <a:bodyPr wrap="square" lIns="0" tIns="0" rIns="0" bIns="0" rtlCol="0" anchor="t"/>
-          <a:lstStyle/>
-          <a:p>
-            <a:pPr indent="0" marL="0">
-              <a:buNone/>
-            </a:pPr>
-            <a:r>
-              <a:rPr lang="en-US" sz="1050" dirty="0">
-                <a:solidFill>
-                  <a:schemeClr val="tx1"/>
-                </a:solidFill>
-              </a:rPr>
-              <a:t>Captures expertise before senior partners retire. New attorneys ramp faster.</a:t>
-            </a:r>
-            <a:endParaRPr lang="en-US" sz="1050" dirty="0"/>
-          </a:p>
-        </p:txBody>
-      </p:sp>
-      <p:sp>
-        <p:nvSpPr>
-          <p:cNvPr id="22" name="Institutional knowledge engine What it needs label"/>
-          <p:cNvSpPr txBox="1"/>
-          <p:nvPr/>
-        </p:nvSpPr>
-        <p:spPr>
-          <a:xfrm>
-            <a:off x="3429000" y="3703320"/>
-            <a:ext cx="2377440" cy="201168"/>
-          </a:xfrm>
-          <a:prstGeom prst="rect">
-            <a:avLst/>
-          </a:prstGeom>
-          <a:noFill/>
-          <a:ln/>
-        </p:spPr>
-        <p:txBody>
-          <a:bodyPr wrap="square" lIns="0" tIns="0" rIns="0" bIns="0" rtlCol="0" anchor="ctr"/>
-          <a:lstStyle/>
-          <a:p>
-            <a:pPr indent="0" marL="0">
-              <a:buNone/>
-            </a:pPr>
-            <a:r>
-              <a:rPr lang="en-US" sz="950" b="1" dirty="0">
-                <a:solidFill>
-                  <a:schemeClr val="accent5"/>
-                </a:solidFill>
-              </a:rPr>
-              <a:t>What it needs</a:t>
-            </a:r>
-            <a:endParaRPr lang="en-US" sz="950" dirty="0"/>
-          </a:p>
-        </p:txBody>
-      </p:sp>
-      <p:sp>
-        <p:nvSpPr>
-          <p:cNvPr id="23" name="Institutional knowledge engine What it needs"/>
-          <p:cNvSpPr txBox="1"/>
-          <p:nvPr/>
-        </p:nvSpPr>
-        <p:spPr>
-          <a:xfrm>
-            <a:off x="3429000" y="3904488"/>
-            <a:ext cx="2377440" cy="621792"/>
-          </a:xfrm>
-          <a:prstGeom prst="rect">
-            <a:avLst/>
-          </a:prstGeom>
-          <a:noFill/>
-          <a:ln/>
-        </p:spPr>
-        <p:txBody>
-          <a:bodyPr wrap="square" lIns="0" tIns="0" rIns="0" bIns="0" rtlCol="0" anchor="t"/>
-          <a:lstStyle/>
-          <a:p>
-            <a:pPr indent="0" marL="0">
-              <a:buNone/>
-            </a:pPr>
-            <a:r>
-              <a:rPr lang="en-US" sz="1050" dirty="0">
-                <a:solidFill>
-                  <a:schemeClr val="tx1"/>
-                </a:solidFill>
-              </a:rPr>
-              <a:t>Document system access that respects ethical walls and permissions. Already built into LexAtlas and Skippy on slide 1.</a:t>
-            </a:r>
-            <a:endParaRPr lang="en-US" sz="1050" dirty="0"/>
-          </a:p>
-        </p:txBody>
-      </p:sp>
-      <p:sp>
-        <p:nvSpPr>
-          <p:cNvPr id="24" name="Ask the matter card"/>
+              <a:t>Keeps expertise when senior partners retire.</a:t>
+            </a:r>
+            <a:endParaRPr lang="en-US" sz="1200" dirty="0"/>
+          </a:p>
+        </p:txBody>
+      </p:sp>
+      <p:sp>
+        <p:nvSpPr>
+          <p:cNvPr id="16" name="Ask the matter card"/>
           <p:cNvSpPr/>
           <p:nvPr/>
         </p:nvSpPr>
         <p:spPr>
           <a:xfrm>
             <a:off x="6126480" y="1325880"/>
-            <a:ext cx="2651760" cy="3246120"/>
+            <a:ext cx="2651760" cy="2743200"/>
           </a:xfrm>
           <a:prstGeom prst="rect">
             <a:avLst/>
@@ -4490,7 +4036,7 @@
       </p:sp>
       <p:sp>
         <p:nvSpPr>
-          <p:cNvPr id="25" name="icon square"/>
+          <p:cNvPr id="17" name="icon square"/>
           <p:cNvSpPr/>
           <p:nvPr/>
         </p:nvSpPr>
@@ -4515,7 +4061,7 @@
       </p:sp>
       <p:pic>
         <p:nvPicPr>
-          <p:cNvPr id="26" name="msg icon" descr="preencoded.png">    </p:cNvPr>
+          <p:cNvPr id="18" name="msg icon" descr="preencoded.png">    </p:cNvPr>
           <p:cNvPicPr>
             <a:picLocks noChangeAspect="1"/>
           </p:cNvPicPr>
@@ -4539,7 +4085,7 @@
       </p:pic>
       <p:sp>
         <p:nvSpPr>
-          <p:cNvPr id="27" name="Ask the matter name"/>
+          <p:cNvPr id="19" name="Ask the matter name"/>
           <p:cNvSpPr txBox="1"/>
           <p:nvPr/>
         </p:nvSpPr>
@@ -4575,253 +4121,84 @@
       </p:sp>
       <p:sp>
         <p:nvSpPr>
-          <p:cNvPr id="28" name="Ask the matter What it is label"/>
-          <p:cNvSpPr txBox="1"/>
-          <p:nvPr/>
-        </p:nvSpPr>
-        <p:spPr>
-          <a:xfrm>
-            <a:off x="6263640" y="1984248"/>
-            <a:ext cx="2377440" cy="201168"/>
-          </a:xfrm>
-          <a:prstGeom prst="rect">
-            <a:avLst/>
-          </a:prstGeom>
-          <a:noFill/>
-          <a:ln/>
-        </p:spPr>
-        <p:txBody>
-          <a:bodyPr wrap="square" lIns="0" tIns="0" rIns="0" bIns="0" rtlCol="0" anchor="ctr"/>
-          <a:lstStyle/>
-          <a:p>
-            <a:pPr indent="0" marL="0">
-              <a:buNone/>
-            </a:pPr>
-            <a:r>
-              <a:rPr lang="en-US" sz="950" b="1" dirty="0">
+          <p:cNvPr id="20" name="Ask the matter what"/>
+          <p:cNvSpPr txBox="1"/>
+          <p:nvPr/>
+        </p:nvSpPr>
+        <p:spPr>
+          <a:xfrm>
+            <a:off x="6263640" y="2011680"/>
+            <a:ext cx="2377440" cy="1188720"/>
+          </a:xfrm>
+          <a:prstGeom prst="rect">
+            <a:avLst/>
+          </a:prstGeom>
+          <a:noFill/>
+          <a:ln/>
+        </p:spPr>
+        <p:txBody>
+          <a:bodyPr wrap="square" lIns="0" tIns="0" rIns="0" bIns="0" rtlCol="0" anchor="t"/>
+          <a:lstStyle/>
+          <a:p>
+            <a:pPr indent="0" marL="0">
+              <a:buNone/>
+            </a:pPr>
+            <a:r>
+              <a:rPr lang="en-US" sz="1250" dirty="0">
+                <a:solidFill>
+                  <a:schemeClr val="tx1"/>
+                </a:solidFill>
+              </a:rPr>
+              <a:t>Questions over one matter's files, every answer cited to the page.</a:t>
+            </a:r>
+            <a:endParaRPr lang="en-US" sz="1250" dirty="0"/>
+          </a:p>
+        </p:txBody>
+      </p:sp>
+      <p:sp>
+        <p:nvSpPr>
+          <p:cNvPr id="21" name="Ask the matter why"/>
+          <p:cNvSpPr txBox="1"/>
+          <p:nvPr/>
+        </p:nvSpPr>
+        <p:spPr>
+          <a:xfrm>
+            <a:off x="6263640" y="3154680"/>
+            <a:ext cx="2377440" cy="822960"/>
+          </a:xfrm>
+          <a:prstGeom prst="rect">
+            <a:avLst/>
+          </a:prstGeom>
+          <a:noFill/>
+          <a:ln/>
+        </p:spPr>
+        <p:txBody>
+          <a:bodyPr wrap="square" lIns="0" tIns="0" rIns="0" bIns="0" rtlCol="0" anchor="t"/>
+          <a:lstStyle/>
+          <a:p>
+            <a:pPr indent="0" marL="0">
+              <a:buNone/>
+            </a:pPr>
+            <a:r>
+              <a:rPr lang="en-US" sz="1200" b="1" dirty="0">
                 <a:solidFill>
                   <a:schemeClr val="accent5"/>
                 </a:solidFill>
               </a:rPr>
-              <a:t>What it is</a:t>
-            </a:r>
-            <a:endParaRPr lang="en-US" sz="950" dirty="0"/>
-          </a:p>
-        </p:txBody>
-      </p:sp>
-      <p:sp>
-        <p:nvSpPr>
-          <p:cNvPr id="29" name="Ask the matter What it is"/>
-          <p:cNvSpPr txBox="1"/>
-          <p:nvPr/>
-        </p:nvSpPr>
-        <p:spPr>
-          <a:xfrm>
-            <a:off x="6263640" y="2185416"/>
-            <a:ext cx="2377440" cy="621792"/>
-          </a:xfrm>
-          <a:prstGeom prst="rect">
-            <a:avLst/>
-          </a:prstGeom>
-          <a:noFill/>
-          <a:ln/>
-        </p:spPr>
-        <p:txBody>
-          <a:bodyPr wrap="square" lIns="0" tIns="0" rIns="0" bIns="0" rtlCol="0" anchor="t"/>
-          <a:lstStyle/>
-          <a:p>
-            <a:pPr indent="0" marL="0">
-              <a:buNone/>
-            </a:pPr>
-            <a:r>
-              <a:rPr lang="en-US" sz="1050" dirty="0">
+              <a:t>Why it matters: </a:t>
+            </a:r>
+            <a:pPr indent="0" marL="0">
+              <a:buNone/>
+            </a:pPr>
+            <a:r>
+              <a:rPr lang="en-US" sz="1200" dirty="0">
                 <a:solidFill>
                   <a:schemeClr val="tx1"/>
                 </a:solidFill>
               </a:rPr>
-              <a:t>A secure question-and-answer tool over one matter's files, with every answer cited to the page.</a:t>
-            </a:r>
-            <a:endParaRPr lang="en-US" sz="1050" dirty="0"/>
-          </a:p>
-        </p:txBody>
-      </p:sp>
-      <p:sp>
-        <p:nvSpPr>
-          <p:cNvPr id="30" name="Ask the matter Why it matters label"/>
-          <p:cNvSpPr txBox="1"/>
-          <p:nvPr/>
-        </p:nvSpPr>
-        <p:spPr>
-          <a:xfrm>
-            <a:off x="6263640" y="2843784"/>
-            <a:ext cx="2377440" cy="201168"/>
-          </a:xfrm>
-          <a:prstGeom prst="rect">
-            <a:avLst/>
-          </a:prstGeom>
-          <a:noFill/>
-          <a:ln/>
-        </p:spPr>
-        <p:txBody>
-          <a:bodyPr wrap="square" lIns="0" tIns="0" rIns="0" bIns="0" rtlCol="0" anchor="ctr"/>
-          <a:lstStyle/>
-          <a:p>
-            <a:pPr indent="0" marL="0">
-              <a:buNone/>
-            </a:pPr>
-            <a:r>
-              <a:rPr lang="en-US" sz="950" b="1" dirty="0">
-                <a:solidFill>
-                  <a:schemeClr val="accent5"/>
-                </a:solidFill>
-              </a:rPr>
-              <a:t>Why it matters</a:t>
-            </a:r>
-            <a:endParaRPr lang="en-US" sz="950" dirty="0"/>
-          </a:p>
-        </p:txBody>
-      </p:sp>
-      <p:sp>
-        <p:nvSpPr>
-          <p:cNvPr id="31" name="Ask the matter Why it matters"/>
-          <p:cNvSpPr txBox="1"/>
-          <p:nvPr/>
-        </p:nvSpPr>
-        <p:spPr>
-          <a:xfrm>
-            <a:off x="6263640" y="3044952"/>
-            <a:ext cx="2377440" cy="621792"/>
-          </a:xfrm>
-          <a:prstGeom prst="rect">
-            <a:avLst/>
-          </a:prstGeom>
-          <a:noFill/>
-          <a:ln/>
-        </p:spPr>
-        <p:txBody>
-          <a:bodyPr wrap="square" lIns="0" tIns="0" rIns="0" bIns="0" rtlCol="0" anchor="t"/>
-          <a:lstStyle/>
-          <a:p>
-            <a:pPr indent="0" marL="0">
-              <a:buNone/>
-            </a:pPr>
-            <a:r>
-              <a:rPr lang="en-US" sz="1050" dirty="0">
-                <a:solidFill>
-                  <a:schemeClr val="tx1"/>
-                </a:solidFill>
-              </a:rPr>
-              <a:t>The first step toward the knowledge engine, scoped to one matter so the risk is contained.</a:t>
-            </a:r>
-            <a:endParaRPr lang="en-US" sz="1050" dirty="0"/>
-          </a:p>
-        </p:txBody>
-      </p:sp>
-      <p:sp>
-        <p:nvSpPr>
-          <p:cNvPr id="32" name="Ask the matter What it needs label"/>
-          <p:cNvSpPr txBox="1"/>
-          <p:nvPr/>
-        </p:nvSpPr>
-        <p:spPr>
-          <a:xfrm>
-            <a:off x="6263640" y="3703320"/>
-            <a:ext cx="2377440" cy="201168"/>
-          </a:xfrm>
-          <a:prstGeom prst="rect">
-            <a:avLst/>
-          </a:prstGeom>
-          <a:noFill/>
-          <a:ln/>
-        </p:spPr>
-        <p:txBody>
-          <a:bodyPr wrap="square" lIns="0" tIns="0" rIns="0" bIns="0" rtlCol="0" anchor="ctr"/>
-          <a:lstStyle/>
-          <a:p>
-            <a:pPr indent="0" marL="0">
-              <a:buNone/>
-            </a:pPr>
-            <a:r>
-              <a:rPr lang="en-US" sz="950" b="1" dirty="0">
-                <a:solidFill>
-                  <a:schemeClr val="accent5"/>
-                </a:solidFill>
-              </a:rPr>
-              <a:t>What it needs</a:t>
-            </a:r>
-            <a:endParaRPr lang="en-US" sz="950" dirty="0"/>
-          </a:p>
-        </p:txBody>
-      </p:sp>
-      <p:sp>
-        <p:nvSpPr>
-          <p:cNvPr id="33" name="Ask the matter What it needs"/>
-          <p:cNvSpPr txBox="1"/>
-          <p:nvPr/>
-        </p:nvSpPr>
-        <p:spPr>
-          <a:xfrm>
-            <a:off x="6263640" y="3904488"/>
-            <a:ext cx="2377440" cy="621792"/>
-          </a:xfrm>
-          <a:prstGeom prst="rect">
-            <a:avLst/>
-          </a:prstGeom>
-          <a:noFill/>
-          <a:ln/>
-        </p:spPr>
-        <p:txBody>
-          <a:bodyPr wrap="square" lIns="0" tIns="0" rIns="0" bIns="0" rtlCol="0" anchor="t"/>
-          <a:lstStyle/>
-          <a:p>
-            <a:pPr indent="0" marL="0">
-              <a:buNone/>
-            </a:pPr>
-            <a:r>
-              <a:rPr lang="en-US" sz="1050" dirty="0">
-                <a:solidFill>
-                  <a:schemeClr val="tx1"/>
-                </a:solidFill>
-              </a:rPr>
-              <a:t>One matter's files and a pilot team.</a:t>
-            </a:r>
-            <a:endParaRPr lang="en-US" sz="1050" dirty="0"/>
-          </a:p>
-        </p:txBody>
-      </p:sp>
-      <p:sp>
-        <p:nvSpPr>
-          <p:cNvPr id="34" name="fourth project note"/>
-          <p:cNvSpPr txBox="1"/>
-          <p:nvPr/>
-        </p:nvSpPr>
-        <p:spPr>
-          <a:xfrm>
-            <a:off x="457200" y="4617720"/>
-            <a:ext cx="7863840" cy="274320"/>
-          </a:xfrm>
-          <a:prstGeom prst="rect">
-            <a:avLst/>
-          </a:prstGeom>
-          <a:noFill/>
-          <a:ln/>
-        </p:spPr>
-        <p:txBody>
-          <a:bodyPr wrap="square" lIns="0" tIns="0" rIns="0" bIns="0" rtlCol="0" anchor="ctr"/>
-          <a:lstStyle/>
-          <a:p>
-            <a:pPr indent="0" marL="0">
-              <a:buNone/>
-            </a:pPr>
-            <a:r>
-              <a:rPr lang="en-US" sz="1000" i="1" dirty="0">
-                <a:solidFill>
-                  <a:schemeClr val="tx2"/>
-                </a:solidFill>
-              </a:rPr>
-              <a:t>A fourth I have wondered about: outcome and pricing intelligence from the firm's own matter history, to support fixed-fee bids.</a:t>
-            </a:r>
-            <a:endParaRPr lang="en-US" sz="1000" dirty="0"/>
+              <a:t>A contained first step toward the knowledge engine.</a:t>
+            </a:r>
+            <a:endParaRPr lang="en-US" sz="1200" dirty="0"/>
           </a:p>
         </p:txBody>
       </p:sp>
@@ -4927,7 +4304,7 @@
                   <a:srgbClr val="2D4459"/>
                 </a:solidFill>
               </a:rPr>
-              <a:t>How I think about choosing</a:t>
+              <a:t>My filter: configure first, buy second, build last</a:t>
             </a:r>
             <a:endParaRPr lang="en-US" sz="2600" dirty="0"/>
           </a:p>
@@ -4965,7 +4342,7 @@
                   <a:schemeClr val="tx2"/>
                 </a:solidFill>
               </a:rPr>
-              <a:t>A lens I have found useful, offered for discussion. Ideas are cheap; the hard part is choosing.</a:t>
+              <a:t>A lens I have found useful, offered for discussion.</a:t>
             </a:r>
             <a:endParaRPr lang="en-US" sz="1300" dirty="0"/>
           </a:p>
@@ -5112,7 +4489,7 @@
                   <a:schemeClr val="tx2"/>
                 </a:solidFill>
               </a:rPr>
-              <a:t>Who benefits, how often, and how much work it takes.</a:t>
+              <a:t>Who benefits, and how much work it takes.</a:t>
             </a:r>
             <a:endParaRPr lang="en-US" sz="1200" dirty="0"/>
           </a:p>
@@ -5223,7 +4600,7 @@
                   <a:schemeClr val="tx2"/>
                 </a:solidFill>
               </a:rPr>
-              <a:t>Is the data clean, in one place, and allowed to be used this way?</a:t>
+              <a:t>Is the data clean, in one place, and allowed?</a:t>
             </a:r>
             <a:endParaRPr lang="en-US" sz="1200" dirty="0"/>
           </a:p>
@@ -5334,7 +4711,7 @@
                   <a:schemeClr val="tx2"/>
                 </a:solidFill>
               </a:rPr>
-              <a:t>What tier of client data it touches. Do walls, permissions and client instructions hold?</a:t>
+              <a:t>Do walls, permissions and client instructions hold?</a:t>
             </a:r>
             <a:endParaRPr lang="en-US" sz="1200" dirty="0"/>
           </a:p>
@@ -5445,7 +4822,7 @@
                   <a:schemeClr val="tx2"/>
                 </a:solidFill>
               </a:rPr>
-              <a:t>Does it fit how people already work, and does a partner want it?</a:t>
+              <a:t>Does it fit how people already work?</a:t>
             </a:r>
             <a:endParaRPr lang="en-US" sz="1200" dirty="0"/>
           </a:p>
@@ -5556,7 +4933,7 @@
                   <a:schemeClr val="tx2"/>
                 </a:solidFill>
               </a:rPr>
-              <a:t>Who maintains it, and does IT have what it needs to run it?</a:t>
+              <a:t>Who maintains it?</a:t>
             </a:r>
             <a:endParaRPr lang="en-US" sz="1200" dirty="0"/>
           </a:p>
@@ -5716,7 +5093,7 @@
                   <a:schemeClr val="tx2"/>
                 </a:solidFill>
               </a:rPr>
-              <a:t>Get more from Copilot and the document system with approved prompts and checklists.</a:t>
+              <a:t>Get more from Copilot and the document system.</a:t>
             </a:r>
             <a:endParaRPr lang="en-US" sz="1200" dirty="0"/>
           </a:p>
@@ -5840,7 +5217,7 @@
                   <a:schemeClr val="tx2"/>
                 </a:solidFill>
               </a:rPr>
-              <a:t>Where the market is mature, after vetting vendors on data use, security, walls and audit logs.</a:t>
+              <a:t>Where the market is mature and vendors pass vetting.</a:t>
             </a:r>
             <a:endParaRPr lang="en-US" sz="1200" dirty="0"/>
           </a:p>
@@ -5964,7 +5341,7 @@
                   <a:schemeClr val="tx2"/>
                 </a:solidFill>
               </a:rPr>
-              <a:t>Only where the firm's own data and ways of working are the advantage.</a:t>
+              <a:t>Only where our own data is the advantage.</a:t>
             </a:r>
             <a:endParaRPr lang="en-US" sz="1200" dirty="0"/>
           </a:p>
@@ -6036,7 +5413,7 @@
                   <a:schemeClr val="bg1"/>
                 </a:solidFill>
               </a:rPr>
-              <a:t>Infrastructure, security, vendor decisions and the final say on what goes live are IT's call. Nothing here assumes otherwise.</a:t>
+              <a:t>Infrastructure, security, vendors and what goes live are IT's call.</a:t>
             </a:r>
             <a:endParaRPr lang="en-US" sz="1050" dirty="0"/>
           </a:p>
@@ -6144,7 +5521,7 @@
                   <a:schemeClr val="bg1"/>
                 </a:solidFill>
               </a:rPr>
-              <a:t>What a rollout could look like, and a longer view</a:t>
+              <a:t>A rollout takes about two weeks</a:t>
             </a:r>
             <a:endParaRPr lang="en-US" sz="2600" dirty="0"/>
           </a:p>
@@ -6182,7 +5559,7 @@
                   <a:schemeClr val="accent3"/>
                 </a:solidFill>
               </a:rPr>
-              <a:t>One example, the guidelines brief, as I picture it: about two weeks, nothing new to host.</a:t>
+              <a:t>One example, the client guidelines brief, as I picture it. Nothing new to host.</a:t>
             </a:r>
             <a:endParaRPr lang="en-US" sz="1300" dirty="0"/>
           </a:p>
@@ -6371,14 +5748,14 @@
               <a:buNone/>
             </a:pPr>
             <a:r>
-              <a:rPr lang="en-US" sz="950" dirty="0">
+              <a:rPr lang="en-US" sz="1050" dirty="0">
                 <a:solidFill>
                   <a:schemeClr val="accent3"/>
                 </a:solidFill>
               </a:rPr>
-              <a:t>Pull each client's outside counsel guidelines from the document system. They already exist.</a:t>
-            </a:r>
-            <a:endParaRPr lang="en-US" sz="950" dirty="0"/>
+              <a:t>The client guidelines are already in the document system.</a:t>
+            </a:r>
+            <a:endParaRPr lang="en-US" sz="1050" dirty="0"/>
           </a:p>
         </p:txBody>
       </p:sp>
@@ -6589,14 +5966,14 @@
               <a:buNone/>
             </a:pPr>
             <a:r>
-              <a:rPr lang="en-US" sz="950" dirty="0">
+              <a:rPr lang="en-US" sz="1050" dirty="0">
                 <a:solidFill>
                   <a:schemeClr val="accent3"/>
                 </a:solidFill>
               </a:rPr>
-              <a:t>The tool reads each guideline and writes a one-page brief of its billing rules, with the source paragraph behind each line.</a:t>
-            </a:r>
-            <a:endParaRPr lang="en-US" sz="950" dirty="0"/>
+              <a:t>One page of billing rules per client, each tied to its source paragraph.</a:t>
+            </a:r>
+            <a:endParaRPr lang="en-US" sz="1050" dirty="0"/>
           </a:p>
         </p:txBody>
       </p:sp>
@@ -6807,14 +6184,14 @@
               <a:buNone/>
             </a:pPr>
             <a:r>
-              <a:rPr lang="en-US" sz="950" dirty="0">
+              <a:rPr lang="en-US" sz="1050" dirty="0">
                 <a:solidFill>
                   <a:schemeClr val="accent3"/>
                 </a:solidFill>
               </a:rPr>
-              <a:t>Runs on firm hardware, no client text leaves. Sign-on, role-based access and an audit log are shown to IT in one sitting.</a:t>
-            </a:r>
-            <a:endParaRPr lang="en-US" sz="950" dirty="0"/>
+              <a:t>Runs on firm hardware. Sign-on, roles and audit log shown in one sitting.</a:t>
+            </a:r>
+            <a:endParaRPr lang="en-US" sz="1050" dirty="0"/>
           </a:p>
         </p:txBody>
       </p:sp>
@@ -7025,14 +6402,14 @@
               <a:buNone/>
             </a:pPr>
             <a:r>
-              <a:rPr lang="en-US" sz="950" dirty="0">
+              <a:rPr lang="en-US" sz="1050" dirty="0">
                 <a:solidFill>
                   <a:schemeClr val="accent3"/>
                 </a:solidFill>
               </a:rPr>
-              <a:t>One billing partner, one client's prebills. Entries that break a rule are flagged with the rule quoted. A person decides what to change.</a:t>
-            </a:r>
-            <a:endParaRPr lang="en-US" sz="950" dirty="0"/>
+              <a:t>One billing partner, one client's prebills. A person decides every change.</a:t>
+            </a:r>
+            <a:endParaRPr lang="en-US" sz="1050" dirty="0"/>
           </a:p>
         </p:txBody>
       </p:sp>
@@ -7243,14 +6620,14 @@
               <a:buNone/>
             </a:pPr>
             <a:r>
-              <a:rPr lang="en-US" sz="950" dirty="0">
+              <a:rPr lang="en-US" sz="1050" dirty="0">
                 <a:solidFill>
                   <a:schemeClr val="accent3"/>
                 </a:solidFill>
               </a:rPr>
-              <a:t>The brief sits on the matter. The flags appear in the prebill review step that already happens. Nobody learns a new program.</a:t>
-            </a:r>
-            <a:endParaRPr lang="en-US" sz="950" dirty="0"/>
+              <a:t>Flags appear in the prebill review that already happens.</a:t>
+            </a:r>
+            <a:endParaRPr lang="en-US" sz="1050" dirty="0"/>
           </a:p>
         </p:txBody>
       </p:sp>
@@ -7685,7 +7062,7 @@
                   <a:schemeClr val="bg1"/>
                 </a:solidFill>
               </a:rPr>
-              <a:t>A longer view, for discussion: one firm-owned platform</a:t>
+              <a:t>A longer view, for discussion: one firm-owned platform that touches everything</a:t>
             </a:r>
             <a:endParaRPr lang="en-US" sz="1400" dirty="0"/>
           </a:p>
@@ -7721,7 +7098,7 @@
                   <a:schemeClr val="bg1"/>
                 </a:solidFill>
               </a:rPr>
-              <a:t>An idea I keep coming back to: an in-house system that, over time, touches every file, matter and system the firm runs, with each tool here as a module of it, one set of permissions, one audit trail and models on firm hardware. The firm would own the code, the data and the roadmap. That is a long way off and leadership's call; I raise it because the quick wins can be built so they add up to it rather than stand alone.</a:t>
+              <a:t>Over time, one in-house system could touch every file, matter and system the firm runs, with each tool as a module, one set of permissions, one audit trail, and the firm owning the code and the data. That is leadership's call and a long way off. I raise it so the quick wins can be built to add up to it.</a:t>
             </a:r>
             <a:endParaRPr lang="en-US" sz="1050" dirty="0"/>
           </a:p>

</xml_diff>

<commit_message>
Refresh the downloadable slides
Co-Authored-By: Claude Opus 5.5 <noreply@anthropic.com>
Claude-Session: https://claude.ai/code/session_01PJvvaL6iM7EXiNVtK6cm1w
</commit_message>
<xml_diff>
--- a/downloads/AI-ideas-Myles-Parslow.pptx
+++ b/downloads/AI-ideas-Myles-Parslow.pptx
@@ -111,7 +111,7 @@
   <p:extLst>
     <p:ext uri="{521415D9-36F7-43E2-AB2F-B90AF26B5E84}">
       <p14:sectionLst xmlns:p14="http://schemas.microsoft.com/office/powerpoint/2010/main">
-        <p14:section name="AI for the firm" id="{6b1d20b7-4271-c322-219c-3523f9396ca3}">
+        <p14:section name="AI for the firm" id="{c95b617e-a02c-da72-5d64-599594b049e7}">
           <p14:sldIdLst>
             <p14:sldId id="256"/>
             <p14:sldId id="257"/>
@@ -1261,7 +1261,7 @@
                   <a:schemeClr val="tx2"/>
                 </a:solidFill>
               </a:rPr>
-              <a:t>Built on my own time, for nearly every part of the firm. A lawyer makes every decision.</a:t>
+              <a:t>Built in my free time with invented clients. Orange marks the three that could be used right away.</a:t>
             </a:r>
             <a:endParaRPr lang="en-US" sz="1300" dirty="0"/>
           </a:p>
@@ -1269,75 +1269,50 @@
       </p:sp>
       <p:sp>
         <p:nvSpPr>
-          <p:cNvPr id="4" name="Conflicts and intake column"/>
-          <p:cNvSpPr/>
+          <p:cNvPr id="4" name="Conflicts and intake heading"/>
+          <p:cNvSpPr txBox="1"/>
           <p:nvPr/>
         </p:nvSpPr>
         <p:spPr>
           <a:xfrm>
             <a:off x="457200" y="1188720"/>
-            <a:ext cx="1572768" cy="3127248"/>
-          </a:xfrm>
-          <a:prstGeom prst="rect">
-            <a:avLst/>
-          </a:prstGeom>
-          <a:solidFill>
-            <a:schemeClr val="bg2"/>
-          </a:solidFill>
-          <a:ln w="12700">
-            <a:solidFill>
-              <a:schemeClr val="bg2"/>
-            </a:solidFill>
-            <a:prstDash val="solid"/>
-          </a:ln>
-        </p:spPr>
-      </p:sp>
-      <p:sp>
-        <p:nvSpPr>
-          <p:cNvPr id="5" name="Conflicts and intake heading"/>
-          <p:cNvSpPr txBox="1"/>
-          <p:nvPr/>
-        </p:nvSpPr>
-        <p:spPr>
-          <a:xfrm>
-            <a:off x="548640" y="1243584"/>
-            <a:ext cx="1389888" cy="365760"/>
-          </a:xfrm>
-          <a:prstGeom prst="rect">
-            <a:avLst/>
-          </a:prstGeom>
-          <a:noFill/>
-          <a:ln/>
-        </p:spPr>
-        <p:txBody>
-          <a:bodyPr wrap="square" lIns="0" tIns="0" rIns="0" bIns="0" rtlCol="0" anchor="ctr"/>
-          <a:lstStyle/>
-          <a:p>
-            <a:pPr indent="0" marL="0">
-              <a:buNone/>
-            </a:pPr>
-            <a:r>
-              <a:rPr lang="en-US" sz="1100" b="1" dirty="0">
+            <a:ext cx="4023360" cy="219456"/>
+          </a:xfrm>
+          <a:prstGeom prst="rect">
+            <a:avLst/>
+          </a:prstGeom>
+          <a:noFill/>
+          <a:ln/>
+        </p:spPr>
+        <p:txBody>
+          <a:bodyPr wrap="square" lIns="0" tIns="0" rIns="0" bIns="0" rtlCol="0" anchor="b"/>
+          <a:lstStyle/>
+          <a:p>
+            <a:pPr indent="0" marL="0">
+              <a:buNone/>
+            </a:pPr>
+            <a:r>
+              <a:rPr lang="en-US" sz="900" b="1" spc="150" kern="0" dirty="0">
                 <a:solidFill>
                   <a:schemeClr val="accent5"/>
                 </a:solidFill>
               </a:rPr>
-              <a:t>Conflicts and intake</a:t>
-            </a:r>
-            <a:endParaRPr lang="en-US" sz="1100" dirty="0"/>
-          </a:p>
-        </p:txBody>
-      </p:sp>
-      <p:sp>
-        <p:nvSpPr>
-          <p:cNvPr id="6" name="Conflion entry"/>
-          <p:cNvSpPr txBox="1"/>
-          <p:nvPr/>
-        </p:nvSpPr>
-        <p:spPr>
-          <a:xfrm>
-            <a:off x="548640" y="1682496"/>
-            <a:ext cx="1389888" cy="603504"/>
+              <a:t>CONFLICTS AND INTAKE</a:t>
+            </a:r>
+            <a:endParaRPr lang="en-US" sz="900" dirty="0"/>
+          </a:p>
+        </p:txBody>
+      </p:sp>
+      <p:sp>
+        <p:nvSpPr>
+          <p:cNvPr id="5" name="Conflion name"/>
+          <p:cNvSpPr txBox="1"/>
+          <p:nvPr/>
+        </p:nvSpPr>
+        <p:spPr>
+          <a:xfrm>
+            <a:off x="457200" y="1435608"/>
+            <a:ext cx="1188720" cy="365760"/>
           </a:xfrm>
           <a:prstGeom prst="rect">
             <a:avLst/>
@@ -1353,41 +1328,27 @@
               <a:buNone/>
             </a:pPr>
             <a:r>
-              <a:rPr lang="en-US" sz="1200" b="1" dirty="0">
+              <a:rPr lang="en-US" sz="1050" b="1" dirty="0">
                 <a:solidFill>
                   <a:schemeClr val="tx1"/>
                 </a:solidFill>
               </a:rPr>
               <a:t>Conflion</a:t>
             </a:r>
-            <a:endParaRPr lang="en-US" sz="1200" dirty="0"/>
-          </a:p>
-          <a:p>
-            <a:pPr indent="0" marL="0">
-              <a:buNone/>
-            </a:pPr>
-            <a:r>
-              <a:rPr lang="en-US" sz="1000" dirty="0">
-                <a:solidFill>
-                  <a:schemeClr val="tx2"/>
-                </a:solidFill>
-              </a:rPr>
-              <a:t>Conflicts check and intake</a:t>
-            </a:r>
-            <a:endParaRPr lang="en-US" sz="1200" dirty="0"/>
-          </a:p>
-        </p:txBody>
-      </p:sp>
-      <p:sp>
-        <p:nvSpPr>
-          <p:cNvPr id="7" name="Party Finder entry"/>
-          <p:cNvSpPr txBox="1"/>
-          <p:nvPr/>
-        </p:nvSpPr>
-        <p:spPr>
-          <a:xfrm>
-            <a:off x="548640" y="2322576"/>
-            <a:ext cx="1389888" cy="603504"/>
+            <a:endParaRPr lang="en-US" sz="1050" dirty="0"/>
+          </a:p>
+        </p:txBody>
+      </p:sp>
+      <p:sp>
+        <p:nvSpPr>
+          <p:cNvPr id="6" name="Conflion line"/>
+          <p:cNvSpPr txBox="1"/>
+          <p:nvPr/>
+        </p:nvSpPr>
+        <p:spPr>
+          <a:xfrm>
+            <a:off x="1691640" y="1435608"/>
+            <a:ext cx="2788920" cy="365760"/>
           </a:xfrm>
           <a:prstGeom prst="rect">
             <a:avLst/>
@@ -1403,41 +1364,63 @@
               <a:buNone/>
             </a:pPr>
             <a:r>
-              <a:rPr lang="en-US" sz="1200" b="1" dirty="0">
+              <a:rPr lang="en-US" sz="950" dirty="0">
                 <a:solidFill>
                   <a:schemeClr val="tx1"/>
                 </a:solidFill>
               </a:rPr>
+              <a:t>Finds the conflicts a letter-for-letter search misses and routes each intake to the right approvers.</a:t>
+            </a:r>
+            <a:endParaRPr lang="en-US" sz="950" dirty="0"/>
+          </a:p>
+        </p:txBody>
+      </p:sp>
+      <p:sp>
+        <p:nvSpPr>
+          <p:cNvPr id="7" name="Party Finder name"/>
+          <p:cNvSpPr txBox="1"/>
+          <p:nvPr/>
+        </p:nvSpPr>
+        <p:spPr>
+          <a:xfrm>
+            <a:off x="457200" y="1819656"/>
+            <a:ext cx="1188720" cy="365760"/>
+          </a:xfrm>
+          <a:prstGeom prst="rect">
+            <a:avLst/>
+          </a:prstGeom>
+          <a:noFill/>
+          <a:ln/>
+        </p:spPr>
+        <p:txBody>
+          <a:bodyPr wrap="square" lIns="0" tIns="0" rIns="0" bIns="0" rtlCol="0" anchor="t"/>
+          <a:lstStyle/>
+          <a:p>
+            <a:pPr indent="0" marL="0">
+              <a:buNone/>
+            </a:pPr>
+            <a:r>
+              <a:rPr lang="en-US" sz="1050" b="1" dirty="0">
+                <a:solidFill>
+                  <a:schemeClr val="accent2"/>
+                </a:solidFill>
+              </a:rPr>
               <a:t>Party Finder</a:t>
             </a:r>
-            <a:endParaRPr lang="en-US" sz="1200" dirty="0"/>
-          </a:p>
-          <a:p>
-            <a:pPr indent="0" marL="0">
-              <a:buNone/>
-            </a:pPr>
-            <a:r>
-              <a:rPr lang="en-US" sz="1000" dirty="0">
-                <a:solidFill>
-                  <a:schemeClr val="tx2"/>
-                </a:solidFill>
-              </a:rPr>
-              <a:t>Names to search, from the documents</a:t>
-            </a:r>
-            <a:endParaRPr lang="en-US" sz="1200" dirty="0"/>
-          </a:p>
-        </p:txBody>
-      </p:sp>
-      <p:sp>
-        <p:nvSpPr>
-          <p:cNvPr id="8" name="LexAtlas entry"/>
-          <p:cNvSpPr txBox="1"/>
-          <p:nvPr/>
-        </p:nvSpPr>
-        <p:spPr>
-          <a:xfrm>
-            <a:off x="548640" y="2962656"/>
-            <a:ext cx="1389888" cy="603504"/>
+            <a:endParaRPr lang="en-US" sz="1050" dirty="0"/>
+          </a:p>
+        </p:txBody>
+      </p:sp>
+      <p:sp>
+        <p:nvSpPr>
+          <p:cNvPr id="8" name="Party Finder line"/>
+          <p:cNvSpPr txBox="1"/>
+          <p:nvPr/>
+        </p:nvSpPr>
+        <p:spPr>
+          <a:xfrm>
+            <a:off x="1691640" y="1819656"/>
+            <a:ext cx="2788920" cy="365760"/>
           </a:xfrm>
           <a:prstGeom prst="rect">
             <a:avLst/>
@@ -1453,41 +1436,63 @@
               <a:buNone/>
             </a:pPr>
             <a:r>
-              <a:rPr lang="en-US" sz="1200" b="1" dirty="0">
+              <a:rPr lang="en-US" sz="950" dirty="0">
                 <a:solidFill>
                   <a:schemeClr val="tx1"/>
                 </a:solidFill>
               </a:rPr>
+              <a:t>Reads the complaint or deal papers and lists every name to run, so intake misses no one.</a:t>
+            </a:r>
+            <a:endParaRPr lang="en-US" sz="950" dirty="0"/>
+          </a:p>
+        </p:txBody>
+      </p:sp>
+      <p:sp>
+        <p:nvSpPr>
+          <p:cNvPr id="9" name="LexAtlas name"/>
+          <p:cNvSpPr txBox="1"/>
+          <p:nvPr/>
+        </p:nvSpPr>
+        <p:spPr>
+          <a:xfrm>
+            <a:off x="457200" y="2203704"/>
+            <a:ext cx="1188720" cy="365760"/>
+          </a:xfrm>
+          <a:prstGeom prst="rect">
+            <a:avLst/>
+          </a:prstGeom>
+          <a:noFill/>
+          <a:ln/>
+        </p:spPr>
+        <p:txBody>
+          <a:bodyPr wrap="square" lIns="0" tIns="0" rIns="0" bIns="0" rtlCol="0" anchor="t"/>
+          <a:lstStyle/>
+          <a:p>
+            <a:pPr indent="0" marL="0">
+              <a:buNone/>
+            </a:pPr>
+            <a:r>
+              <a:rPr lang="en-US" sz="1050" b="1" dirty="0">
+                <a:solidFill>
+                  <a:schemeClr val="tx1"/>
+                </a:solidFill>
+              </a:rPr>
               <a:t>LexAtlas</a:t>
             </a:r>
-            <a:endParaRPr lang="en-US" sz="1200" dirty="0"/>
-          </a:p>
-          <a:p>
-            <a:pPr indent="0" marL="0">
-              <a:buNone/>
-            </a:pPr>
-            <a:r>
-              <a:rPr lang="en-US" sz="1000" dirty="0">
-                <a:solidFill>
-                  <a:schemeClr val="tx2"/>
-                </a:solidFill>
-              </a:rPr>
-              <a:t>Relationship graph with ethical walls</a:t>
-            </a:r>
-            <a:endParaRPr lang="en-US" sz="1200" dirty="0"/>
-          </a:p>
-        </p:txBody>
-      </p:sp>
-      <p:sp>
-        <p:nvSpPr>
-          <p:cNvPr id="9" name="VigilMark entry"/>
-          <p:cNvSpPr txBox="1"/>
-          <p:nvPr/>
-        </p:nvSpPr>
-        <p:spPr>
-          <a:xfrm>
-            <a:off x="548640" y="3602736"/>
-            <a:ext cx="1389888" cy="603504"/>
+            <a:endParaRPr lang="en-US" sz="1050" dirty="0"/>
+          </a:p>
+        </p:txBody>
+      </p:sp>
+      <p:sp>
+        <p:nvSpPr>
+          <p:cNvPr id="10" name="LexAtlas line"/>
+          <p:cNvSpPr txBox="1"/>
+          <p:nvPr/>
+        </p:nvSpPr>
+        <p:spPr>
+          <a:xfrm>
+            <a:off x="1691640" y="2203704"/>
+            <a:ext cx="2788920" cy="365760"/>
           </a:xfrm>
           <a:prstGeom prst="rect">
             <a:avLst/>
@@ -1503,102 +1508,135 @@
               <a:buNone/>
             </a:pPr>
             <a:r>
-              <a:rPr lang="en-US" sz="1200" b="1" dirty="0">
+              <a:rPr lang="en-US" sz="950" dirty="0">
                 <a:solidFill>
                   <a:schemeClr val="tx1"/>
                 </a:solidFill>
               </a:rPr>
+              <a:t>Maps how companies, people and matters connect, for conflicts and diligence.</a:t>
+            </a:r>
+            <a:endParaRPr lang="en-US" sz="950" dirty="0"/>
+          </a:p>
+        </p:txBody>
+      </p:sp>
+      <p:sp>
+        <p:nvSpPr>
+          <p:cNvPr id="11" name="VigilMark name"/>
+          <p:cNvSpPr txBox="1"/>
+          <p:nvPr/>
+        </p:nvSpPr>
+        <p:spPr>
+          <a:xfrm>
+            <a:off x="457200" y="2587752"/>
+            <a:ext cx="1188720" cy="365760"/>
+          </a:xfrm>
+          <a:prstGeom prst="rect">
+            <a:avLst/>
+          </a:prstGeom>
+          <a:noFill/>
+          <a:ln/>
+        </p:spPr>
+        <p:txBody>
+          <a:bodyPr wrap="square" lIns="0" tIns="0" rIns="0" bIns="0" rtlCol="0" anchor="t"/>
+          <a:lstStyle/>
+          <a:p>
+            <a:pPr indent="0" marL="0">
+              <a:buNone/>
+            </a:pPr>
+            <a:r>
+              <a:rPr lang="en-US" sz="1050" b="1" dirty="0">
+                <a:solidFill>
+                  <a:schemeClr val="tx1"/>
+                </a:solidFill>
+              </a:rPr>
               <a:t>VigilMark</a:t>
             </a:r>
-            <a:endParaRPr lang="en-US" sz="1200" dirty="0"/>
-          </a:p>
-          <a:p>
-            <a:pPr indent="0" marL="0">
-              <a:buNone/>
-            </a:pPr>
-            <a:r>
-              <a:rPr lang="en-US" sz="1000" dirty="0">
-                <a:solidFill>
-                  <a:schemeClr val="tx2"/>
-                </a:solidFill>
-              </a:rPr>
-              <a:t>Trademark watch and triage</a:t>
-            </a:r>
-            <a:endParaRPr lang="en-US" sz="1200" dirty="0"/>
-          </a:p>
-        </p:txBody>
-      </p:sp>
-      <p:sp>
-        <p:nvSpPr>
-          <p:cNvPr id="10" name="Litigation column"/>
-          <p:cNvSpPr/>
-          <p:nvPr/>
-        </p:nvSpPr>
-        <p:spPr>
-          <a:xfrm>
-            <a:off x="2139696" y="1188720"/>
-            <a:ext cx="1572768" cy="3127248"/>
-          </a:xfrm>
-          <a:prstGeom prst="rect">
-            <a:avLst/>
-          </a:prstGeom>
-          <a:solidFill>
-            <a:schemeClr val="bg2"/>
-          </a:solidFill>
-          <a:ln w="12700">
-            <a:solidFill>
-              <a:schemeClr val="bg2"/>
-            </a:solidFill>
-            <a:prstDash val="solid"/>
-          </a:ln>
-        </p:spPr>
-      </p:sp>
-      <p:sp>
-        <p:nvSpPr>
-          <p:cNvPr id="11" name="Litigation heading"/>
-          <p:cNvSpPr txBox="1"/>
-          <p:nvPr/>
-        </p:nvSpPr>
-        <p:spPr>
-          <a:xfrm>
-            <a:off x="2231136" y="1243584"/>
-            <a:ext cx="1389888" cy="365760"/>
-          </a:xfrm>
-          <a:prstGeom prst="rect">
-            <a:avLst/>
-          </a:prstGeom>
-          <a:noFill/>
-          <a:ln/>
-        </p:spPr>
-        <p:txBody>
-          <a:bodyPr wrap="square" lIns="0" tIns="0" rIns="0" bIns="0" rtlCol="0" anchor="ctr"/>
-          <a:lstStyle/>
-          <a:p>
-            <a:pPr indent="0" marL="0">
-              <a:buNone/>
-            </a:pPr>
-            <a:r>
-              <a:rPr lang="en-US" sz="1100" b="1" dirty="0">
+            <a:endParaRPr lang="en-US" sz="1050" dirty="0"/>
+          </a:p>
+        </p:txBody>
+      </p:sp>
+      <p:sp>
+        <p:nvSpPr>
+          <p:cNvPr id="12" name="VigilMark line"/>
+          <p:cNvSpPr txBox="1"/>
+          <p:nvPr/>
+        </p:nvSpPr>
+        <p:spPr>
+          <a:xfrm>
+            <a:off x="1691640" y="2587752"/>
+            <a:ext cx="2788920" cy="365760"/>
+          </a:xfrm>
+          <a:prstGeom prst="rect">
+            <a:avLst/>
+          </a:prstGeom>
+          <a:noFill/>
+          <a:ln/>
+        </p:spPr>
+        <p:txBody>
+          <a:bodyPr wrap="square" lIns="0" tIns="0" rIns="0" bIns="0" rtlCol="0" anchor="t"/>
+          <a:lstStyle/>
+          <a:p>
+            <a:pPr indent="0" marL="0">
+              <a:buNone/>
+            </a:pPr>
+            <a:r>
+              <a:rPr lang="en-US" sz="950" dirty="0">
+                <a:solidFill>
+                  <a:schemeClr val="tx1"/>
+                </a:solidFill>
+              </a:rPr>
+              <a:t>Ranks new trademark filings against clients' marks before the opposition window closes.</a:t>
+            </a:r>
+            <a:endParaRPr lang="en-US" sz="950" dirty="0"/>
+          </a:p>
+        </p:txBody>
+      </p:sp>
+      <p:sp>
+        <p:nvSpPr>
+          <p:cNvPr id="13" name="Litigation heading"/>
+          <p:cNvSpPr txBox="1"/>
+          <p:nvPr/>
+        </p:nvSpPr>
+        <p:spPr>
+          <a:xfrm>
+            <a:off x="457200" y="3044952"/>
+            <a:ext cx="4023360" cy="219456"/>
+          </a:xfrm>
+          <a:prstGeom prst="rect">
+            <a:avLst/>
+          </a:prstGeom>
+          <a:noFill/>
+          <a:ln/>
+        </p:spPr>
+        <p:txBody>
+          <a:bodyPr wrap="square" lIns="0" tIns="0" rIns="0" bIns="0" rtlCol="0" anchor="b"/>
+          <a:lstStyle/>
+          <a:p>
+            <a:pPr indent="0" marL="0">
+              <a:buNone/>
+            </a:pPr>
+            <a:r>
+              <a:rPr lang="en-US" sz="900" b="1" spc="150" kern="0" dirty="0">
                 <a:solidFill>
                   <a:schemeClr val="accent5"/>
                 </a:solidFill>
               </a:rPr>
-              <a:t>Litigation</a:t>
-            </a:r>
-            <a:endParaRPr lang="en-US" sz="1100" dirty="0"/>
-          </a:p>
-        </p:txBody>
-      </p:sp>
-      <p:sp>
-        <p:nvSpPr>
-          <p:cNvPr id="12" name="Win your case ASAP entry"/>
-          <p:cNvSpPr txBox="1"/>
-          <p:nvPr/>
-        </p:nvSpPr>
-        <p:spPr>
-          <a:xfrm>
-            <a:off x="2231136" y="1682496"/>
-            <a:ext cx="1389888" cy="603504"/>
+              <a:t>LITIGATION</a:t>
+            </a:r>
+            <a:endParaRPr lang="en-US" sz="900" dirty="0"/>
+          </a:p>
+        </p:txBody>
+      </p:sp>
+      <p:sp>
+        <p:nvSpPr>
+          <p:cNvPr id="14" name="Win your case ASAP name"/>
+          <p:cNvSpPr txBox="1"/>
+          <p:nvPr/>
+        </p:nvSpPr>
+        <p:spPr>
+          <a:xfrm>
+            <a:off x="457200" y="3291840"/>
+            <a:ext cx="1188720" cy="365760"/>
           </a:xfrm>
           <a:prstGeom prst="rect">
             <a:avLst/>
@@ -1614,41 +1652,27 @@
               <a:buNone/>
             </a:pPr>
             <a:r>
-              <a:rPr lang="en-US" sz="1200" b="1" dirty="0">
+              <a:rPr lang="en-US" sz="1050" b="1" dirty="0">
                 <a:solidFill>
                   <a:schemeClr val="tx1"/>
                 </a:solidFill>
               </a:rPr>
               <a:t>Win your case ASAP</a:t>
             </a:r>
-            <a:endParaRPr lang="en-US" sz="1200" dirty="0"/>
-          </a:p>
-          <a:p>
-            <a:pPr indent="0" marL="0">
-              <a:buNone/>
-            </a:pPr>
-            <a:r>
-              <a:rPr lang="en-US" sz="1000" dirty="0">
-                <a:solidFill>
-                  <a:schemeClr val="tx2"/>
-                </a:solidFill>
-              </a:rPr>
-              <a:t>First read of a complaint</a:t>
-            </a:r>
-            <a:endParaRPr lang="en-US" sz="1200" dirty="0"/>
-          </a:p>
-        </p:txBody>
-      </p:sp>
-      <p:sp>
-        <p:nvSpPr>
-          <p:cNvPr id="13" name="Testimony Check entry"/>
-          <p:cNvSpPr txBox="1"/>
-          <p:nvPr/>
-        </p:nvSpPr>
-        <p:spPr>
-          <a:xfrm>
-            <a:off x="2231136" y="2322576"/>
-            <a:ext cx="1389888" cy="603504"/>
+            <a:endParaRPr lang="en-US" sz="1050" dirty="0"/>
+          </a:p>
+        </p:txBody>
+      </p:sp>
+      <p:sp>
+        <p:nvSpPr>
+          <p:cNvPr id="15" name="Win your case ASAP line"/>
+          <p:cNvSpPr txBox="1"/>
+          <p:nvPr/>
+        </p:nvSpPr>
+        <p:spPr>
+          <a:xfrm>
+            <a:off x="1691640" y="3291840"/>
+            <a:ext cx="2788920" cy="365760"/>
           </a:xfrm>
           <a:prstGeom prst="rect">
             <a:avLst/>
@@ -1664,41 +1688,63 @@
               <a:buNone/>
             </a:pPr>
             <a:r>
-              <a:rPr lang="en-US" sz="1200" b="1" dirty="0">
+              <a:rPr lang="en-US" sz="950" dirty="0">
                 <a:solidFill>
                   <a:schemeClr val="tx1"/>
                 </a:solidFill>
               </a:rPr>
+              <a:t>First read of a complaint: which motions could end the case early, with filing dates.</a:t>
+            </a:r>
+            <a:endParaRPr lang="en-US" sz="950" dirty="0"/>
+          </a:p>
+        </p:txBody>
+      </p:sp>
+      <p:sp>
+        <p:nvSpPr>
+          <p:cNvPr id="16" name="Testimony Check name"/>
+          <p:cNvSpPr txBox="1"/>
+          <p:nvPr/>
+        </p:nvSpPr>
+        <p:spPr>
+          <a:xfrm>
+            <a:off x="457200" y="3675888"/>
+            <a:ext cx="1188720" cy="365760"/>
+          </a:xfrm>
+          <a:prstGeom prst="rect">
+            <a:avLst/>
+          </a:prstGeom>
+          <a:noFill/>
+          <a:ln/>
+        </p:spPr>
+        <p:txBody>
+          <a:bodyPr wrap="square" lIns="0" tIns="0" rIns="0" bIns="0" rtlCol="0" anchor="t"/>
+          <a:lstStyle/>
+          <a:p>
+            <a:pPr indent="0" marL="0">
+              <a:buNone/>
+            </a:pPr>
+            <a:r>
+              <a:rPr lang="en-US" sz="1050" b="1" dirty="0">
+                <a:solidFill>
+                  <a:schemeClr val="tx1"/>
+                </a:solidFill>
+              </a:rPr>
               <a:t>Testimony Check</a:t>
             </a:r>
-            <a:endParaRPr lang="en-US" sz="1200" dirty="0"/>
-          </a:p>
-          <a:p>
-            <a:pPr indent="0" marL="0">
-              <a:buNone/>
-            </a:pPr>
-            <a:r>
-              <a:rPr lang="en-US" sz="1000" dirty="0">
-                <a:solidFill>
-                  <a:schemeClr val="tx2"/>
-                </a:solidFill>
-              </a:rPr>
-              <a:t>Witness vs. the record</a:t>
-            </a:r>
-            <a:endParaRPr lang="en-US" sz="1200" dirty="0"/>
-          </a:p>
-        </p:txBody>
-      </p:sp>
-      <p:sp>
-        <p:nvSpPr>
-          <p:cNvPr id="14" name="Citation Gate entry"/>
-          <p:cNvSpPr txBox="1"/>
-          <p:nvPr/>
-        </p:nvSpPr>
-        <p:spPr>
-          <a:xfrm>
-            <a:off x="2231136" y="2962656"/>
-            <a:ext cx="1389888" cy="603504"/>
+            <a:endParaRPr lang="en-US" sz="1050" dirty="0"/>
+          </a:p>
+        </p:txBody>
+      </p:sp>
+      <p:sp>
+        <p:nvSpPr>
+          <p:cNvPr id="17" name="Testimony Check line"/>
+          <p:cNvSpPr txBox="1"/>
+          <p:nvPr/>
+        </p:nvSpPr>
+        <p:spPr>
+          <a:xfrm>
+            <a:off x="1691640" y="3675888"/>
+            <a:ext cx="2788920" cy="365760"/>
           </a:xfrm>
           <a:prstGeom prst="rect">
             <a:avLst/>
@@ -1714,41 +1760,63 @@
               <a:buNone/>
             </a:pPr>
             <a:r>
-              <a:rPr lang="en-US" sz="1200" b="1" dirty="0">
+              <a:rPr lang="en-US" sz="950" dirty="0">
                 <a:solidFill>
                   <a:schemeClr val="tx1"/>
                 </a:solidFill>
               </a:rPr>
+              <a:t>Finds where a witness's story conflicts with the documents and drafts the deposition outline.</a:t>
+            </a:r>
+            <a:endParaRPr lang="en-US" sz="950" dirty="0"/>
+          </a:p>
+        </p:txBody>
+      </p:sp>
+      <p:sp>
+        <p:nvSpPr>
+          <p:cNvPr id="18" name="Citation Gate name"/>
+          <p:cNvSpPr txBox="1"/>
+          <p:nvPr/>
+        </p:nvSpPr>
+        <p:spPr>
+          <a:xfrm>
+            <a:off x="457200" y="4059936"/>
+            <a:ext cx="1188720" cy="365760"/>
+          </a:xfrm>
+          <a:prstGeom prst="rect">
+            <a:avLst/>
+          </a:prstGeom>
+          <a:noFill/>
+          <a:ln/>
+        </p:spPr>
+        <p:txBody>
+          <a:bodyPr wrap="square" lIns="0" tIns="0" rIns="0" bIns="0" rtlCol="0" anchor="t"/>
+          <a:lstStyle/>
+          <a:p>
+            <a:pPr indent="0" marL="0">
+              <a:buNone/>
+            </a:pPr>
+            <a:r>
+              <a:rPr lang="en-US" sz="1050" b="1" dirty="0">
+                <a:solidFill>
+                  <a:schemeClr val="tx1"/>
+                </a:solidFill>
+              </a:rPr>
               <a:t>Citation Gate</a:t>
             </a:r>
-            <a:endParaRPr lang="en-US" sz="1200" dirty="0"/>
-          </a:p>
-          <a:p>
-            <a:pPr indent="0" marL="0">
-              <a:buNone/>
-            </a:pPr>
-            <a:r>
-              <a:rPr lang="en-US" sz="1000" dirty="0">
-                <a:solidFill>
-                  <a:schemeClr val="tx2"/>
-                </a:solidFill>
-              </a:rPr>
-              <a:t>Every citation checked</a:t>
-            </a:r>
-            <a:endParaRPr lang="en-US" sz="1200" dirty="0"/>
-          </a:p>
-        </p:txBody>
-      </p:sp>
-      <p:sp>
-        <p:nvSpPr>
-          <p:cNvPr id="15" name="Case Wins Debrief entry"/>
-          <p:cNvSpPr txBox="1"/>
-          <p:nvPr/>
-        </p:nvSpPr>
-        <p:spPr>
-          <a:xfrm>
-            <a:off x="2231136" y="3602736"/>
-            <a:ext cx="1389888" cy="603504"/>
+            <a:endParaRPr lang="en-US" sz="1050" dirty="0"/>
+          </a:p>
+        </p:txBody>
+      </p:sp>
+      <p:sp>
+        <p:nvSpPr>
+          <p:cNvPr id="19" name="Citation Gate line"/>
+          <p:cNvSpPr txBox="1"/>
+          <p:nvPr/>
+        </p:nvSpPr>
+        <p:spPr>
+          <a:xfrm>
+            <a:off x="1691640" y="4059936"/>
+            <a:ext cx="2788920" cy="365760"/>
           </a:xfrm>
           <a:prstGeom prst="rect">
             <a:avLst/>
@@ -1764,102 +1832,135 @@
               <a:buNone/>
             </a:pPr>
             <a:r>
-              <a:rPr lang="en-US" sz="1200" b="1" dirty="0">
+              <a:rPr lang="en-US" sz="950" dirty="0">
                 <a:solidFill>
                   <a:schemeClr val="tx1"/>
                 </a:solidFill>
               </a:rPr>
+              <a:t>Checks every cited case and quotation against real opinions before a brief goes out.</a:t>
+            </a:r>
+            <a:endParaRPr lang="en-US" sz="950" dirty="0"/>
+          </a:p>
+        </p:txBody>
+      </p:sp>
+      <p:sp>
+        <p:nvSpPr>
+          <p:cNvPr id="20" name="Case Wins Debrief name"/>
+          <p:cNvSpPr txBox="1"/>
+          <p:nvPr/>
+        </p:nvSpPr>
+        <p:spPr>
+          <a:xfrm>
+            <a:off x="457200" y="4443984"/>
+            <a:ext cx="1188720" cy="365760"/>
+          </a:xfrm>
+          <a:prstGeom prst="rect">
+            <a:avLst/>
+          </a:prstGeom>
+          <a:noFill/>
+          <a:ln/>
+        </p:spPr>
+        <p:txBody>
+          <a:bodyPr wrap="square" lIns="0" tIns="0" rIns="0" bIns="0" rtlCol="0" anchor="t"/>
+          <a:lstStyle/>
+          <a:p>
+            <a:pPr indent="0" marL="0">
+              <a:buNone/>
+            </a:pPr>
+            <a:r>
+              <a:rPr lang="en-US" sz="1050" b="1" dirty="0">
+                <a:solidFill>
+                  <a:schemeClr val="tx1"/>
+                </a:solidFill>
+              </a:rPr>
               <a:t>Case Wins Debrief</a:t>
             </a:r>
-            <a:endParaRPr lang="en-US" sz="1200" dirty="0"/>
-          </a:p>
-          <a:p>
-            <a:pPr indent="0" marL="0">
-              <a:buNone/>
-            </a:pPr>
-            <a:r>
-              <a:rPr lang="en-US" sz="1000" dirty="0">
-                <a:solidFill>
-                  <a:schemeClr val="tx2"/>
-                </a:solidFill>
-              </a:rPr>
-              <a:t>Lessons from wins, reusable</a:t>
-            </a:r>
-            <a:endParaRPr lang="en-US" sz="1200" dirty="0"/>
-          </a:p>
-        </p:txBody>
-      </p:sp>
-      <p:sp>
-        <p:nvSpPr>
-          <p:cNvPr id="16" name="Transactions and practice groups column"/>
-          <p:cNvSpPr/>
-          <p:nvPr/>
-        </p:nvSpPr>
-        <p:spPr>
-          <a:xfrm>
-            <a:off x="3822192" y="1188720"/>
-            <a:ext cx="1572768" cy="3127248"/>
-          </a:xfrm>
-          <a:prstGeom prst="rect">
-            <a:avLst/>
-          </a:prstGeom>
-          <a:solidFill>
-            <a:schemeClr val="bg2"/>
-          </a:solidFill>
-          <a:ln w="12700">
-            <a:solidFill>
-              <a:schemeClr val="bg2"/>
-            </a:solidFill>
-            <a:prstDash val="solid"/>
-          </a:ln>
-        </p:spPr>
-      </p:sp>
-      <p:sp>
-        <p:nvSpPr>
-          <p:cNvPr id="17" name="Transactions and practice groups heading"/>
-          <p:cNvSpPr txBox="1"/>
-          <p:nvPr/>
-        </p:nvSpPr>
-        <p:spPr>
-          <a:xfrm>
-            <a:off x="3913632" y="1243584"/>
-            <a:ext cx="1389888" cy="365760"/>
-          </a:xfrm>
-          <a:prstGeom prst="rect">
-            <a:avLst/>
-          </a:prstGeom>
-          <a:noFill/>
-          <a:ln/>
-        </p:spPr>
-        <p:txBody>
-          <a:bodyPr wrap="square" lIns="0" tIns="0" rIns="0" bIns="0" rtlCol="0" anchor="ctr"/>
-          <a:lstStyle/>
-          <a:p>
-            <a:pPr indent="0" marL="0">
-              <a:buNone/>
-            </a:pPr>
-            <a:r>
-              <a:rPr lang="en-US" sz="1100" b="1" dirty="0">
+            <a:endParaRPr lang="en-US" sz="1050" dirty="0"/>
+          </a:p>
+        </p:txBody>
+      </p:sp>
+      <p:sp>
+        <p:nvSpPr>
+          <p:cNvPr id="21" name="Case Wins Debrief line"/>
+          <p:cNvSpPr txBox="1"/>
+          <p:nvPr/>
+        </p:nvSpPr>
+        <p:spPr>
+          <a:xfrm>
+            <a:off x="1691640" y="4443984"/>
+            <a:ext cx="2788920" cy="365760"/>
+          </a:xfrm>
+          <a:prstGeom prst="rect">
+            <a:avLst/>
+          </a:prstGeom>
+          <a:noFill/>
+          <a:ln/>
+        </p:spPr>
+        <p:txBody>
+          <a:bodyPr wrap="square" lIns="0" tIns="0" rIns="0" bIns="0" rtlCol="0" anchor="t"/>
+          <a:lstStyle/>
+          <a:p>
+            <a:pPr indent="0" marL="0">
+              <a:buNone/>
+            </a:pPr>
+            <a:r>
+              <a:rPr lang="en-US" sz="950" dirty="0">
+                <a:solidFill>
+                  <a:schemeClr val="tx1"/>
+                </a:solidFill>
+              </a:rPr>
+              <a:t>Turns each trial win into lessons and a tool the next team can reuse.</a:t>
+            </a:r>
+            <a:endParaRPr lang="en-US" sz="950" dirty="0"/>
+          </a:p>
+        </p:txBody>
+      </p:sp>
+      <p:sp>
+        <p:nvSpPr>
+          <p:cNvPr id="22" name="Transactions and practice groups heading"/>
+          <p:cNvSpPr txBox="1"/>
+          <p:nvPr/>
+        </p:nvSpPr>
+        <p:spPr>
+          <a:xfrm>
+            <a:off x="4663440" y="1188720"/>
+            <a:ext cx="4023360" cy="219456"/>
+          </a:xfrm>
+          <a:prstGeom prst="rect">
+            <a:avLst/>
+          </a:prstGeom>
+          <a:noFill/>
+          <a:ln/>
+        </p:spPr>
+        <p:txBody>
+          <a:bodyPr wrap="square" lIns="0" tIns="0" rIns="0" bIns="0" rtlCol="0" anchor="b"/>
+          <a:lstStyle/>
+          <a:p>
+            <a:pPr indent="0" marL="0">
+              <a:buNone/>
+            </a:pPr>
+            <a:r>
+              <a:rPr lang="en-US" sz="900" b="1" spc="150" kern="0" dirty="0">
                 <a:solidFill>
                   <a:schemeClr val="accent5"/>
                 </a:solidFill>
               </a:rPr>
-              <a:t>Transactions and practice groups</a:t>
-            </a:r>
-            <a:endParaRPr lang="en-US" sz="1100" dirty="0"/>
-          </a:p>
-        </p:txBody>
-      </p:sp>
-      <p:sp>
-        <p:nvSpPr>
-          <p:cNvPr id="18" name="Matter Desk entry"/>
-          <p:cNvSpPr txBox="1"/>
-          <p:nvPr/>
-        </p:nvSpPr>
-        <p:spPr>
-          <a:xfrm>
-            <a:off x="3913632" y="1682496"/>
-            <a:ext cx="1389888" cy="603504"/>
+              <a:t>TRANSACTIONS AND PRACTICE GROUPS</a:t>
+            </a:r>
+            <a:endParaRPr lang="en-US" sz="900" dirty="0"/>
+          </a:p>
+        </p:txBody>
+      </p:sp>
+      <p:sp>
+        <p:nvSpPr>
+          <p:cNvPr id="23" name="Matter Desk name"/>
+          <p:cNvSpPr txBox="1"/>
+          <p:nvPr/>
+        </p:nvSpPr>
+        <p:spPr>
+          <a:xfrm>
+            <a:off x="4663440" y="1435608"/>
+            <a:ext cx="1188720" cy="365760"/>
           </a:xfrm>
           <a:prstGeom prst="rect">
             <a:avLst/>
@@ -1875,41 +1976,27 @@
               <a:buNone/>
             </a:pPr>
             <a:r>
-              <a:rPr lang="en-US" sz="1200" b="1" dirty="0">
+              <a:rPr lang="en-US" sz="1050" b="1" dirty="0">
                 <a:solidFill>
                   <a:schemeClr val="tx1"/>
                 </a:solidFill>
               </a:rPr>
               <a:t>Matter Desk</a:t>
             </a:r>
-            <a:endParaRPr lang="en-US" sz="1200" dirty="0"/>
-          </a:p>
-          <a:p>
-            <a:pPr indent="0" marL="0">
-              <a:buNone/>
-            </a:pPr>
-            <a:r>
-              <a:rPr lang="en-US" sz="1000" dirty="0">
-                <a:solidFill>
-                  <a:schemeClr val="tx2"/>
-                </a:solidFill>
-              </a:rPr>
-              <a:t>First read of a new matter</a:t>
-            </a:r>
-            <a:endParaRPr lang="en-US" sz="1200" dirty="0"/>
-          </a:p>
-        </p:txBody>
-      </p:sp>
-      <p:sp>
-        <p:nvSpPr>
-          <p:cNvPr id="19" name="Synthesis entry"/>
-          <p:cNvSpPr txBox="1"/>
-          <p:nvPr/>
-        </p:nvSpPr>
-        <p:spPr>
-          <a:xfrm>
-            <a:off x="3913632" y="2322576"/>
-            <a:ext cx="1389888" cy="603504"/>
+            <a:endParaRPr lang="en-US" sz="1050" dirty="0"/>
+          </a:p>
+        </p:txBody>
+      </p:sp>
+      <p:sp>
+        <p:nvSpPr>
+          <p:cNvPr id="24" name="Matter Desk line"/>
+          <p:cNvSpPr txBox="1"/>
+          <p:nvPr/>
+        </p:nvSpPr>
+        <p:spPr>
+          <a:xfrm>
+            <a:off x="5897880" y="1435608"/>
+            <a:ext cx="2788920" cy="365760"/>
           </a:xfrm>
           <a:prstGeom prst="rect">
             <a:avLst/>
@@ -1925,41 +2012,63 @@
               <a:buNone/>
             </a:pPr>
             <a:r>
-              <a:rPr lang="en-US" sz="1200" b="1" dirty="0">
+              <a:rPr lang="en-US" sz="950" dirty="0">
                 <a:solidFill>
                   <a:schemeClr val="tx1"/>
                 </a:solidFill>
               </a:rPr>
+              <a:t>First read of a new matter in five practice areas, with every deadline dated.</a:t>
+            </a:r>
+            <a:endParaRPr lang="en-US" sz="950" dirty="0"/>
+          </a:p>
+        </p:txBody>
+      </p:sp>
+      <p:sp>
+        <p:nvSpPr>
+          <p:cNvPr id="25" name="Synthesis name"/>
+          <p:cNvSpPr txBox="1"/>
+          <p:nvPr/>
+        </p:nvSpPr>
+        <p:spPr>
+          <a:xfrm>
+            <a:off x="4663440" y="1819656"/>
+            <a:ext cx="1188720" cy="365760"/>
+          </a:xfrm>
+          <a:prstGeom prst="rect">
+            <a:avLst/>
+          </a:prstGeom>
+          <a:noFill/>
+          <a:ln/>
+        </p:spPr>
+        <p:txBody>
+          <a:bodyPr wrap="square" lIns="0" tIns="0" rIns="0" bIns="0" rtlCol="0" anchor="t"/>
+          <a:lstStyle/>
+          <a:p>
+            <a:pPr indent="0" marL="0">
+              <a:buNone/>
+            </a:pPr>
+            <a:r>
+              <a:rPr lang="en-US" sz="1050" b="1" dirty="0">
+                <a:solidFill>
+                  <a:schemeClr val="tx1"/>
+                </a:solidFill>
+              </a:rPr>
               <a:t>Synthesis</a:t>
             </a:r>
-            <a:endParaRPr lang="en-US" sz="1200" dirty="0"/>
-          </a:p>
-          <a:p>
-            <a:pPr indent="0" marL="0">
-              <a:buNone/>
-            </a:pPr>
-            <a:r>
-              <a:rPr lang="en-US" sz="1000" dirty="0">
-                <a:solidFill>
-                  <a:schemeClr val="tx2"/>
-                </a:solidFill>
-              </a:rPr>
-              <a:t>Buy-side deal workbench</a:t>
-            </a:r>
-            <a:endParaRPr lang="en-US" sz="1200" dirty="0"/>
-          </a:p>
-        </p:txBody>
-      </p:sp>
-      <p:sp>
-        <p:nvSpPr>
-          <p:cNvPr id="20" name="Skippy entry"/>
-          <p:cNvSpPr txBox="1"/>
-          <p:nvPr/>
-        </p:nvSpPr>
-        <p:spPr>
-          <a:xfrm>
-            <a:off x="3913632" y="2962656"/>
-            <a:ext cx="1389888" cy="603504"/>
+            <a:endParaRPr lang="en-US" sz="1050" dirty="0"/>
+          </a:p>
+        </p:txBody>
+      </p:sp>
+      <p:sp>
+        <p:nvSpPr>
+          <p:cNvPr id="26" name="Synthesis line"/>
+          <p:cNvSpPr txBox="1"/>
+          <p:nvPr/>
+        </p:nvSpPr>
+        <p:spPr>
+          <a:xfrm>
+            <a:off x="5897880" y="1819656"/>
+            <a:ext cx="2788920" cy="365760"/>
           </a:xfrm>
           <a:prstGeom prst="rect">
             <a:avLst/>
@@ -1975,102 +2084,135 @@
               <a:buNone/>
             </a:pPr>
             <a:r>
-              <a:rPr lang="en-US" sz="1200" b="1" dirty="0">
+              <a:rPr lang="en-US" sz="950" dirty="0">
                 <a:solidFill>
                   <a:schemeClr val="tx1"/>
                 </a:solidFill>
               </a:rPr>
+              <a:t>Buy-side deal workbench: schedules against reps, the markup explained, closing list built.</a:t>
+            </a:r>
+            <a:endParaRPr lang="en-US" sz="950" dirty="0"/>
+          </a:p>
+        </p:txBody>
+      </p:sp>
+      <p:sp>
+        <p:nvSpPr>
+          <p:cNvPr id="27" name="Skippy name"/>
+          <p:cNvSpPr txBox="1"/>
+          <p:nvPr/>
+        </p:nvSpPr>
+        <p:spPr>
+          <a:xfrm>
+            <a:off x="4663440" y="2203704"/>
+            <a:ext cx="1188720" cy="365760"/>
+          </a:xfrm>
+          <a:prstGeom prst="rect">
+            <a:avLst/>
+          </a:prstGeom>
+          <a:noFill/>
+          <a:ln/>
+        </p:spPr>
+        <p:txBody>
+          <a:bodyPr wrap="square" lIns="0" tIns="0" rIns="0" bIns="0" rtlCol="0" anchor="t"/>
+          <a:lstStyle/>
+          <a:p>
+            <a:pPr indent="0" marL="0">
+              <a:buNone/>
+            </a:pPr>
+            <a:r>
+              <a:rPr lang="en-US" sz="1050" b="1" dirty="0">
+                <a:solidFill>
+                  <a:schemeClr val="tx1"/>
+                </a:solidFill>
+              </a:rPr>
               <a:t>Skippy</a:t>
             </a:r>
-            <a:endParaRPr lang="en-US" sz="1200" dirty="0"/>
-          </a:p>
-          <a:p>
-            <a:pPr indent="0" marL="0">
-              <a:buNone/>
-            </a:pPr>
-            <a:r>
-              <a:rPr lang="en-US" sz="1000" dirty="0">
-                <a:solidFill>
-                  <a:schemeClr val="tx2"/>
-                </a:solidFill>
-              </a:rPr>
-              <a:t>Ask the matter, cited to the page</a:t>
-            </a:r>
-            <a:endParaRPr lang="en-US" sz="1200" dirty="0"/>
-          </a:p>
-        </p:txBody>
-      </p:sp>
-      <p:sp>
-        <p:nvSpPr>
-          <p:cNvPr id="21" name="Billing and time column"/>
-          <p:cNvSpPr/>
-          <p:nvPr/>
-        </p:nvSpPr>
-        <p:spPr>
-          <a:xfrm>
-            <a:off x="5504688" y="1188720"/>
-            <a:ext cx="1572768" cy="3127248"/>
-          </a:xfrm>
-          <a:prstGeom prst="rect">
-            <a:avLst/>
-          </a:prstGeom>
-          <a:solidFill>
-            <a:schemeClr val="bg2"/>
-          </a:solidFill>
-          <a:ln w="12700">
-            <a:solidFill>
-              <a:schemeClr val="bg2"/>
-            </a:solidFill>
-            <a:prstDash val="solid"/>
-          </a:ln>
-        </p:spPr>
-      </p:sp>
-      <p:sp>
-        <p:nvSpPr>
-          <p:cNvPr id="22" name="Billing and time heading"/>
-          <p:cNvSpPr txBox="1"/>
-          <p:nvPr/>
-        </p:nvSpPr>
-        <p:spPr>
-          <a:xfrm>
-            <a:off x="5596128" y="1243584"/>
-            <a:ext cx="1389888" cy="365760"/>
-          </a:xfrm>
-          <a:prstGeom prst="rect">
-            <a:avLst/>
-          </a:prstGeom>
-          <a:noFill/>
-          <a:ln/>
-        </p:spPr>
-        <p:txBody>
-          <a:bodyPr wrap="square" lIns="0" tIns="0" rIns="0" bIns="0" rtlCol="0" anchor="ctr"/>
-          <a:lstStyle/>
-          <a:p>
-            <a:pPr indent="0" marL="0">
-              <a:buNone/>
-            </a:pPr>
-            <a:r>
-              <a:rPr lang="en-US" sz="1100" b="1" dirty="0">
+            <a:endParaRPr lang="en-US" sz="1050" dirty="0"/>
+          </a:p>
+        </p:txBody>
+      </p:sp>
+      <p:sp>
+        <p:nvSpPr>
+          <p:cNvPr id="28" name="Skippy line"/>
+          <p:cNvSpPr txBox="1"/>
+          <p:nvPr/>
+        </p:nvSpPr>
+        <p:spPr>
+          <a:xfrm>
+            <a:off x="5897880" y="2203704"/>
+            <a:ext cx="2788920" cy="365760"/>
+          </a:xfrm>
+          <a:prstGeom prst="rect">
+            <a:avLst/>
+          </a:prstGeom>
+          <a:noFill/>
+          <a:ln/>
+        </p:spPr>
+        <p:txBody>
+          <a:bodyPr wrap="square" lIns="0" tIns="0" rIns="0" bIns="0" rtlCol="0" anchor="t"/>
+          <a:lstStyle/>
+          <a:p>
+            <a:pPr indent="0" marL="0">
+              <a:buNone/>
+            </a:pPr>
+            <a:r>
+              <a:rPr lang="en-US" sz="950" dirty="0">
+                <a:solidFill>
+                  <a:schemeClr val="tx1"/>
+                </a:solidFill>
+              </a:rPr>
+              <a:t>Answers questions about a matter's files, every answer cited to the page.</a:t>
+            </a:r>
+            <a:endParaRPr lang="en-US" sz="950" dirty="0"/>
+          </a:p>
+        </p:txBody>
+      </p:sp>
+      <p:sp>
+        <p:nvSpPr>
+          <p:cNvPr id="29" name="Billing and time heading"/>
+          <p:cNvSpPr txBox="1"/>
+          <p:nvPr/>
+        </p:nvSpPr>
+        <p:spPr>
+          <a:xfrm>
+            <a:off x="4663440" y="2660904"/>
+            <a:ext cx="4023360" cy="219456"/>
+          </a:xfrm>
+          <a:prstGeom prst="rect">
+            <a:avLst/>
+          </a:prstGeom>
+          <a:noFill/>
+          <a:ln/>
+        </p:spPr>
+        <p:txBody>
+          <a:bodyPr wrap="square" lIns="0" tIns="0" rIns="0" bIns="0" rtlCol="0" anchor="b"/>
+          <a:lstStyle/>
+          <a:p>
+            <a:pPr indent="0" marL="0">
+              <a:buNone/>
+            </a:pPr>
+            <a:r>
+              <a:rPr lang="en-US" sz="900" b="1" spc="150" kern="0" dirty="0">
                 <a:solidFill>
                   <a:schemeClr val="accent5"/>
                 </a:solidFill>
               </a:rPr>
-              <a:t>Billing and time</a:t>
-            </a:r>
-            <a:endParaRPr lang="en-US" sz="1100" dirty="0"/>
-          </a:p>
-        </p:txBody>
-      </p:sp>
-      <p:sp>
-        <p:nvSpPr>
-          <p:cNvPr id="23" name="Guideline Guard entry"/>
-          <p:cNvSpPr txBox="1"/>
-          <p:nvPr/>
-        </p:nvSpPr>
-        <p:spPr>
-          <a:xfrm>
-            <a:off x="5596128" y="1682496"/>
-            <a:ext cx="1389888" cy="603504"/>
+              <a:t>BILLING AND TIME</a:t>
+            </a:r>
+            <a:endParaRPr lang="en-US" sz="900" dirty="0"/>
+          </a:p>
+        </p:txBody>
+      </p:sp>
+      <p:sp>
+        <p:nvSpPr>
+          <p:cNvPr id="30" name="Guideline Guard name"/>
+          <p:cNvSpPr txBox="1"/>
+          <p:nvPr/>
+        </p:nvSpPr>
+        <p:spPr>
+          <a:xfrm>
+            <a:off x="4663440" y="2907792"/>
+            <a:ext cx="1188720" cy="365760"/>
           </a:xfrm>
           <a:prstGeom prst="rect">
             <a:avLst/>
@@ -2086,41 +2228,63 @@
               <a:buNone/>
             </a:pPr>
             <a:r>
-              <a:rPr lang="en-US" sz="1200" b="1" dirty="0">
+              <a:rPr lang="en-US" sz="1050" b="1" dirty="0">
+                <a:solidFill>
+                  <a:schemeClr val="accent2"/>
+                </a:solidFill>
+              </a:rPr>
+              <a:t>Guideline Guard</a:t>
+            </a:r>
+            <a:endParaRPr lang="en-US" sz="1050" dirty="0"/>
+          </a:p>
+        </p:txBody>
+      </p:sp>
+      <p:sp>
+        <p:nvSpPr>
+          <p:cNvPr id="31" name="Guideline Guard line"/>
+          <p:cNvSpPr txBox="1"/>
+          <p:nvPr/>
+        </p:nvSpPr>
+        <p:spPr>
+          <a:xfrm>
+            <a:off x="5897880" y="2907792"/>
+            <a:ext cx="2788920" cy="365760"/>
+          </a:xfrm>
+          <a:prstGeom prst="rect">
+            <a:avLst/>
+          </a:prstGeom>
+          <a:noFill/>
+          <a:ln/>
+        </p:spPr>
+        <p:txBody>
+          <a:bodyPr wrap="square" lIns="0" tIns="0" rIns="0" bIns="0" rtlCol="0" anchor="t"/>
+          <a:lstStyle/>
+          <a:p>
+            <a:pPr indent="0" marL="0">
+              <a:buNone/>
+            </a:pPr>
+            <a:r>
+              <a:rPr lang="en-US" sz="950" dirty="0">
                 <a:solidFill>
                   <a:schemeClr val="tx1"/>
                 </a:solidFill>
               </a:rPr>
-              <a:t>Guideline Guard</a:t>
-            </a:r>
-            <a:endParaRPr lang="en-US" sz="1200" dirty="0"/>
-          </a:p>
-          <a:p>
-            <a:pPr indent="0" marL="0">
-              <a:buNone/>
-            </a:pPr>
-            <a:r>
-              <a:rPr lang="en-US" sz="1000" dirty="0">
-                <a:solidFill>
-                  <a:schemeClr val="tx2"/>
-                </a:solidFill>
-              </a:rPr>
-              <a:t>Client guidelines on the prebill</a:t>
-            </a:r>
-            <a:endParaRPr lang="en-US" sz="1200" dirty="0"/>
-          </a:p>
-        </p:txBody>
-      </p:sp>
-      <p:sp>
-        <p:nvSpPr>
-          <p:cNvPr id="24" name="Hour Catch entry"/>
-          <p:cNvSpPr txBox="1"/>
-          <p:nvPr/>
-        </p:nvSpPr>
-        <p:spPr>
-          <a:xfrm>
-            <a:off x="5596128" y="2322576"/>
-            <a:ext cx="1389888" cy="603504"/>
+              <a:t>Checks each prebill against that client's own guidelines and proposes the fix.</a:t>
+            </a:r>
+            <a:endParaRPr lang="en-US" sz="950" dirty="0"/>
+          </a:p>
+        </p:txBody>
+      </p:sp>
+      <p:sp>
+        <p:nvSpPr>
+          <p:cNvPr id="32" name="Hour Catch name"/>
+          <p:cNvSpPr txBox="1"/>
+          <p:nvPr/>
+        </p:nvSpPr>
+        <p:spPr>
+          <a:xfrm>
+            <a:off x="4663440" y="3291840"/>
+            <a:ext cx="1188720" cy="365760"/>
           </a:xfrm>
           <a:prstGeom prst="rect">
             <a:avLst/>
@@ -2136,102 +2300,99 @@
               <a:buNone/>
             </a:pPr>
             <a:r>
-              <a:rPr lang="en-US" sz="1200" b="1" dirty="0">
+              <a:rPr lang="en-US" sz="1050" b="1" dirty="0">
                 <a:solidFill>
                   <a:schemeClr val="tx1"/>
                 </a:solidFill>
               </a:rPr>
               <a:t>Hour Catch</a:t>
             </a:r>
-            <a:endParaRPr lang="en-US" sz="1200" dirty="0"/>
-          </a:p>
-          <a:p>
-            <a:pPr indent="0" marL="0">
-              <a:buNone/>
-            </a:pPr>
-            <a:r>
-              <a:rPr lang="en-US" sz="1000" dirty="0">
-                <a:solidFill>
-                  <a:schemeClr val="tx2"/>
-                </a:solidFill>
-              </a:rPr>
-              <a:t>Missed time, drafted</a:t>
-            </a:r>
-            <a:endParaRPr lang="en-US" sz="1200" dirty="0"/>
-          </a:p>
-        </p:txBody>
-      </p:sp>
-      <p:sp>
-        <p:nvSpPr>
-          <p:cNvPr id="25" name="Firm strategy and knowledge column"/>
-          <p:cNvSpPr/>
-          <p:nvPr/>
-        </p:nvSpPr>
-        <p:spPr>
-          <a:xfrm>
-            <a:off x="7187184" y="1188720"/>
-            <a:ext cx="1572768" cy="3127248"/>
-          </a:xfrm>
-          <a:prstGeom prst="rect">
-            <a:avLst/>
-          </a:prstGeom>
-          <a:solidFill>
-            <a:schemeClr val="bg2"/>
-          </a:solidFill>
-          <a:ln w="12700">
-            <a:solidFill>
-              <a:schemeClr val="bg2"/>
-            </a:solidFill>
-            <a:prstDash val="solid"/>
-          </a:ln>
-        </p:spPr>
-      </p:sp>
-      <p:sp>
-        <p:nvSpPr>
-          <p:cNvPr id="26" name="Firm strategy and knowledge heading"/>
-          <p:cNvSpPr txBox="1"/>
-          <p:nvPr/>
-        </p:nvSpPr>
-        <p:spPr>
-          <a:xfrm>
-            <a:off x="7278624" y="1243584"/>
-            <a:ext cx="1389888" cy="365760"/>
-          </a:xfrm>
-          <a:prstGeom prst="rect">
-            <a:avLst/>
-          </a:prstGeom>
-          <a:noFill/>
-          <a:ln/>
-        </p:spPr>
-        <p:txBody>
-          <a:bodyPr wrap="square" lIns="0" tIns="0" rIns="0" bIns="0" rtlCol="0" anchor="ctr"/>
-          <a:lstStyle/>
-          <a:p>
-            <a:pPr indent="0" marL="0">
-              <a:buNone/>
-            </a:pPr>
-            <a:r>
-              <a:rPr lang="en-US" sz="1100" b="1" dirty="0">
+            <a:endParaRPr lang="en-US" sz="1050" dirty="0"/>
+          </a:p>
+        </p:txBody>
+      </p:sp>
+      <p:sp>
+        <p:nvSpPr>
+          <p:cNvPr id="33" name="Hour Catch line"/>
+          <p:cNvSpPr txBox="1"/>
+          <p:nvPr/>
+        </p:nvSpPr>
+        <p:spPr>
+          <a:xfrm>
+            <a:off x="5897880" y="3291840"/>
+            <a:ext cx="2788920" cy="365760"/>
+          </a:xfrm>
+          <a:prstGeom prst="rect">
+            <a:avLst/>
+          </a:prstGeom>
+          <a:noFill/>
+          <a:ln/>
+        </p:spPr>
+        <p:txBody>
+          <a:bodyPr wrap="square" lIns="0" tIns="0" rIns="0" bIns="0" rtlCol="0" anchor="t"/>
+          <a:lstStyle/>
+          <a:p>
+            <a:pPr indent="0" marL="0">
+              <a:buNone/>
+            </a:pPr>
+            <a:r>
+              <a:rPr lang="en-US" sz="950" dirty="0">
+                <a:solidFill>
+                  <a:schemeClr val="tx1"/>
+                </a:solidFill>
+              </a:rPr>
+              <a:t>Reads a lawyer's day in Outlook and Teams and drafts the time entries that would be lost.</a:t>
+            </a:r>
+            <a:endParaRPr lang="en-US" sz="950" dirty="0"/>
+          </a:p>
+        </p:txBody>
+      </p:sp>
+      <p:sp>
+        <p:nvSpPr>
+          <p:cNvPr id="34" name="Firm strategy and marketing heading"/>
+          <p:cNvSpPr txBox="1"/>
+          <p:nvPr/>
+        </p:nvSpPr>
+        <p:spPr>
+          <a:xfrm>
+            <a:off x="4663440" y="3749040"/>
+            <a:ext cx="4023360" cy="219456"/>
+          </a:xfrm>
+          <a:prstGeom prst="rect">
+            <a:avLst/>
+          </a:prstGeom>
+          <a:noFill/>
+          <a:ln/>
+        </p:spPr>
+        <p:txBody>
+          <a:bodyPr wrap="square" lIns="0" tIns="0" rIns="0" bIns="0" rtlCol="0" anchor="b"/>
+          <a:lstStyle/>
+          <a:p>
+            <a:pPr indent="0" marL="0">
+              <a:buNone/>
+            </a:pPr>
+            <a:r>
+              <a:rPr lang="en-US" sz="900" b="1" spc="150" kern="0" dirty="0">
                 <a:solidFill>
                   <a:schemeClr val="accent5"/>
                 </a:solidFill>
               </a:rPr>
-              <a:t>Firm strategy and knowledge</a:t>
-            </a:r>
-            <a:endParaRPr lang="en-US" sz="1100" dirty="0"/>
-          </a:p>
-        </p:txBody>
-      </p:sp>
-      <p:sp>
-        <p:nvSpPr>
-          <p:cNvPr id="27" name="Praxis entry"/>
-          <p:cNvSpPr txBox="1"/>
-          <p:nvPr/>
-        </p:nvSpPr>
-        <p:spPr>
-          <a:xfrm>
-            <a:off x="7278624" y="1682496"/>
-            <a:ext cx="1389888" cy="603504"/>
+              <a:t>FIRM STRATEGY AND MARKETING</a:t>
+            </a:r>
+            <a:endParaRPr lang="en-US" sz="900" dirty="0"/>
+          </a:p>
+        </p:txBody>
+      </p:sp>
+      <p:sp>
+        <p:nvSpPr>
+          <p:cNvPr id="35" name="Praxis name"/>
+          <p:cNvSpPr txBox="1"/>
+          <p:nvPr/>
+        </p:nvSpPr>
+        <p:spPr>
+          <a:xfrm>
+            <a:off x="4663440" y="3995928"/>
+            <a:ext cx="1188720" cy="365760"/>
           </a:xfrm>
           <a:prstGeom prst="rect">
             <a:avLst/>
@@ -2247,41 +2408,27 @@
               <a:buNone/>
             </a:pPr>
             <a:r>
-              <a:rPr lang="en-US" sz="1200" b="1" dirty="0">
+              <a:rPr lang="en-US" sz="1050" b="1" dirty="0">
                 <a:solidFill>
                   <a:schemeClr val="tx1"/>
                 </a:solidFill>
               </a:rPr>
               <a:t>Praxis</a:t>
             </a:r>
-            <a:endParaRPr lang="en-US" sz="1200" dirty="0"/>
-          </a:p>
-          <a:p>
-            <a:pPr indent="0" marL="0">
-              <a:buNone/>
-            </a:pPr>
-            <a:r>
-              <a:rPr lang="en-US" sz="1000" dirty="0">
-                <a:solidFill>
-                  <a:schemeClr val="tx2"/>
-                </a:solidFill>
-              </a:rPr>
-              <a:t>Scores AI ideas, runs pilots</a:t>
-            </a:r>
-            <a:endParaRPr lang="en-US" sz="1200" dirty="0"/>
-          </a:p>
-        </p:txBody>
-      </p:sp>
-      <p:sp>
-        <p:nvSpPr>
-          <p:cNvPr id="28" name="Marketing Studio entry"/>
-          <p:cNvSpPr txBox="1"/>
-          <p:nvPr/>
-        </p:nvSpPr>
-        <p:spPr>
-          <a:xfrm>
-            <a:off x="7278624" y="2322576"/>
-            <a:ext cx="1389888" cy="603504"/>
+            <a:endParaRPr lang="en-US" sz="1050" dirty="0"/>
+          </a:p>
+        </p:txBody>
+      </p:sp>
+      <p:sp>
+        <p:nvSpPr>
+          <p:cNvPr id="36" name="Praxis line"/>
+          <p:cNvSpPr txBox="1"/>
+          <p:nvPr/>
+        </p:nvSpPr>
+        <p:spPr>
+          <a:xfrm>
+            <a:off x="5897880" y="3995928"/>
+            <a:ext cx="2788920" cy="365760"/>
           </a:xfrm>
           <a:prstGeom prst="rect">
             <a:avLst/>
@@ -2297,99 +2444,72 @@
               <a:buNone/>
             </a:pPr>
             <a:r>
-              <a:rPr lang="en-US" sz="1200" b="1" dirty="0">
+              <a:rPr lang="en-US" sz="950" dirty="0">
                 <a:solidFill>
                   <a:schemeClr val="tx1"/>
                 </a:solidFill>
               </a:rPr>
+              <a:t>Lets leadership compare AI ideas on impact, risk and effort, and track the pilots.</a:t>
+            </a:r>
+            <a:endParaRPr lang="en-US" sz="950" dirty="0"/>
+          </a:p>
+        </p:txBody>
+      </p:sp>
+      <p:sp>
+        <p:nvSpPr>
+          <p:cNvPr id="37" name="Marketing Studio name"/>
+          <p:cNvSpPr txBox="1"/>
+          <p:nvPr/>
+        </p:nvSpPr>
+        <p:spPr>
+          <a:xfrm>
+            <a:off x="4663440" y="4379976"/>
+            <a:ext cx="1188720" cy="365760"/>
+          </a:xfrm>
+          <a:prstGeom prst="rect">
+            <a:avLst/>
+          </a:prstGeom>
+          <a:noFill/>
+          <a:ln/>
+        </p:spPr>
+        <p:txBody>
+          <a:bodyPr wrap="square" lIns="0" tIns="0" rIns="0" bIns="0" rtlCol="0" anchor="t"/>
+          <a:lstStyle/>
+          <a:p>
+            <a:pPr indent="0" marL="0">
+              <a:buNone/>
+            </a:pPr>
+            <a:r>
+              <a:rPr lang="en-US" sz="1050" b="1" dirty="0">
+                <a:solidFill>
+                  <a:schemeClr val="accent2"/>
+                </a:solidFill>
+              </a:rPr>
               <a:t>Marketing Studio</a:t>
             </a:r>
-            <a:endParaRPr lang="en-US" sz="1200" dirty="0"/>
-          </a:p>
-          <a:p>
-            <a:pPr indent="0" marL="0">
-              <a:buNone/>
-            </a:pPr>
-            <a:r>
-              <a:rPr lang="en-US" sz="1000" dirty="0">
-                <a:solidFill>
-                  <a:schemeClr val="tx2"/>
-                </a:solidFill>
-              </a:rPr>
-              <a:t>Bios, alerts and RFPs, checked</a:t>
-            </a:r>
-            <a:endParaRPr lang="en-US" sz="1200" dirty="0"/>
-          </a:p>
-        </p:txBody>
-      </p:sp>
-      <p:sp>
-        <p:nvSpPr>
-          <p:cNvPr id="29" name="icon square"/>
-          <p:cNvSpPr/>
-          <p:nvPr/>
-        </p:nvSpPr>
-        <p:spPr>
-          <a:xfrm>
-            <a:off x="457200" y="4462272"/>
-            <a:ext cx="274320" cy="274320"/>
-          </a:xfrm>
-          <a:prstGeom prst="rect">
-            <a:avLst/>
-          </a:prstGeom>
-          <a:solidFill>
-            <a:schemeClr val="accent1"/>
-          </a:solidFill>
-          <a:ln w="12700">
-            <a:solidFill>
-              <a:schemeClr val="accent1"/>
-            </a:solidFill>
-            <a:prstDash val="solid"/>
-          </a:ln>
-        </p:spPr>
-      </p:sp>
-      <p:pic>
-        <p:nvPicPr>
-          <p:cNvPr id="30" name="lock icon" descr="preencoded.png">    </p:cNvPr>
-          <p:cNvPicPr>
-            <a:picLocks noChangeAspect="1"/>
-          </p:cNvPicPr>
-          <p:nvPr/>
-        </p:nvPicPr>
-        <p:blipFill>
-          <a:blip r:embed="rId1"/>
-          <a:stretch>
-            <a:fillRect/>
-          </a:stretch>
-        </p:blipFill>
-        <p:spPr>
-          <a:xfrm>
-            <a:off x="517550" y="4522622"/>
-            <a:ext cx="153619" cy="153619"/>
-          </a:xfrm>
-          <a:prstGeom prst="rect">
-            <a:avLst/>
-          </a:prstGeom>
-        </p:spPr>
-      </p:pic>
-      <p:sp>
-        <p:nvSpPr>
-          <p:cNvPr id="31" name="IT strip lock"/>
-          <p:cNvSpPr txBox="1"/>
-          <p:nvPr/>
-        </p:nvSpPr>
-        <p:spPr>
-          <a:xfrm>
-            <a:off x="786384" y="4425696"/>
-            <a:ext cx="1353312" cy="365760"/>
-          </a:xfrm>
-          <a:prstGeom prst="rect">
-            <a:avLst/>
-          </a:prstGeom>
-          <a:noFill/>
-          <a:ln/>
-        </p:spPr>
-        <p:txBody>
-          <a:bodyPr wrap="square" lIns="0" tIns="0" rIns="0" bIns="0" rtlCol="0" anchor="ctr"/>
+            <a:endParaRPr lang="en-US" sz="1050" dirty="0"/>
+          </a:p>
+        </p:txBody>
+      </p:sp>
+      <p:sp>
+        <p:nvSpPr>
+          <p:cNvPr id="38" name="Marketing Studio line"/>
+          <p:cNvSpPr txBox="1"/>
+          <p:nvPr/>
+        </p:nvSpPr>
+        <p:spPr>
+          <a:xfrm>
+            <a:off x="5897880" y="4379976"/>
+            <a:ext cx="2788920" cy="365760"/>
+          </a:xfrm>
+          <a:prstGeom prst="rect">
+            <a:avLst/>
+          </a:prstGeom>
+          <a:noFill/>
+          <a:ln/>
+        </p:spPr>
+        <p:txBody>
+          <a:bodyPr wrap="square" lIns="0" tIns="0" rIns="0" bIns="0" rtlCol="0" anchor="t"/>
           <a:lstStyle/>
           <a:p>
             <a:pPr indent="0" marL="0">
@@ -2398,350 +2518,10 @@
             <a:r>
               <a:rPr lang="en-US" sz="950" dirty="0">
                 <a:solidFill>
-                  <a:schemeClr val="tx2"/>
-                </a:solidFill>
-              </a:rPr>
-              <a:t>Data stays on firm hardware</a:t>
-            </a:r>
-            <a:endParaRPr lang="en-US" sz="950" dirty="0"/>
-          </a:p>
-        </p:txBody>
-      </p:sp>
-      <p:sp>
-        <p:nvSpPr>
-          <p:cNvPr id="32" name="icon square"/>
-          <p:cNvSpPr/>
-          <p:nvPr/>
-        </p:nvSpPr>
-        <p:spPr>
-          <a:xfrm>
-            <a:off x="2157984" y="4462272"/>
-            <a:ext cx="274320" cy="274320"/>
-          </a:xfrm>
-          <a:prstGeom prst="rect">
-            <a:avLst/>
-          </a:prstGeom>
-          <a:solidFill>
-            <a:schemeClr val="accent1"/>
-          </a:solidFill>
-          <a:ln w="12700">
-            <a:solidFill>
-              <a:schemeClr val="accent1"/>
-            </a:solidFill>
-            <a:prstDash val="solid"/>
-          </a:ln>
-        </p:spPr>
-      </p:sp>
-      <p:pic>
-        <p:nvPicPr>
-          <p:cNvPr id="33" name="users icon" descr="preencoded.png">    </p:cNvPr>
-          <p:cNvPicPr>
-            <a:picLocks noChangeAspect="1"/>
-          </p:cNvPicPr>
-          <p:nvPr/>
-        </p:nvPicPr>
-        <p:blipFill>
-          <a:blip r:embed="rId2"/>
-          <a:stretch>
-            <a:fillRect/>
-          </a:stretch>
-        </p:blipFill>
-        <p:spPr>
-          <a:xfrm>
-            <a:off x="2218334" y="4522622"/>
-            <a:ext cx="153619" cy="153619"/>
-          </a:xfrm>
-          <a:prstGeom prst="rect">
-            <a:avLst/>
-          </a:prstGeom>
-        </p:spPr>
-      </p:pic>
-      <p:sp>
-        <p:nvSpPr>
-          <p:cNvPr id="34" name="IT strip users"/>
-          <p:cNvSpPr txBox="1"/>
-          <p:nvPr/>
-        </p:nvSpPr>
-        <p:spPr>
-          <a:xfrm>
-            <a:off x="2487168" y="4425696"/>
-            <a:ext cx="1353312" cy="365760"/>
-          </a:xfrm>
-          <a:prstGeom prst="rect">
-            <a:avLst/>
-          </a:prstGeom>
-          <a:noFill/>
-          <a:ln/>
-        </p:spPr>
-        <p:txBody>
-          <a:bodyPr wrap="square" lIns="0" tIns="0" rIns="0" bIns="0" rtlCol="0" anchor="ctr"/>
-          <a:lstStyle/>
-          <a:p>
-            <a:pPr indent="0" marL="0">
-              <a:buNone/>
-            </a:pPr>
-            <a:r>
-              <a:rPr lang="en-US" sz="950" dirty="0">
-                <a:solidFill>
-                  <a:schemeClr val="tx2"/>
-                </a:solidFill>
-              </a:rPr>
-              <a:t>Sign-on and roles</a:t>
-            </a:r>
-            <a:endParaRPr lang="en-US" sz="950" dirty="0"/>
-          </a:p>
-        </p:txBody>
-      </p:sp>
-      <p:sp>
-        <p:nvSpPr>
-          <p:cNvPr id="35" name="icon square"/>
-          <p:cNvSpPr/>
-          <p:nvPr/>
-        </p:nvSpPr>
-        <p:spPr>
-          <a:xfrm>
-            <a:off x="3858768" y="4462272"/>
-            <a:ext cx="274320" cy="274320"/>
-          </a:xfrm>
-          <a:prstGeom prst="rect">
-            <a:avLst/>
-          </a:prstGeom>
-          <a:solidFill>
-            <a:schemeClr val="accent1"/>
-          </a:solidFill>
-          <a:ln w="12700">
-            <a:solidFill>
-              <a:schemeClr val="accent1"/>
-            </a:solidFill>
-            <a:prstDash val="solid"/>
-          </a:ln>
-        </p:spPr>
-      </p:sp>
-      <p:pic>
-        <p:nvPicPr>
-          <p:cNvPr id="36" name="shield icon" descr="preencoded.png">    </p:cNvPr>
-          <p:cNvPicPr>
-            <a:picLocks noChangeAspect="1"/>
-          </p:cNvPicPr>
-          <p:nvPr/>
-        </p:nvPicPr>
-        <p:blipFill>
-          <a:blip r:embed="rId3"/>
-          <a:stretch>
-            <a:fillRect/>
-          </a:stretch>
-        </p:blipFill>
-        <p:spPr>
-          <a:xfrm>
-            <a:off x="3919118" y="4522622"/>
-            <a:ext cx="153619" cy="153619"/>
-          </a:xfrm>
-          <a:prstGeom prst="rect">
-            <a:avLst/>
-          </a:prstGeom>
-        </p:spPr>
-      </p:pic>
-      <p:sp>
-        <p:nvSpPr>
-          <p:cNvPr id="37" name="IT strip shield"/>
-          <p:cNvSpPr txBox="1"/>
-          <p:nvPr/>
-        </p:nvSpPr>
-        <p:spPr>
-          <a:xfrm>
-            <a:off x="4187952" y="4425696"/>
-            <a:ext cx="1353312" cy="365760"/>
-          </a:xfrm>
-          <a:prstGeom prst="rect">
-            <a:avLst/>
-          </a:prstGeom>
-          <a:noFill/>
-          <a:ln/>
-        </p:spPr>
-        <p:txBody>
-          <a:bodyPr wrap="square" lIns="0" tIns="0" rIns="0" bIns="0" rtlCol="0" anchor="ctr"/>
-          <a:lstStyle/>
-          <a:p>
-            <a:pPr indent="0" marL="0">
-              <a:buNone/>
-            </a:pPr>
-            <a:r>
-              <a:rPr lang="en-US" sz="950" dirty="0">
-                <a:solidFill>
-                  <a:schemeClr val="tx2"/>
-                </a:solidFill>
-              </a:rPr>
-              <a:t>Ethical walls</a:t>
-            </a:r>
-            <a:endParaRPr lang="en-US" sz="950" dirty="0"/>
-          </a:p>
-        </p:txBody>
-      </p:sp>
-      <p:sp>
-        <p:nvSpPr>
-          <p:cNvPr id="38" name="icon square"/>
-          <p:cNvSpPr/>
-          <p:nvPr/>
-        </p:nvSpPr>
-        <p:spPr>
-          <a:xfrm>
-            <a:off x="5559552" y="4462272"/>
-            <a:ext cx="274320" cy="274320"/>
-          </a:xfrm>
-          <a:prstGeom prst="rect">
-            <a:avLst/>
-          </a:prstGeom>
-          <a:solidFill>
-            <a:schemeClr val="accent1"/>
-          </a:solidFill>
-          <a:ln w="12700">
-            <a:solidFill>
-              <a:schemeClr val="accent1"/>
-            </a:solidFill>
-            <a:prstDash val="solid"/>
-          </a:ln>
-        </p:spPr>
-      </p:sp>
-      <p:pic>
-        <p:nvPicPr>
-          <p:cNvPr id="39" name="list icon" descr="preencoded.png">    </p:cNvPr>
-          <p:cNvPicPr>
-            <a:picLocks noChangeAspect="1"/>
-          </p:cNvPicPr>
-          <p:nvPr/>
-        </p:nvPicPr>
-        <p:blipFill>
-          <a:blip r:embed="rId4"/>
-          <a:stretch>
-            <a:fillRect/>
-          </a:stretch>
-        </p:blipFill>
-        <p:spPr>
-          <a:xfrm>
-            <a:off x="5619902" y="4522622"/>
-            <a:ext cx="153619" cy="153619"/>
-          </a:xfrm>
-          <a:prstGeom prst="rect">
-            <a:avLst/>
-          </a:prstGeom>
-        </p:spPr>
-      </p:pic>
-      <p:sp>
-        <p:nvSpPr>
-          <p:cNvPr id="40" name="IT strip list"/>
-          <p:cNvSpPr txBox="1"/>
-          <p:nvPr/>
-        </p:nvSpPr>
-        <p:spPr>
-          <a:xfrm>
-            <a:off x="5888736" y="4425696"/>
-            <a:ext cx="1353312" cy="365760"/>
-          </a:xfrm>
-          <a:prstGeom prst="rect">
-            <a:avLst/>
-          </a:prstGeom>
-          <a:noFill/>
-          <a:ln/>
-        </p:spPr>
-        <p:txBody>
-          <a:bodyPr wrap="square" lIns="0" tIns="0" rIns="0" bIns="0" rtlCol="0" anchor="ctr"/>
-          <a:lstStyle/>
-          <a:p>
-            <a:pPr indent="0" marL="0">
-              <a:buNone/>
-            </a:pPr>
-            <a:r>
-              <a:rPr lang="en-US" sz="950" dirty="0">
-                <a:solidFill>
-                  <a:schemeClr val="tx2"/>
-                </a:solidFill>
-              </a:rPr>
-              <a:t>Audit trail</a:t>
-            </a:r>
-            <a:endParaRPr lang="en-US" sz="950" dirty="0"/>
-          </a:p>
-        </p:txBody>
-      </p:sp>
-      <p:sp>
-        <p:nvSpPr>
-          <p:cNvPr id="41" name="icon square"/>
-          <p:cNvSpPr/>
-          <p:nvPr/>
-        </p:nvSpPr>
-        <p:spPr>
-          <a:xfrm>
-            <a:off x="7260336" y="4462272"/>
-            <a:ext cx="274320" cy="274320"/>
-          </a:xfrm>
-          <a:prstGeom prst="rect">
-            <a:avLst/>
-          </a:prstGeom>
-          <a:solidFill>
-            <a:schemeClr val="accent1"/>
-          </a:solidFill>
-          <a:ln w="12700">
-            <a:solidFill>
-              <a:schemeClr val="accent1"/>
-            </a:solidFill>
-            <a:prstDash val="solid"/>
-          </a:ln>
-        </p:spPr>
-      </p:sp>
-      <p:pic>
-        <p:nvPicPr>
-          <p:cNvPr id="42" name="check icon" descr="preencoded.png">    </p:cNvPr>
-          <p:cNvPicPr>
-            <a:picLocks noChangeAspect="1"/>
-          </p:cNvPicPr>
-          <p:nvPr/>
-        </p:nvPicPr>
-        <p:blipFill>
-          <a:blip r:embed="rId5"/>
-          <a:stretch>
-            <a:fillRect/>
-          </a:stretch>
-        </p:blipFill>
-        <p:spPr>
-          <a:xfrm>
-            <a:off x="7320686" y="4522622"/>
-            <a:ext cx="153619" cy="153619"/>
-          </a:xfrm>
-          <a:prstGeom prst="rect">
-            <a:avLst/>
-          </a:prstGeom>
-        </p:spPr>
-      </p:pic>
-      <p:sp>
-        <p:nvSpPr>
-          <p:cNvPr id="43" name="IT strip check"/>
-          <p:cNvSpPr txBox="1"/>
-          <p:nvPr/>
-        </p:nvSpPr>
-        <p:spPr>
-          <a:xfrm>
-            <a:off x="7589520" y="4425696"/>
-            <a:ext cx="1353312" cy="365760"/>
-          </a:xfrm>
-          <a:prstGeom prst="rect">
-            <a:avLst/>
-          </a:prstGeom>
-          <a:noFill/>
-          <a:ln/>
-        </p:spPr>
-        <p:txBody>
-          <a:bodyPr wrap="square" lIns="0" tIns="0" rIns="0" bIns="0" rtlCol="0" anchor="ctr"/>
-          <a:lstStyle/>
-          <a:p>
-            <a:pPr indent="0" marL="0">
-              <a:buNone/>
-            </a:pPr>
-            <a:r>
-              <a:rPr lang="en-US" sz="950" dirty="0">
-                <a:solidFill>
-                  <a:schemeClr val="tx2"/>
-                </a:solidFill>
-              </a:rPr>
-              <a:t>Tests and docs for IT</a:t>
+                  <a:schemeClr val="tx1"/>
+                </a:solidFill>
+              </a:rPr>
+              <a:t>Drafts bios, client alerts and RFP responses in the firm's voice, then checks the rules.</a:t>
             </a:r>
             <a:endParaRPr lang="en-US" sz="950" dirty="0"/>
           </a:p>
@@ -2849,7 +2629,7 @@
                   <a:srgbClr val="2D4459"/>
                 </a:solidFill>
               </a:rPr>
-              <a:t>Four quick wins on what we already license</a:t>
+              <a:t>Three of them could be used right away</a:t>
             </a:r>
             <a:endParaRPr lang="en-US" sz="2600" dirty="0"/>
           </a:p>
@@ -2887,7 +2667,7 @@
                   <a:schemeClr val="tx2"/>
                 </a:solidFill>
               </a:rPr>
-              <a:t>Ideas, not a plan. Each uses data the firm already holds, and a person reviews every output.</a:t>
+              <a:t>None needs a connection to firm systems. Each runs in a browser on an approved account, and a person reviews every output.</a:t>
             </a:r>
             <a:endParaRPr lang="en-US" sz="1300" dirty="0"/>
           </a:p>
@@ -2895,14 +2675,14 @@
       </p:sp>
       <p:sp>
         <p:nvSpPr>
-          <p:cNvPr id="4" name="Client guidelines brief card"/>
+          <p:cNvPr id="4" name="Guideline Guard card"/>
           <p:cNvSpPr/>
           <p:nvPr/>
         </p:nvSpPr>
         <p:spPr>
           <a:xfrm>
-            <a:off x="457200" y="1234440"/>
-            <a:ext cx="4023360" cy="1645920"/>
+            <a:off x="457200" y="1280160"/>
+            <a:ext cx="2651760" cy="3383280"/>
           </a:xfrm>
           <a:prstGeom prst="rect">
             <a:avLst/>
@@ -2926,7 +2706,7 @@
         </p:nvSpPr>
         <p:spPr>
           <a:xfrm>
-            <a:off x="594360" y="1371600"/>
+            <a:off x="594360" y="1417320"/>
             <a:ext cx="384048" cy="384048"/>
           </a:xfrm>
           <a:prstGeom prst="rect">
@@ -2945,7 +2725,7 @@
       </p:sp>
       <p:pic>
         <p:nvPicPr>
-          <p:cNvPr id="6" name="book icon" descr="preencoded.png">    </p:cNvPr>
+          <p:cNvPr id="6" name="dollar icon" descr="preencoded.png">    </p:cNvPr>
           <p:cNvPicPr>
             <a:picLocks noChangeAspect="1"/>
           </p:cNvPicPr>
@@ -2959,7 +2739,7 @@
         </p:blipFill>
         <p:spPr>
           <a:xfrm>
-            <a:off x="678851" y="1456091"/>
+            <a:off x="678851" y="1501811"/>
             <a:ext cx="215067" cy="215067"/>
           </a:xfrm>
           <a:prstGeom prst="rect">
@@ -2969,14 +2749,14 @@
       </p:pic>
       <p:sp>
         <p:nvSpPr>
-          <p:cNvPr id="7" name="Client guidelines brief name"/>
-          <p:cNvSpPr txBox="1"/>
-          <p:nvPr/>
-        </p:nvSpPr>
-        <p:spPr>
-          <a:xfrm>
-            <a:off x="1097280" y="1344168"/>
-            <a:ext cx="3246120" cy="438912"/>
+          <p:cNvPr id="7" name="Guideline Guard name"/>
+          <p:cNvSpPr txBox="1"/>
+          <p:nvPr/>
+        </p:nvSpPr>
+        <p:spPr>
+          <a:xfrm>
+            <a:off x="1097280" y="1389888"/>
+            <a:ext cx="1874520" cy="438912"/>
           </a:xfrm>
           <a:prstGeom prst="rect">
             <a:avLst/>
@@ -2997,7 +2777,7 @@
                   <a:schemeClr val="tx1"/>
                 </a:solidFill>
               </a:rPr>
-              <a:t>Client guidelines brief</a:t>
+              <a:t>Guideline Guard</a:t>
             </a:r>
             <a:endParaRPr lang="en-US" sz="1400" dirty="0"/>
           </a:p>
@@ -3005,14 +2785,14 @@
       </p:sp>
       <p:sp>
         <p:nvSpPr>
-          <p:cNvPr id="8" name="Client guidelines brief what"/>
-          <p:cNvSpPr txBox="1"/>
-          <p:nvPr/>
-        </p:nvSpPr>
-        <p:spPr>
-          <a:xfrm>
-            <a:off x="594360" y="1892808"/>
-            <a:ext cx="3749040" cy="868680"/>
+          <p:cNvPr id="8" name="Guideline Guard what"/>
+          <p:cNvSpPr txBox="1"/>
+          <p:nvPr/>
+        </p:nvSpPr>
+        <p:spPr>
+          <a:xfrm>
+            <a:off x="594360" y="1965960"/>
+            <a:ext cx="2377440" cy="1143000"/>
           </a:xfrm>
           <a:prstGeom prst="rect">
             <a:avLst/>
@@ -3028,27 +2808,121 @@
               <a:buNone/>
             </a:pPr>
             <a:r>
-              <a:rPr lang="en-US" sz="1300" dirty="0">
+              <a:rPr lang="en-US" sz="1150" dirty="0">
                 <a:solidFill>
                   <a:schemeClr val="tx1"/>
                 </a:solidFill>
               </a:rPr>
-              <a:t>Each client's billing rules on one page, and entries that break them flagged before the invoice goes out.</a:t>
-            </a:r>
-            <a:endParaRPr lang="en-US" sz="1300" dirty="0"/>
-          </a:p>
-        </p:txBody>
-      </p:sp>
-      <p:sp>
-        <p:nvSpPr>
-          <p:cNvPr id="9" name="Pre-bill reviewer card"/>
+              <a:t>Checks each prebill against that client's outside counsel guidelines, quotes the rule it applies and proposes the fix.</a:t>
+            </a:r>
+            <a:endParaRPr lang="en-US" sz="1150" dirty="0"/>
+          </a:p>
+        </p:txBody>
+      </p:sp>
+      <p:sp>
+        <p:nvSpPr>
+          <p:cNvPr id="9" name="Guideline Guard helps"/>
+          <p:cNvSpPr txBox="1"/>
+          <p:nvPr/>
+        </p:nvSpPr>
+        <p:spPr>
+          <a:xfrm>
+            <a:off x="594360" y="3154680"/>
+            <a:ext cx="2377440" cy="731520"/>
+          </a:xfrm>
+          <a:prstGeom prst="rect">
+            <a:avLst/>
+          </a:prstGeom>
+          <a:noFill/>
+          <a:ln/>
+        </p:spPr>
+        <p:txBody>
+          <a:bodyPr wrap="square" lIns="0" tIns="0" rIns="0" bIns="0" rtlCol="0" anchor="t"/>
+          <a:lstStyle/>
+          <a:p>
+            <a:pPr indent="0" marL="0">
+              <a:buNone/>
+            </a:pPr>
+            <a:r>
+              <a:rPr lang="en-US" sz="1050" b="1" dirty="0">
+                <a:solidFill>
+                  <a:schemeClr val="accent5"/>
+                </a:solidFill>
+              </a:rPr>
+              <a:t>Helps: </a:t>
+            </a:r>
+            <a:pPr indent="0" marL="0">
+              <a:buNone/>
+            </a:pPr>
+            <a:r>
+              <a:rPr lang="en-US" sz="1050" dirty="0">
+                <a:solidFill>
+                  <a:schemeClr val="tx1"/>
+                </a:solidFill>
+              </a:rPr>
+              <a:t>Billing and responsible partners. Fewer write-offs and rejected invoices.</a:t>
+            </a:r>
+            <a:endParaRPr lang="en-US" sz="1050" dirty="0"/>
+          </a:p>
+        </p:txBody>
+      </p:sp>
+      <p:sp>
+        <p:nvSpPr>
+          <p:cNvPr id="10" name="Guideline Guard needs"/>
+          <p:cNvSpPr txBox="1"/>
+          <p:nvPr/>
+        </p:nvSpPr>
+        <p:spPr>
+          <a:xfrm>
+            <a:off x="594360" y="3931920"/>
+            <a:ext cx="2377440" cy="640080"/>
+          </a:xfrm>
+          <a:prstGeom prst="rect">
+            <a:avLst/>
+          </a:prstGeom>
+          <a:noFill/>
+          <a:ln/>
+        </p:spPr>
+        <p:txBody>
+          <a:bodyPr wrap="square" lIns="0" tIns="0" rIns="0" bIns="0" rtlCol="0" anchor="t"/>
+          <a:lstStyle/>
+          <a:p>
+            <a:pPr indent="0" marL="0">
+              <a:buNone/>
+            </a:pPr>
+            <a:r>
+              <a:rPr lang="en-US" sz="1050" b="1" dirty="0">
+                <a:solidFill>
+                  <a:schemeClr val="accent5"/>
+                </a:solidFill>
+              </a:rPr>
+              <a:t>To run it here: </a:t>
+            </a:r>
+            <a:pPr indent="0" marL="0">
+              <a:buNone/>
+            </a:pPr>
+            <a:r>
+              <a:rPr lang="en-US" sz="1050" dirty="0">
+                <a:solidFill>
+                  <a:schemeClr val="tx2"/>
+                </a:solidFill>
+              </a:rPr>
+              <a:t>The client's guidelines and the prebill.</a:t>
+            </a:r>
+            <a:endParaRPr lang="en-US" sz="1050" dirty="0"/>
+          </a:p>
+        </p:txBody>
+      </p:sp>
+      <p:sp>
+        <p:nvSpPr>
+          <p:cNvPr id="11" name="Party Finder card"/>
           <p:cNvSpPr/>
           <p:nvPr/>
         </p:nvSpPr>
         <p:spPr>
           <a:xfrm>
-            <a:off x="4663440" y="1234440"/>
-            <a:ext cx="4023360" cy="1645920"/>
+            <a:off x="3291840" y="1280160"/>
+            <a:ext cx="2651760" cy="3383280"/>
           </a:xfrm>
           <a:prstGeom prst="rect">
             <a:avLst/>
@@ -3066,13 +2940,13 @@
       </p:sp>
       <p:sp>
         <p:nvSpPr>
-          <p:cNvPr id="10" name="icon square"/>
+          <p:cNvPr id="12" name="icon square"/>
           <p:cNvSpPr/>
           <p:nvPr/>
         </p:nvSpPr>
         <p:spPr>
           <a:xfrm>
-            <a:off x="4800600" y="1371600"/>
+            <a:off x="3429000" y="1417320"/>
             <a:ext cx="384048" cy="384048"/>
           </a:xfrm>
           <a:prstGeom prst="rect">
@@ -3091,7 +2965,7 @@
       </p:sp>
       <p:pic>
         <p:nvPicPr>
-          <p:cNvPr id="11" name="dollar icon" descr="preencoded.png">    </p:cNvPr>
+          <p:cNvPr id="13" name="users icon" descr="preencoded.png">    </p:cNvPr>
           <p:cNvPicPr>
             <a:picLocks noChangeAspect="1"/>
           </p:cNvPicPr>
@@ -3105,7 +2979,7 @@
         </p:blipFill>
         <p:spPr>
           <a:xfrm>
-            <a:off x="4885091" y="1456091"/>
+            <a:off x="3513491" y="1501811"/>
             <a:ext cx="215067" cy="215067"/>
           </a:xfrm>
           <a:prstGeom prst="rect">
@@ -3115,14 +2989,14 @@
       </p:pic>
       <p:sp>
         <p:nvSpPr>
-          <p:cNvPr id="12" name="Pre-bill reviewer name"/>
-          <p:cNvSpPr txBox="1"/>
-          <p:nvPr/>
-        </p:nvSpPr>
-        <p:spPr>
-          <a:xfrm>
-            <a:off x="5303520" y="1344168"/>
-            <a:ext cx="3246120" cy="438912"/>
+          <p:cNvPr id="14" name="Party Finder name"/>
+          <p:cNvSpPr txBox="1"/>
+          <p:nvPr/>
+        </p:nvSpPr>
+        <p:spPr>
+          <a:xfrm>
+            <a:off x="3931920" y="1389888"/>
+            <a:ext cx="1874520" cy="438912"/>
           </a:xfrm>
           <a:prstGeom prst="rect">
             <a:avLst/>
@@ -3143,7 +3017,7 @@
                   <a:schemeClr val="tx1"/>
                 </a:solidFill>
               </a:rPr>
-              <a:t>Pre-bill reviewer</a:t>
+              <a:t>Party Finder</a:t>
             </a:r>
             <a:endParaRPr lang="en-US" sz="1400" dirty="0"/>
           </a:p>
@@ -3151,14 +3025,14 @@
       </p:sp>
       <p:sp>
         <p:nvSpPr>
-          <p:cNvPr id="13" name="Pre-bill reviewer what"/>
-          <p:cNvSpPr txBox="1"/>
-          <p:nvPr/>
-        </p:nvSpPr>
-        <p:spPr>
-          <a:xfrm>
-            <a:off x="4800600" y="1892808"/>
-            <a:ext cx="3749040" cy="868680"/>
+          <p:cNvPr id="15" name="Party Finder what"/>
+          <p:cNvSpPr txBox="1"/>
+          <p:nvPr/>
+        </p:nvSpPr>
+        <p:spPr>
+          <a:xfrm>
+            <a:off x="3429000" y="1965960"/>
+            <a:ext cx="2377440" cy="1143000"/>
           </a:xfrm>
           <a:prstGeom prst="rect">
             <a:avLst/>
@@ -3174,27 +3048,121 @@
               <a:buNone/>
             </a:pPr>
             <a:r>
-              <a:rPr lang="en-US" sz="1300" dirty="0">
+              <a:rPr lang="en-US" sz="1150" dirty="0">
                 <a:solidFill>
                   <a:schemeClr val="tx1"/>
                 </a:solidFill>
               </a:rPr>
-              <a:t>Flags vague or block-billed entries a client would reject, and suggests the rewrite.</a:t>
-            </a:r>
-            <a:endParaRPr lang="en-US" sz="1300" dirty="0"/>
-          </a:p>
-        </p:txBody>
-      </p:sp>
-      <p:sp>
-        <p:nvSpPr>
-          <p:cNvPr id="14" name="Matter handoff memo card"/>
+              <a:t>Reads the complaint, deal documents or engagement request and lists every name to search, each tied to the sentence it came from.</a:t>
+            </a:r>
+            <a:endParaRPr lang="en-US" sz="1150" dirty="0"/>
+          </a:p>
+        </p:txBody>
+      </p:sp>
+      <p:sp>
+        <p:nvSpPr>
+          <p:cNvPr id="16" name="Party Finder helps"/>
+          <p:cNvSpPr txBox="1"/>
+          <p:nvPr/>
+        </p:nvSpPr>
+        <p:spPr>
+          <a:xfrm>
+            <a:off x="3429000" y="3154680"/>
+            <a:ext cx="2377440" cy="731520"/>
+          </a:xfrm>
+          <a:prstGeom prst="rect">
+            <a:avLst/>
+          </a:prstGeom>
+          <a:noFill/>
+          <a:ln/>
+        </p:spPr>
+        <p:txBody>
+          <a:bodyPr wrap="square" lIns="0" tIns="0" rIns="0" bIns="0" rtlCol="0" anchor="t"/>
+          <a:lstStyle/>
+          <a:p>
+            <a:pPr indent="0" marL="0">
+              <a:buNone/>
+            </a:pPr>
+            <a:r>
+              <a:rPr lang="en-US" sz="1050" b="1" dirty="0">
+                <a:solidFill>
+                  <a:schemeClr val="accent5"/>
+                </a:solidFill>
+              </a:rPr>
+              <a:t>Helps: </a:t>
+            </a:r>
+            <a:pPr indent="0" marL="0">
+              <a:buNone/>
+            </a:pPr>
+            <a:r>
+              <a:rPr lang="en-US" sz="1050" dirty="0">
+                <a:solidFill>
+                  <a:schemeClr val="tx1"/>
+                </a:solidFill>
+              </a:rPr>
+              <a:t>Intake and conflicts staff. Nothing missed that an intake form would not catch.</a:t>
+            </a:r>
+            <a:endParaRPr lang="en-US" sz="1050" dirty="0"/>
+          </a:p>
+        </p:txBody>
+      </p:sp>
+      <p:sp>
+        <p:nvSpPr>
+          <p:cNvPr id="17" name="Party Finder needs"/>
+          <p:cNvSpPr txBox="1"/>
+          <p:nvPr/>
+        </p:nvSpPr>
+        <p:spPr>
+          <a:xfrm>
+            <a:off x="3429000" y="3931920"/>
+            <a:ext cx="2377440" cy="640080"/>
+          </a:xfrm>
+          <a:prstGeom prst="rect">
+            <a:avLst/>
+          </a:prstGeom>
+          <a:noFill/>
+          <a:ln/>
+        </p:spPr>
+        <p:txBody>
+          <a:bodyPr wrap="square" lIns="0" tIns="0" rIns="0" bIns="0" rtlCol="0" anchor="t"/>
+          <a:lstStyle/>
+          <a:p>
+            <a:pPr indent="0" marL="0">
+              <a:buNone/>
+            </a:pPr>
+            <a:r>
+              <a:rPr lang="en-US" sz="1050" b="1" dirty="0">
+                <a:solidFill>
+                  <a:schemeClr val="accent5"/>
+                </a:solidFill>
+              </a:rPr>
+              <a:t>To run it here: </a:t>
+            </a:r>
+            <a:pPr indent="0" marL="0">
+              <a:buNone/>
+            </a:pPr>
+            <a:r>
+              <a:rPr lang="en-US" sz="1050" dirty="0">
+                <a:solidFill>
+                  <a:schemeClr val="tx2"/>
+                </a:solidFill>
+              </a:rPr>
+              <a:t>The documents. Our conflicts system stays the system of record.</a:t>
+            </a:r>
+            <a:endParaRPr lang="en-US" sz="1050" dirty="0"/>
+          </a:p>
+        </p:txBody>
+      </p:sp>
+      <p:sp>
+        <p:nvSpPr>
+          <p:cNvPr id="18" name="Marketing Studio card"/>
           <p:cNvSpPr/>
           <p:nvPr/>
         </p:nvSpPr>
         <p:spPr>
           <a:xfrm>
-            <a:off x="457200" y="3017520"/>
-            <a:ext cx="4023360" cy="1645920"/>
+            <a:off x="6126480" y="1280160"/>
+            <a:ext cx="2651760" cy="3383280"/>
           </a:xfrm>
           <a:prstGeom prst="rect">
             <a:avLst/>
@@ -3212,13 +3180,13 @@
       </p:sp>
       <p:sp>
         <p:nvSpPr>
-          <p:cNvPr id="15" name="icon square"/>
+          <p:cNvPr id="19" name="icon square"/>
           <p:cNvSpPr/>
           <p:nvPr/>
         </p:nvSpPr>
         <p:spPr>
           <a:xfrm>
-            <a:off x="594360" y="3154680"/>
+            <a:off x="6263640" y="1417320"/>
             <a:ext cx="384048" cy="384048"/>
           </a:xfrm>
           <a:prstGeom prst="rect">
@@ -3237,7 +3205,7 @@
       </p:sp>
       <p:pic>
         <p:nvPicPr>
-          <p:cNvPr id="16" name="repeat icon" descr="preencoded.png">    </p:cNvPr>
+          <p:cNvPr id="20" name="edit icon" descr="preencoded.png">    </p:cNvPr>
           <p:cNvPicPr>
             <a:picLocks noChangeAspect="1"/>
           </p:cNvPicPr>
@@ -3251,7 +3219,7 @@
         </p:blipFill>
         <p:spPr>
           <a:xfrm>
-            <a:off x="678851" y="3239171"/>
+            <a:off x="6348131" y="1501811"/>
             <a:ext cx="215067" cy="215067"/>
           </a:xfrm>
           <a:prstGeom prst="rect">
@@ -3261,14 +3229,14 @@
       </p:pic>
       <p:sp>
         <p:nvSpPr>
-          <p:cNvPr id="17" name="Matter handoff memo name"/>
-          <p:cNvSpPr txBox="1"/>
-          <p:nvPr/>
-        </p:nvSpPr>
-        <p:spPr>
-          <a:xfrm>
-            <a:off x="1097280" y="3127248"/>
-            <a:ext cx="3246120" cy="438912"/>
+          <p:cNvPr id="21" name="Marketing Studio name"/>
+          <p:cNvSpPr txBox="1"/>
+          <p:nvPr/>
+        </p:nvSpPr>
+        <p:spPr>
+          <a:xfrm>
+            <a:off x="6766560" y="1389888"/>
+            <a:ext cx="1874520" cy="438912"/>
           </a:xfrm>
           <a:prstGeom prst="rect">
             <a:avLst/>
@@ -3289,7 +3257,7 @@
                   <a:schemeClr val="tx1"/>
                 </a:solidFill>
               </a:rPr>
-              <a:t>Matter handoff memo</a:t>
+              <a:t>Marketing Studio</a:t>
             </a:r>
             <a:endParaRPr lang="en-US" sz="1400" dirty="0"/>
           </a:p>
@@ -3297,14 +3265,14 @@
       </p:sp>
       <p:sp>
         <p:nvSpPr>
-          <p:cNvPr id="18" name="Matter handoff memo what"/>
-          <p:cNvSpPr txBox="1"/>
-          <p:nvPr/>
-        </p:nvSpPr>
-        <p:spPr>
-          <a:xfrm>
-            <a:off x="594360" y="3675888"/>
-            <a:ext cx="3749040" cy="868680"/>
+          <p:cNvPr id="22" name="Marketing Studio what"/>
+          <p:cNvSpPr txBox="1"/>
+          <p:nvPr/>
+        </p:nvSpPr>
+        <p:spPr>
+          <a:xfrm>
+            <a:off x="6263640" y="1965960"/>
+            <a:ext cx="2377440" cy="1143000"/>
           </a:xfrm>
           <a:prstGeom prst="rect">
             <a:avLst/>
@@ -3320,137 +3288,74 @@
               <a:buNone/>
             </a:pPr>
             <a:r>
-              <a:rPr lang="en-US" sz="1300" dirty="0">
+              <a:rPr lang="en-US" sz="1150" dirty="0">
                 <a:solidFill>
                   <a:schemeClr val="tx1"/>
                 </a:solidFill>
               </a:rPr>
-              <a:t>A "state of the matter" brief from the emails and documents when someone rotates off or retires.</a:t>
-            </a:r>
-            <a:endParaRPr lang="en-US" sz="1300" dirty="0"/>
-          </a:p>
-        </p:txBody>
-      </p:sp>
-      <p:sp>
-        <p:nvSpPr>
-          <p:cNvPr id="19" name="Drafting from our own precedents card"/>
-          <p:cNvSpPr/>
-          <p:nvPr/>
-        </p:nvSpPr>
-        <p:spPr>
-          <a:xfrm>
-            <a:off x="4663440" y="3017520"/>
-            <a:ext cx="4023360" cy="1645920"/>
-          </a:xfrm>
-          <a:prstGeom prst="rect">
-            <a:avLst/>
-          </a:prstGeom>
-          <a:solidFill>
-            <a:schemeClr val="bg2"/>
-          </a:solidFill>
-          <a:ln w="12700">
-            <a:solidFill>
-              <a:schemeClr val="bg2"/>
-            </a:solidFill>
-            <a:prstDash val="solid"/>
-          </a:ln>
-        </p:spPr>
-      </p:sp>
-      <p:sp>
-        <p:nvSpPr>
-          <p:cNvPr id="20" name="icon square"/>
-          <p:cNvSpPr/>
-          <p:nvPr/>
-        </p:nvSpPr>
-        <p:spPr>
-          <a:xfrm>
-            <a:off x="4800600" y="3154680"/>
-            <a:ext cx="384048" cy="384048"/>
-          </a:xfrm>
-          <a:prstGeom prst="rect">
-            <a:avLst/>
-          </a:prstGeom>
-          <a:solidFill>
-            <a:schemeClr val="accent1"/>
-          </a:solidFill>
-          <a:ln w="12700">
-            <a:solidFill>
-              <a:schemeClr val="accent1"/>
-            </a:solidFill>
-            <a:prstDash val="solid"/>
-          </a:ln>
-        </p:spPr>
-      </p:sp>
-      <p:pic>
-        <p:nvPicPr>
-          <p:cNvPr id="21" name="edit icon" descr="preencoded.png">    </p:cNvPr>
-          <p:cNvPicPr>
-            <a:picLocks noChangeAspect="1"/>
-          </p:cNvPicPr>
-          <p:nvPr/>
-        </p:nvPicPr>
-        <p:blipFill>
-          <a:blip r:embed="rId4"/>
-          <a:stretch>
-            <a:fillRect/>
-          </a:stretch>
-        </p:blipFill>
-        <p:spPr>
-          <a:xfrm>
-            <a:off x="4885091" y="3239171"/>
-            <a:ext cx="215067" cy="215067"/>
-          </a:xfrm>
-          <a:prstGeom prst="rect">
-            <a:avLst/>
-          </a:prstGeom>
-        </p:spPr>
-      </p:pic>
-      <p:sp>
-        <p:nvSpPr>
-          <p:cNvPr id="22" name="Drafting from our own precedents name"/>
-          <p:cNvSpPr txBox="1"/>
-          <p:nvPr/>
-        </p:nvSpPr>
-        <p:spPr>
-          <a:xfrm>
-            <a:off x="5303520" y="3127248"/>
-            <a:ext cx="3246120" cy="438912"/>
-          </a:xfrm>
-          <a:prstGeom prst="rect">
-            <a:avLst/>
-          </a:prstGeom>
-          <a:noFill/>
-          <a:ln/>
-        </p:spPr>
-        <p:txBody>
-          <a:bodyPr wrap="square" lIns="0" tIns="0" rIns="0" bIns="0" rtlCol="0" anchor="ctr"/>
-          <a:lstStyle/>
-          <a:p>
-            <a:pPr indent="0" marL="0">
-              <a:buNone/>
-            </a:pPr>
-            <a:r>
-              <a:rPr lang="en-US" sz="1400" b="1" dirty="0">
+              <a:t>Drafts attorney bios, client alerts, RFP responses and award submissions in the firm's voice, then checks each draft against its source and the advertising rules.</a:t>
+            </a:r>
+            <a:endParaRPr lang="en-US" sz="1150" dirty="0"/>
+          </a:p>
+        </p:txBody>
+      </p:sp>
+      <p:sp>
+        <p:nvSpPr>
+          <p:cNvPr id="23" name="Marketing Studio helps"/>
+          <p:cNvSpPr txBox="1"/>
+          <p:nvPr/>
+        </p:nvSpPr>
+        <p:spPr>
+          <a:xfrm>
+            <a:off x="6263640" y="3154680"/>
+            <a:ext cx="2377440" cy="731520"/>
+          </a:xfrm>
+          <a:prstGeom prst="rect">
+            <a:avLst/>
+          </a:prstGeom>
+          <a:noFill/>
+          <a:ln/>
+        </p:spPr>
+        <p:txBody>
+          <a:bodyPr wrap="square" lIns="0" tIns="0" rIns="0" bIns="0" rtlCol="0" anchor="t"/>
+          <a:lstStyle/>
+          <a:p>
+            <a:pPr indent="0" marL="0">
+              <a:buNone/>
+            </a:pPr>
+            <a:r>
+              <a:rPr lang="en-US" sz="1050" b="1" dirty="0">
+                <a:solidFill>
+                  <a:schemeClr val="accent5"/>
+                </a:solidFill>
+              </a:rPr>
+              <a:t>Helps: </a:t>
+            </a:r>
+            <a:pPr indent="0" marL="0">
+              <a:buNone/>
+            </a:pPr>
+            <a:r>
+              <a:rPr lang="en-US" sz="1050" dirty="0">
                 <a:solidFill>
                   <a:schemeClr val="tx1"/>
                 </a:solidFill>
               </a:rPr>
-              <a:t>Drafting from our own precedents</a:t>
-            </a:r>
-            <a:endParaRPr lang="en-US" sz="1400" dirty="0"/>
-          </a:p>
-        </p:txBody>
-      </p:sp>
-      <p:sp>
-        <p:nvSpPr>
-          <p:cNvPr id="23" name="Drafting from our own precedents what"/>
-          <p:cNvSpPr txBox="1"/>
-          <p:nvPr/>
-        </p:nvSpPr>
-        <p:spPr>
-          <a:xfrm>
-            <a:off x="4800600" y="3675888"/>
-            <a:ext cx="3749040" cy="868680"/>
+              <a:t>Marketing and the attorneys they chase for drafts. First drafts in minutes, nothing invented.</a:t>
+            </a:r>
+            <a:endParaRPr lang="en-US" sz="1050" dirty="0"/>
+          </a:p>
+        </p:txBody>
+      </p:sp>
+      <p:sp>
+        <p:nvSpPr>
+          <p:cNvPr id="24" name="Marketing Studio needs"/>
+          <p:cNvSpPr txBox="1"/>
+          <p:nvPr/>
+        </p:nvSpPr>
+        <p:spPr>
+          <a:xfrm>
+            <a:off x="6263640" y="3931920"/>
+            <a:ext cx="2377440" cy="640080"/>
           </a:xfrm>
           <a:prstGeom prst="rect">
             <a:avLst/>
@@ -3466,14 +3371,25 @@
               <a:buNone/>
             </a:pPr>
             <a:r>
-              <a:rPr lang="en-US" sz="1300" dirty="0">
-                <a:solidFill>
-                  <a:schemeClr val="tx1"/>
-                </a:solidFill>
-              </a:rPr>
-              <a:t>First drafts from the firm's best past documents, inside Copilot and the document system.</a:t>
-            </a:r>
-            <a:endParaRPr lang="en-US" sz="1300" dirty="0"/>
+              <a:rPr lang="en-US" sz="1050" b="1" dirty="0">
+                <a:solidFill>
+                  <a:schemeClr val="accent5"/>
+                </a:solidFill>
+              </a:rPr>
+              <a:t>To run it here: </a:t>
+            </a:r>
+            <a:pPr indent="0" marL="0">
+              <a:buNone/>
+            </a:pPr>
+            <a:r>
+              <a:rPr lang="en-US" sz="1050" dirty="0">
+                <a:solidFill>
+                  <a:schemeClr val="tx2"/>
+                </a:solidFill>
+              </a:rPr>
+              <a:t>The source material and the firm's style examples.</a:t>
+            </a:r>
+            <a:endParaRPr lang="en-US" sz="1050" dirty="0"/>
           </a:p>
         </p:txBody>
       </p:sp>
@@ -3617,7 +3533,7 @@
                   <a:schemeClr val="tx2"/>
                 </a:solidFill>
               </a:rPr>
-              <a:t>Directions I find promising. They would need IT and leadership to shape them.</a:t>
+              <a:t>Directions I find promising. They would need leadership to shape them, and IT to vet them.</a:t>
             </a:r>
             <a:endParaRPr lang="en-US" sz="1300" dirty="0"/>
           </a:p>
@@ -3810,7 +3726,7 @@
                   <a:schemeClr val="tx1"/>
                 </a:solidFill>
               </a:rPr>
-              <a:t>We call the client before they know they need help.</a:t>
+              <a:t>We call the client before they know they need help. VigilMark already does this for trademarks.</a:t>
             </a:r>
             <a:endParaRPr lang="en-US" sz="1200" dirty="0"/>
           </a:p>
@@ -4003,7 +3919,7 @@
                   <a:schemeClr val="tx1"/>
                 </a:solidFill>
               </a:rPr>
-              <a:t>Keeps expertise when senior partners retire.</a:t>
+              <a:t>Keeps expertise when senior partners retire. LexAtlas and Skippy are the pieces.</a:t>
             </a:r>
             <a:endParaRPr lang="en-US" sz="1200" dirty="0"/>
           </a:p>
@@ -4196,7 +4112,7 @@
                   <a:schemeClr val="tx1"/>
                 </a:solidFill>
               </a:rPr>
-              <a:t>A contained first step toward the knowledge engine.</a:t>
+              <a:t>A contained first step toward the knowledge engine. Skippy does this today, one matter at a time.</a:t>
             </a:r>
             <a:endParaRPr lang="en-US" sz="1200" dirty="0"/>
           </a:p>
@@ -5402,7 +5318,7 @@
                   <a:schemeClr val="bg1"/>
                 </a:solidFill>
               </a:rPr>
-              <a:t>All of it inside IT's rules. </a:t>
+              <a:t>Every one of these goes through IT review first: </a:t>
             </a:r>
             <a:pPr indent="0" marL="0">
               <a:buNone/>
@@ -5413,7 +5329,7 @@
                   <a:schemeClr val="bg1"/>
                 </a:solidFill>
               </a:rPr>
-              <a:t>Infrastructure, security, vendors and what goes live are IT's call.</a:t>
+              <a:t>where it runs, who can see what, and what is logged.</a:t>
             </a:r>
             <a:endParaRPr lang="en-US" sz="1050" dirty="0"/>
           </a:p>

</xml_diff>